<commit_message>
Initial commit: KPI Navigator project
Co-authored-by: Cursor <cursoragent@cursor.com>
</commit_message>
<xml_diff>
--- a/image/機能詳細/KPI Navigater.pptx
+++ b/image/機能詳細/KPI Navigater.pptx
@@ -5,8 +5,11 @@
     <p:sldMasterId id="2147483660" r:id="rId1"/>
   </p:sldMasterIdLst>
   <p:sldIdLst>
-    <p:sldId id="256" r:id="rId2"/>
-    <p:sldId id="257" r:id="rId3"/>
+    <p:sldId id="260" r:id="rId2"/>
+    <p:sldId id="258" r:id="rId3"/>
+    <p:sldId id="256" r:id="rId4"/>
+    <p:sldId id="257" r:id="rId5"/>
+    <p:sldId id="259" r:id="rId6"/>
   </p:sldIdLst>
   <p:sldSz cx="6858000" cy="12192000"/>
   <p:notesSz cx="6858000" cy="9144000"/>
@@ -255,7 +258,7 @@
           <a:p>
             <a:fld id="{741D5141-573D-7F4B-A753-13E094770F8C}" type="datetimeFigureOut">
               <a:rPr kumimoji="1" lang="ja-JP" altLang="en-US" smtClean="0"/>
-              <a:t>2025/5/31</a:t>
+              <a:t>2025/6/18</a:t>
             </a:fld>
             <a:endParaRPr kumimoji="1" lang="ja-JP" altLang="en-US"/>
           </a:p>
@@ -457,7 +460,7 @@
           <a:p>
             <a:fld id="{741D5141-573D-7F4B-A753-13E094770F8C}" type="datetimeFigureOut">
               <a:rPr kumimoji="1" lang="ja-JP" altLang="en-US" smtClean="0"/>
-              <a:t>2025/5/31</a:t>
+              <a:t>2025/6/18</a:t>
             </a:fld>
             <a:endParaRPr kumimoji="1" lang="ja-JP" altLang="en-US"/>
           </a:p>
@@ -669,7 +672,7 @@
           <a:p>
             <a:fld id="{741D5141-573D-7F4B-A753-13E094770F8C}" type="datetimeFigureOut">
               <a:rPr kumimoji="1" lang="ja-JP" altLang="en-US" smtClean="0"/>
-              <a:t>2025/5/31</a:t>
+              <a:t>2025/6/18</a:t>
             </a:fld>
             <a:endParaRPr kumimoji="1" lang="ja-JP" altLang="en-US"/>
           </a:p>
@@ -871,7 +874,7 @@
           <a:p>
             <a:fld id="{741D5141-573D-7F4B-A753-13E094770F8C}" type="datetimeFigureOut">
               <a:rPr kumimoji="1" lang="ja-JP" altLang="en-US" smtClean="0"/>
-              <a:t>2025/5/31</a:t>
+              <a:t>2025/6/18</a:t>
             </a:fld>
             <a:endParaRPr kumimoji="1" lang="ja-JP" altLang="en-US"/>
           </a:p>
@@ -1117,7 +1120,7 @@
           <a:p>
             <a:fld id="{741D5141-573D-7F4B-A753-13E094770F8C}" type="datetimeFigureOut">
               <a:rPr kumimoji="1" lang="ja-JP" altLang="en-US" smtClean="0"/>
-              <a:t>2025/5/31</a:t>
+              <a:t>2025/6/18</a:t>
             </a:fld>
             <a:endParaRPr kumimoji="1" lang="ja-JP" altLang="en-US"/>
           </a:p>
@@ -1413,7 +1416,7 @@
           <a:p>
             <a:fld id="{741D5141-573D-7F4B-A753-13E094770F8C}" type="datetimeFigureOut">
               <a:rPr kumimoji="1" lang="ja-JP" altLang="en-US" smtClean="0"/>
-              <a:t>2025/5/31</a:t>
+              <a:t>2025/6/18</a:t>
             </a:fld>
             <a:endParaRPr kumimoji="1" lang="ja-JP" altLang="en-US"/>
           </a:p>
@@ -1844,7 +1847,7 @@
           <a:p>
             <a:fld id="{741D5141-573D-7F4B-A753-13E094770F8C}" type="datetimeFigureOut">
               <a:rPr kumimoji="1" lang="ja-JP" altLang="en-US" smtClean="0"/>
-              <a:t>2025/5/31</a:t>
+              <a:t>2025/6/18</a:t>
             </a:fld>
             <a:endParaRPr kumimoji="1" lang="ja-JP" altLang="en-US"/>
           </a:p>
@@ -1962,7 +1965,7 @@
           <a:p>
             <a:fld id="{741D5141-573D-7F4B-A753-13E094770F8C}" type="datetimeFigureOut">
               <a:rPr kumimoji="1" lang="ja-JP" altLang="en-US" smtClean="0"/>
-              <a:t>2025/5/31</a:t>
+              <a:t>2025/6/18</a:t>
             </a:fld>
             <a:endParaRPr kumimoji="1" lang="ja-JP" altLang="en-US"/>
           </a:p>
@@ -2057,7 +2060,7 @@
           <a:p>
             <a:fld id="{741D5141-573D-7F4B-A753-13E094770F8C}" type="datetimeFigureOut">
               <a:rPr kumimoji="1" lang="ja-JP" altLang="en-US" smtClean="0"/>
-              <a:t>2025/5/31</a:t>
+              <a:t>2025/6/18</a:t>
             </a:fld>
             <a:endParaRPr kumimoji="1" lang="ja-JP" altLang="en-US"/>
           </a:p>
@@ -2366,7 +2369,7 @@
           <a:p>
             <a:fld id="{741D5141-573D-7F4B-A753-13E094770F8C}" type="datetimeFigureOut">
               <a:rPr kumimoji="1" lang="ja-JP" altLang="en-US" smtClean="0"/>
-              <a:t>2025/5/31</a:t>
+              <a:t>2025/6/18</a:t>
             </a:fld>
             <a:endParaRPr kumimoji="1" lang="ja-JP" altLang="en-US"/>
           </a:p>
@@ -2623,7 +2626,7 @@
           <a:p>
             <a:fld id="{741D5141-573D-7F4B-A753-13E094770F8C}" type="datetimeFigureOut">
               <a:rPr kumimoji="1" lang="ja-JP" altLang="en-US" smtClean="0"/>
-              <a:t>2025/5/31</a:t>
+              <a:t>2025/6/18</a:t>
             </a:fld>
             <a:endParaRPr kumimoji="1" lang="ja-JP" altLang="en-US"/>
           </a:p>
@@ -2868,7 +2871,7 @@
           <a:p>
             <a:fld id="{741D5141-573D-7F4B-A753-13E094770F8C}" type="datetimeFigureOut">
               <a:rPr kumimoji="1" lang="ja-JP" altLang="en-US" smtClean="0"/>
-              <a:t>2025/5/31</a:t>
+              <a:t>2025/6/18</a:t>
             </a:fld>
             <a:endParaRPr kumimoji="1" lang="ja-JP" altLang="en-US"/>
           </a:p>
@@ -3278,7 +3281,7 @@
           <p:cNvPr id="4" name="テキスト ボックス 3">
             <a:extLst>
               <a:ext uri="{FF2B5EF4-FFF2-40B4-BE49-F238E27FC236}">
-                <a16:creationId xmlns:a16="http://schemas.microsoft.com/office/drawing/2014/main" id="{AE99DE16-AD02-4A09-A39B-B73330EFA7CD}"/>
+                <a16:creationId xmlns:a16="http://schemas.microsoft.com/office/drawing/2014/main" id="{0A0CD8FD-B23B-9DE3-6FEA-1C04F36AE85B}"/>
               </a:ext>
             </a:extLst>
           </p:cNvPr>
@@ -3313,7 +3316,2755 @@
                 <a:latin typeface="Meiryo" panose="020B0604030504040204" pitchFamily="34" charset="-128"/>
                 <a:ea typeface="Meiryo" panose="020B0604030504040204" pitchFamily="34" charset="-128"/>
               </a:rPr>
+              <a:t>初期設定</a:t>
+            </a:r>
+          </a:p>
+        </p:txBody>
+      </p:sp>
+      <p:sp>
+        <p:nvSpPr>
+          <p:cNvPr id="5" name="テキスト ボックス 4">
+            <a:extLst>
+              <a:ext uri="{FF2B5EF4-FFF2-40B4-BE49-F238E27FC236}">
+                <a16:creationId xmlns:a16="http://schemas.microsoft.com/office/drawing/2014/main" id="{16682CF4-30EB-1F4A-FA22-DD8797376A9A}"/>
+              </a:ext>
+            </a:extLst>
+          </p:cNvPr>
+          <p:cNvSpPr txBox="1"/>
+          <p:nvPr/>
+        </p:nvSpPr>
+        <p:spPr>
+          <a:xfrm>
+            <a:off x="583198" y="834644"/>
+            <a:ext cx="5709185" cy="2554545"/>
+          </a:xfrm>
+          <a:prstGeom prst="rect">
+            <a:avLst/>
+          </a:prstGeom>
+          <a:noFill/>
+        </p:spPr>
+        <p:txBody>
+          <a:bodyPr wrap="square" rtlCol="0">
+            <a:spAutoFit/>
+          </a:bodyPr>
+          <a:lstStyle/>
+          <a:p>
+            <a:r>
+              <a:rPr lang="en-US" altLang="ja-JP" sz="1000" dirty="0">
+                <a:latin typeface="Meiryo" panose="020B0604030504040204" pitchFamily="34" charset="-128"/>
+                <a:ea typeface="Meiryo" panose="020B0604030504040204" pitchFamily="34" charset="-128"/>
+              </a:rPr>
+              <a:t>【</a:t>
+            </a:r>
+            <a:r>
+              <a:rPr lang="ja-JP" altLang="en-US" sz="1000">
+                <a:latin typeface="Meiryo" panose="020B0604030504040204" pitchFamily="34" charset="-128"/>
+                <a:ea typeface="Meiryo" panose="020B0604030504040204" pitchFamily="34" charset="-128"/>
+              </a:rPr>
+              <a:t>ユーザー</a:t>
+            </a:r>
+            <a:r>
+              <a:rPr lang="en-US" altLang="ja-JP" sz="1000" dirty="0">
+                <a:latin typeface="Meiryo" panose="020B0604030504040204" pitchFamily="34" charset="-128"/>
+                <a:ea typeface="Meiryo" panose="020B0604030504040204" pitchFamily="34" charset="-128"/>
+              </a:rPr>
+              <a:t>】</a:t>
+            </a:r>
+          </a:p>
+          <a:p>
+            <a:pPr marL="228600" indent="-228600">
+              <a:buAutoNum type="arabicPeriod"/>
+            </a:pPr>
+            <a:r>
+              <a:rPr lang="ja-JP" altLang="en-US" sz="1000">
+                <a:latin typeface="Meiryo" panose="020B0604030504040204" pitchFamily="34" charset="-128"/>
+                <a:ea typeface="Meiryo" panose="020B0604030504040204" pitchFamily="34" charset="-128"/>
+              </a:rPr>
+              <a:t>前年もしくはそれ以前の年の総営業日の設定</a:t>
+            </a:r>
+            <a:r>
+              <a:rPr lang="en-US" altLang="ja-JP" sz="1000" dirty="0">
+                <a:latin typeface="Meiryo" panose="020B0604030504040204" pitchFamily="34" charset="-128"/>
+                <a:ea typeface="Meiryo" panose="020B0604030504040204" pitchFamily="34" charset="-128"/>
+              </a:rPr>
+              <a:t>(</a:t>
+            </a:r>
+            <a:r>
+              <a:rPr lang="ja-JP" altLang="en-US" sz="1000">
+                <a:latin typeface="Meiryo" panose="020B0604030504040204" pitchFamily="34" charset="-128"/>
+                <a:ea typeface="Meiryo" panose="020B0604030504040204" pitchFamily="34" charset="-128"/>
+              </a:rPr>
+              <a:t>後でいつでも変更可能＊誤入力修正など</a:t>
+            </a:r>
+            <a:r>
+              <a:rPr lang="en-US" altLang="ja-JP" sz="1000" dirty="0">
+                <a:latin typeface="Meiryo" panose="020B0604030504040204" pitchFamily="34" charset="-128"/>
+                <a:ea typeface="Meiryo" panose="020B0604030504040204" pitchFamily="34" charset="-128"/>
+              </a:rPr>
+              <a:t>)</a:t>
+            </a:r>
+            <a:r>
+              <a:rPr lang="ja-JP" altLang="en-US" sz="1000">
+                <a:latin typeface="Meiryo" panose="020B0604030504040204" pitchFamily="34" charset="-128"/>
+                <a:ea typeface="Meiryo" panose="020B0604030504040204" pitchFamily="34" charset="-128"/>
+              </a:rPr>
+              <a:t>＊複数年入力可能→精度が上がる</a:t>
+            </a:r>
+            <a:r>
+              <a:rPr lang="en-US" altLang="ja-JP" sz="1000" dirty="0">
+                <a:latin typeface="Meiryo" panose="020B0604030504040204" pitchFamily="34" charset="-128"/>
+                <a:ea typeface="Meiryo" panose="020B0604030504040204" pitchFamily="34" charset="-128"/>
+              </a:rPr>
+              <a:t>(</a:t>
+            </a:r>
+            <a:r>
+              <a:rPr lang="ja-JP" altLang="en-US" sz="1000">
+                <a:latin typeface="Meiryo" panose="020B0604030504040204" pitchFamily="34" charset="-128"/>
+                <a:ea typeface="Meiryo" panose="020B0604030504040204" pitchFamily="34" charset="-128"/>
+              </a:rPr>
+              <a:t>コロナ禍でなければ</a:t>
+            </a:r>
+            <a:r>
+              <a:rPr lang="en-US" altLang="ja-JP" sz="1000" dirty="0">
+                <a:latin typeface="Meiryo" panose="020B0604030504040204" pitchFamily="34" charset="-128"/>
+                <a:ea typeface="Meiryo" panose="020B0604030504040204" pitchFamily="34" charset="-128"/>
+              </a:rPr>
+              <a:t>)</a:t>
+            </a:r>
+          </a:p>
+          <a:p>
+            <a:pPr marL="228600" indent="-228600">
+              <a:buAutoNum type="arabicPeriod"/>
+            </a:pPr>
+            <a:r>
+              <a:rPr lang="ja-JP" altLang="en-US" sz="1000">
+                <a:latin typeface="Meiryo" panose="020B0604030504040204" pitchFamily="34" charset="-128"/>
+                <a:ea typeface="Meiryo" panose="020B0604030504040204" pitchFamily="34" charset="-128"/>
+              </a:rPr>
+              <a:t>前年もしくはそれ以前の年の日次売上額</a:t>
+            </a:r>
+            <a:r>
+              <a:rPr lang="en-US" altLang="ja-JP" sz="1000" dirty="0">
+                <a:latin typeface="Meiryo" panose="020B0604030504040204" pitchFamily="34" charset="-128"/>
+                <a:ea typeface="Meiryo" panose="020B0604030504040204" pitchFamily="34" charset="-128"/>
+              </a:rPr>
+              <a:t>(</a:t>
+            </a:r>
+            <a:r>
+              <a:rPr lang="ja-JP" altLang="en-US" sz="1000">
+                <a:latin typeface="Meiryo" panose="020B0604030504040204" pitchFamily="34" charset="-128"/>
+                <a:ea typeface="Meiryo" panose="020B0604030504040204" pitchFamily="34" charset="-128"/>
+              </a:rPr>
+              <a:t>後でいつでも変更可能＊誤入力修正など</a:t>
+            </a:r>
+            <a:r>
+              <a:rPr lang="en-US" altLang="ja-JP" sz="1000" dirty="0">
+                <a:latin typeface="Meiryo" panose="020B0604030504040204" pitchFamily="34" charset="-128"/>
+                <a:ea typeface="Meiryo" panose="020B0604030504040204" pitchFamily="34" charset="-128"/>
+              </a:rPr>
+              <a:t>)</a:t>
+            </a:r>
+          </a:p>
+          <a:p>
+            <a:r>
+              <a:rPr lang="ja-JP" altLang="en-US" sz="1000">
+                <a:latin typeface="Meiryo" panose="020B0604030504040204" pitchFamily="34" charset="-128"/>
+                <a:ea typeface="Meiryo" panose="020B0604030504040204" pitchFamily="34" charset="-128"/>
+              </a:rPr>
+              <a:t>＊</a:t>
+            </a:r>
+            <a:r>
+              <a:rPr lang="en-US" altLang="ja-JP" sz="1000" dirty="0">
+                <a:latin typeface="Meiryo" panose="020B0604030504040204" pitchFamily="34" charset="-128"/>
+                <a:ea typeface="Meiryo" panose="020B0604030504040204" pitchFamily="34" charset="-128"/>
+              </a:rPr>
+              <a:t>CSV</a:t>
+            </a:r>
+            <a:r>
+              <a:rPr lang="ja-JP" altLang="en-US" sz="1000">
+                <a:latin typeface="Meiryo" panose="020B0604030504040204" pitchFamily="34" charset="-128"/>
+                <a:ea typeface="Meiryo" panose="020B0604030504040204" pitchFamily="34" charset="-128"/>
+              </a:rPr>
+              <a:t>をアップロードして自動で反映もしたい。その場合の</a:t>
+            </a:r>
+            <a:r>
+              <a:rPr lang="en-US" altLang="ja-JP" sz="1000" dirty="0">
+                <a:latin typeface="Meiryo" panose="020B0604030504040204" pitchFamily="34" charset="-128"/>
+                <a:ea typeface="Meiryo" panose="020B0604030504040204" pitchFamily="34" charset="-128"/>
+              </a:rPr>
+              <a:t>CSV</a:t>
+            </a:r>
+            <a:r>
+              <a:rPr lang="ja-JP" altLang="en-US" sz="1000">
+                <a:latin typeface="Meiryo" panose="020B0604030504040204" pitchFamily="34" charset="-128"/>
+                <a:ea typeface="Meiryo" panose="020B0604030504040204" pitchFamily="34" charset="-128"/>
+              </a:rPr>
+              <a:t>のタイトルなどはユーザーにより差異があるのでそのパターンを見極められるロジックが欲しい。</a:t>
+            </a:r>
+            <a:endParaRPr lang="en-US" altLang="ja-JP" sz="1000" dirty="0">
+              <a:latin typeface="Meiryo" panose="020B0604030504040204" pitchFamily="34" charset="-128"/>
+              <a:ea typeface="Meiryo" panose="020B0604030504040204" pitchFamily="34" charset="-128"/>
+            </a:endParaRPr>
+          </a:p>
+          <a:p>
+            <a:r>
+              <a:rPr lang="en-US" altLang="ja-JP" sz="1000" dirty="0">
+                <a:latin typeface="Meiryo" panose="020B0604030504040204" pitchFamily="34" charset="-128"/>
+                <a:ea typeface="Meiryo" panose="020B0604030504040204" pitchFamily="34" charset="-128"/>
+              </a:rPr>
+              <a:t>3.</a:t>
+            </a:r>
+            <a:r>
+              <a:rPr lang="ja-JP" altLang="en-US" sz="1000">
+                <a:latin typeface="Meiryo" panose="020B0604030504040204" pitchFamily="34" charset="-128"/>
+                <a:ea typeface="Meiryo" panose="020B0604030504040204" pitchFamily="34" charset="-128"/>
+              </a:rPr>
+              <a:t>　入力希望があれば、その年の収支</a:t>
+            </a:r>
+            <a:r>
+              <a:rPr lang="en-US" altLang="ja-JP" sz="1000" dirty="0">
+                <a:latin typeface="Meiryo" panose="020B0604030504040204" pitchFamily="34" charset="-128"/>
+                <a:ea typeface="Meiryo" panose="020B0604030504040204" pitchFamily="34" charset="-128"/>
+              </a:rPr>
+              <a:t>(PL)</a:t>
+            </a:r>
+            <a:r>
+              <a:rPr lang="ja-JP" altLang="en-US" sz="1000">
+                <a:latin typeface="Meiryo" panose="020B0604030504040204" pitchFamily="34" charset="-128"/>
+                <a:ea typeface="Meiryo" panose="020B0604030504040204" pitchFamily="34" charset="-128"/>
+              </a:rPr>
+              <a:t>の入力も可能→経営健康指数の表記</a:t>
+            </a:r>
+            <a:r>
+              <a:rPr lang="en-US" altLang="ja-JP" sz="1000" dirty="0">
+                <a:latin typeface="Meiryo" panose="020B0604030504040204" pitchFamily="34" charset="-128"/>
+                <a:ea typeface="Meiryo" panose="020B0604030504040204" pitchFamily="34" charset="-128"/>
+              </a:rPr>
+              <a:t>(</a:t>
+            </a:r>
+            <a:r>
+              <a:rPr lang="ja-JP" altLang="en-US" sz="1000">
+                <a:latin typeface="Meiryo" panose="020B0604030504040204" pitchFamily="34" charset="-128"/>
+                <a:ea typeface="Meiryo" panose="020B0604030504040204" pitchFamily="34" charset="-128"/>
+              </a:rPr>
+              <a:t>グラフ化など</a:t>
+            </a:r>
+            <a:r>
+              <a:rPr lang="en-US" altLang="ja-JP" sz="1000" dirty="0">
+                <a:latin typeface="Meiryo" panose="020B0604030504040204" pitchFamily="34" charset="-128"/>
+                <a:ea typeface="Meiryo" panose="020B0604030504040204" pitchFamily="34" charset="-128"/>
+              </a:rPr>
+              <a:t>)</a:t>
+            </a:r>
+          </a:p>
+          <a:p>
+            <a:endParaRPr lang="en-US" altLang="ja-JP" sz="1000" dirty="0">
+              <a:latin typeface="Meiryo" panose="020B0604030504040204" pitchFamily="34" charset="-128"/>
+              <a:ea typeface="Meiryo" panose="020B0604030504040204" pitchFamily="34" charset="-128"/>
+            </a:endParaRPr>
+          </a:p>
+          <a:p>
+            <a:r>
+              <a:rPr lang="en-US" altLang="ja-JP" sz="1000" dirty="0">
+                <a:latin typeface="Meiryo" panose="020B0604030504040204" pitchFamily="34" charset="-128"/>
+                <a:ea typeface="Meiryo" panose="020B0604030504040204" pitchFamily="34" charset="-128"/>
+              </a:rPr>
+              <a:t>【</a:t>
+            </a:r>
+            <a:r>
+              <a:rPr lang="ja-JP" altLang="en-US" sz="1000">
+                <a:latin typeface="Meiryo" panose="020B0604030504040204" pitchFamily="34" charset="-128"/>
+                <a:ea typeface="Meiryo" panose="020B0604030504040204" pitchFamily="34" charset="-128"/>
+              </a:rPr>
+              <a:t>ユーザー入力後に</a:t>
+            </a:r>
+            <a:r>
+              <a:rPr lang="en-US" altLang="ja-JP" sz="1000" dirty="0">
+                <a:latin typeface="Meiryo" panose="020B0604030504040204" pitchFamily="34" charset="-128"/>
+                <a:ea typeface="Meiryo" panose="020B0604030504040204" pitchFamily="34" charset="-128"/>
+              </a:rPr>
+              <a:t>Web</a:t>
+            </a:r>
+            <a:r>
+              <a:rPr lang="ja-JP" altLang="en-US" sz="1000">
+                <a:latin typeface="Meiryo" panose="020B0604030504040204" pitchFamily="34" charset="-128"/>
+                <a:ea typeface="Meiryo" panose="020B0604030504040204" pitchFamily="34" charset="-128"/>
+              </a:rPr>
+              <a:t>アプリがすること</a:t>
+            </a:r>
+            <a:r>
+              <a:rPr lang="en-US" altLang="ja-JP" sz="1000" dirty="0">
+                <a:latin typeface="Meiryo" panose="020B0604030504040204" pitchFamily="34" charset="-128"/>
+                <a:ea typeface="Meiryo" panose="020B0604030504040204" pitchFamily="34" charset="-128"/>
+              </a:rPr>
+              <a:t>】</a:t>
+            </a:r>
+          </a:p>
+          <a:p>
+            <a:r>
+              <a:rPr lang="en-US" altLang="ja-JP" sz="1000" dirty="0">
+                <a:latin typeface="Meiryo" panose="020B0604030504040204" pitchFamily="34" charset="-128"/>
+                <a:ea typeface="Meiryo" panose="020B0604030504040204" pitchFamily="34" charset="-128"/>
+              </a:rPr>
+              <a:t>	1. </a:t>
+            </a:r>
+            <a:r>
+              <a:rPr lang="ja-JP" altLang="en-US" sz="1000">
+                <a:latin typeface="Meiryo" panose="020B0604030504040204" pitchFamily="34" charset="-128"/>
+                <a:ea typeface="Meiryo" panose="020B0604030504040204" pitchFamily="34" charset="-128"/>
+              </a:rPr>
+              <a:t>年間総売上額を年間総営業日で割る</a:t>
+            </a:r>
+            <a:endParaRPr lang="en-US" altLang="ja-JP" sz="1000" dirty="0">
+              <a:latin typeface="Meiryo" panose="020B0604030504040204" pitchFamily="34" charset="-128"/>
+              <a:ea typeface="Meiryo" panose="020B0604030504040204" pitchFamily="34" charset="-128"/>
+            </a:endParaRPr>
+          </a:p>
+          <a:p>
+            <a:r>
+              <a:rPr lang="en-US" altLang="ja-JP" sz="1000" dirty="0">
+                <a:latin typeface="Meiryo" panose="020B0604030504040204" pitchFamily="34" charset="-128"/>
+                <a:ea typeface="Meiryo" panose="020B0604030504040204" pitchFamily="34" charset="-128"/>
+              </a:rPr>
+              <a:t>	2. </a:t>
+            </a:r>
+            <a:r>
+              <a:rPr lang="ja-JP" altLang="en-US" sz="1000">
+                <a:latin typeface="Meiryo" panose="020B0604030504040204" pitchFamily="34" charset="-128"/>
+                <a:ea typeface="Meiryo" panose="020B0604030504040204" pitchFamily="34" charset="-128"/>
+              </a:rPr>
+              <a:t>日次の平均売上額を算出</a:t>
+            </a:r>
+            <a:r>
+              <a:rPr lang="en-US" altLang="ja-JP" sz="1000" dirty="0">
+                <a:latin typeface="Meiryo" panose="020B0604030504040204" pitchFamily="34" charset="-128"/>
+                <a:ea typeface="Meiryo" panose="020B0604030504040204" pitchFamily="34" charset="-128"/>
+              </a:rPr>
+              <a:t>(</a:t>
+            </a:r>
+            <a:r>
+              <a:rPr lang="ja-JP" altLang="en-US" sz="1000">
+                <a:latin typeface="Meiryo" panose="020B0604030504040204" pitchFamily="34" charset="-128"/>
+                <a:ea typeface="Meiryo" panose="020B0604030504040204" pitchFamily="34" charset="-128"/>
+              </a:rPr>
+              <a:t>繁閑期を割り出すための基軸となる数値</a:t>
+            </a:r>
+            <a:r>
+              <a:rPr lang="en-US" altLang="ja-JP" sz="1000" dirty="0">
+                <a:latin typeface="Meiryo" panose="020B0604030504040204" pitchFamily="34" charset="-128"/>
+                <a:ea typeface="Meiryo" panose="020B0604030504040204" pitchFamily="34" charset="-128"/>
+              </a:rPr>
+              <a:t>)</a:t>
+            </a:r>
+          </a:p>
+          <a:p>
+            <a:r>
+              <a:rPr lang="en-US" altLang="ja-JP" sz="1000" dirty="0">
+                <a:latin typeface="Meiryo" panose="020B0604030504040204" pitchFamily="34" charset="-128"/>
+                <a:ea typeface="Meiryo" panose="020B0604030504040204" pitchFamily="34" charset="-128"/>
+              </a:rPr>
+              <a:t>	3. </a:t>
+            </a:r>
+            <a:r>
+              <a:rPr lang="ja-JP" altLang="en-US" sz="1000">
+                <a:latin typeface="Meiryo" panose="020B0604030504040204" pitchFamily="34" charset="-128"/>
+                <a:ea typeface="Meiryo" panose="020B0604030504040204" pitchFamily="34" charset="-128"/>
+              </a:rPr>
+              <a:t>日次売上</a:t>
+            </a:r>
+            <a:r>
+              <a:rPr lang="en-US" altLang="ja-JP" sz="1000" dirty="0">
+                <a:latin typeface="Meiryo" panose="020B0604030504040204" pitchFamily="34" charset="-128"/>
+                <a:ea typeface="Meiryo" panose="020B0604030504040204" pitchFamily="34" charset="-128"/>
+              </a:rPr>
+              <a:t>×</a:t>
+            </a:r>
+            <a:r>
+              <a:rPr lang="ja-JP" altLang="en-US" sz="1000">
+                <a:latin typeface="Meiryo" panose="020B0604030504040204" pitchFamily="34" charset="-128"/>
+                <a:ea typeface="Meiryo" panose="020B0604030504040204" pitchFamily="34" charset="-128"/>
+              </a:rPr>
+              <a:t>月次営業日</a:t>
+            </a:r>
+            <a:r>
+              <a:rPr lang="en-US" altLang="ja-JP" sz="1000" dirty="0">
+                <a:latin typeface="Meiryo" panose="020B0604030504040204" pitchFamily="34" charset="-128"/>
+                <a:ea typeface="Meiryo" panose="020B0604030504040204" pitchFamily="34" charset="-128"/>
+              </a:rPr>
+              <a:t>=</a:t>
+            </a:r>
+            <a:r>
+              <a:rPr lang="ja-JP" altLang="en-US" sz="1000">
+                <a:latin typeface="Meiryo" panose="020B0604030504040204" pitchFamily="34" charset="-128"/>
+                <a:ea typeface="Meiryo" panose="020B0604030504040204" pitchFamily="34" charset="-128"/>
+              </a:rPr>
+              <a:t>平均月次売上額算出</a:t>
+            </a:r>
+            <a:endParaRPr lang="en-US" altLang="ja-JP" sz="1000" dirty="0">
+              <a:latin typeface="Meiryo" panose="020B0604030504040204" pitchFamily="34" charset="-128"/>
+              <a:ea typeface="Meiryo" panose="020B0604030504040204" pitchFamily="34" charset="-128"/>
+            </a:endParaRPr>
+          </a:p>
+          <a:p>
+            <a:r>
+              <a:rPr lang="en-US" altLang="ja-JP" sz="1000" dirty="0">
+                <a:latin typeface="Meiryo" panose="020B0604030504040204" pitchFamily="34" charset="-128"/>
+                <a:ea typeface="Meiryo" panose="020B0604030504040204" pitchFamily="34" charset="-128"/>
+              </a:rPr>
+              <a:t>	4. </a:t>
+            </a:r>
+            <a:r>
+              <a:rPr lang="ja-JP" altLang="en-US" sz="1000">
+                <a:latin typeface="Meiryo" panose="020B0604030504040204" pitchFamily="34" charset="-128"/>
+                <a:ea typeface="Meiryo" panose="020B0604030504040204" pitchFamily="34" charset="-128"/>
+              </a:rPr>
+              <a:t>実際の月次の売上との差額からそのお店の繁閑期パーセンテージ算出</a:t>
+            </a:r>
+            <a:endParaRPr lang="en-US" altLang="ja-JP" sz="1000" dirty="0">
+              <a:latin typeface="Meiryo" panose="020B0604030504040204" pitchFamily="34" charset="-128"/>
+              <a:ea typeface="Meiryo" panose="020B0604030504040204" pitchFamily="34" charset="-128"/>
+            </a:endParaRPr>
+          </a:p>
+          <a:p>
+            <a:r>
+              <a:rPr lang="en-US" altLang="ja-JP" sz="1000" dirty="0">
+                <a:latin typeface="Meiryo" panose="020B0604030504040204" pitchFamily="34" charset="-128"/>
+                <a:ea typeface="Meiryo" panose="020B0604030504040204" pitchFamily="34" charset="-128"/>
+              </a:rPr>
+              <a:t>	5. </a:t>
+            </a:r>
+            <a:r>
+              <a:rPr lang="ja-JP" altLang="en-US" sz="1000">
+                <a:latin typeface="Meiryo" panose="020B0604030504040204" pitchFamily="34" charset="-128"/>
+                <a:ea typeface="Meiryo" panose="020B0604030504040204" pitchFamily="34" charset="-128"/>
+              </a:rPr>
+              <a:t>各月の各曜日の繁閑パーセンテージ算出</a:t>
+            </a:r>
+            <a:r>
+              <a:rPr lang="en-US" altLang="ja-JP" sz="1000" dirty="0">
+                <a:latin typeface="Meiryo" panose="020B0604030504040204" pitchFamily="34" charset="-128"/>
+                <a:ea typeface="Meiryo" panose="020B0604030504040204" pitchFamily="34" charset="-128"/>
+              </a:rPr>
+              <a:t> </a:t>
+            </a:r>
+            <a:r>
+              <a:rPr lang="ja-JP" altLang="en-US" sz="1000">
+                <a:latin typeface="Meiryo" panose="020B0604030504040204" pitchFamily="34" charset="-128"/>
+                <a:ea typeface="Meiryo" panose="020B0604030504040204" pitchFamily="34" charset="-128"/>
+              </a:rPr>
+              <a:t>→</a:t>
+            </a:r>
+            <a:r>
+              <a:rPr lang="en-US" altLang="ja-JP" sz="1000" dirty="0">
+                <a:latin typeface="Meiryo" panose="020B0604030504040204" pitchFamily="34" charset="-128"/>
+                <a:ea typeface="Meiryo" panose="020B0604030504040204" pitchFamily="34" charset="-128"/>
+              </a:rPr>
+              <a:t> </a:t>
+            </a:r>
+            <a:r>
+              <a:rPr lang="ja-JP" altLang="en-US" sz="1000">
+                <a:latin typeface="Meiryo" panose="020B0604030504040204" pitchFamily="34" charset="-128"/>
+                <a:ea typeface="Meiryo" panose="020B0604030504040204" pitchFamily="34" charset="-128"/>
+              </a:rPr>
+              <a:t>月次の総売上を超えない額に自動調整</a:t>
+            </a:r>
+            <a:endParaRPr lang="en-US" altLang="ja-JP" sz="1000" dirty="0">
+              <a:latin typeface="Meiryo" panose="020B0604030504040204" pitchFamily="34" charset="-128"/>
+              <a:ea typeface="Meiryo" panose="020B0604030504040204" pitchFamily="34" charset="-128"/>
+            </a:endParaRPr>
+          </a:p>
+          <a:p>
+            <a:r>
+              <a:rPr lang="en-US" altLang="ja-JP" sz="1000" dirty="0">
+                <a:latin typeface="Meiryo" panose="020B0604030504040204" pitchFamily="34" charset="-128"/>
+                <a:ea typeface="Meiryo" panose="020B0604030504040204" pitchFamily="34" charset="-128"/>
+              </a:rPr>
+              <a:t>	</a:t>
+            </a:r>
+            <a:r>
+              <a:rPr lang="ja-JP" altLang="en-US" sz="1000">
+                <a:latin typeface="Meiryo" panose="020B0604030504040204" pitchFamily="34" charset="-128"/>
+                <a:ea typeface="Meiryo" panose="020B0604030504040204" pitchFamily="34" charset="-128"/>
+              </a:rPr>
+              <a:t>→今年の</a:t>
+            </a:r>
+            <a:r>
+              <a:rPr lang="en-US" altLang="ja-JP" sz="1000" dirty="0">
+                <a:latin typeface="Meiryo" panose="020B0604030504040204" pitchFamily="34" charset="-128"/>
+                <a:ea typeface="Meiryo" panose="020B0604030504040204" pitchFamily="34" charset="-128"/>
+              </a:rPr>
+              <a:t>KPI</a:t>
+            </a:r>
+            <a:r>
+              <a:rPr lang="ja-JP" altLang="en-US" sz="1000">
+                <a:latin typeface="Meiryo" panose="020B0604030504040204" pitchFamily="34" charset="-128"/>
+                <a:ea typeface="Meiryo" panose="020B0604030504040204" pitchFamily="34" charset="-128"/>
+              </a:rPr>
+              <a:t>算出に仕様</a:t>
+            </a:r>
+            <a:endParaRPr lang="en-US" altLang="ja-JP" sz="1000" dirty="0">
+              <a:latin typeface="Meiryo" panose="020B0604030504040204" pitchFamily="34" charset="-128"/>
+              <a:ea typeface="Meiryo" panose="020B0604030504040204" pitchFamily="34" charset="-128"/>
+            </a:endParaRPr>
+          </a:p>
+          <a:p>
+            <a:r>
+              <a:rPr lang="ja-JP" altLang="en-US" sz="1000" b="1">
+                <a:latin typeface="Meiryo" panose="020B0604030504040204" pitchFamily="34" charset="-128"/>
+                <a:ea typeface="Meiryo" panose="020B0604030504040204" pitchFamily="34" charset="-128"/>
+              </a:rPr>
+              <a:t>＊ユーザーが初期設定時に入力した、</a:t>
+            </a:r>
+            <a:r>
+              <a:rPr lang="en-US" altLang="ja-JP" sz="1000" b="1" dirty="0">
+                <a:latin typeface="Meiryo" panose="020B0604030504040204" pitchFamily="34" charset="-128"/>
+                <a:ea typeface="Meiryo" panose="020B0604030504040204" pitchFamily="34" charset="-128"/>
+              </a:rPr>
+              <a:t>1</a:t>
+            </a:r>
+            <a:r>
+              <a:rPr lang="ja-JP" altLang="en-US" sz="1000" b="1">
+                <a:latin typeface="Meiryo" panose="020B0604030504040204" pitchFamily="34" charset="-128"/>
+                <a:ea typeface="Meiryo" panose="020B0604030504040204" pitchFamily="34" charset="-128"/>
+              </a:rPr>
+              <a:t>と</a:t>
+            </a:r>
+            <a:r>
+              <a:rPr lang="en-US" altLang="ja-JP" sz="1000" b="1" dirty="0">
+                <a:latin typeface="Meiryo" panose="020B0604030504040204" pitchFamily="34" charset="-128"/>
+                <a:ea typeface="Meiryo" panose="020B0604030504040204" pitchFamily="34" charset="-128"/>
+              </a:rPr>
+              <a:t>2</a:t>
+            </a:r>
+            <a:r>
+              <a:rPr lang="ja-JP" altLang="en-US" sz="1000" b="1">
+                <a:latin typeface="Meiryo" panose="020B0604030504040204" pitchFamily="34" charset="-128"/>
+                <a:ea typeface="Meiryo" panose="020B0604030504040204" pitchFamily="34" charset="-128"/>
+              </a:rPr>
+              <a:t>のデータからここまでを自動計算し可視化たい。</a:t>
+            </a:r>
+            <a:endParaRPr lang="en-US" altLang="ja-JP" sz="1000" b="1" dirty="0">
+              <a:latin typeface="Meiryo" panose="020B0604030504040204" pitchFamily="34" charset="-128"/>
+              <a:ea typeface="Meiryo" panose="020B0604030504040204" pitchFamily="34" charset="-128"/>
+            </a:endParaRPr>
+          </a:p>
+        </p:txBody>
+      </p:sp>
+      <p:sp>
+        <p:nvSpPr>
+          <p:cNvPr id="6" name="テキスト ボックス 5">
+            <a:extLst>
+              <a:ext uri="{FF2B5EF4-FFF2-40B4-BE49-F238E27FC236}">
+                <a16:creationId xmlns:a16="http://schemas.microsoft.com/office/drawing/2014/main" id="{BF1B7448-07C0-CB0F-F5DB-BFB2A921EFCB}"/>
+              </a:ext>
+            </a:extLst>
+          </p:cNvPr>
+          <p:cNvSpPr txBox="1"/>
+          <p:nvPr/>
+        </p:nvSpPr>
+        <p:spPr>
+          <a:xfrm>
+            <a:off x="239615" y="548853"/>
+            <a:ext cx="1003801" cy="276999"/>
+          </a:xfrm>
+          <a:prstGeom prst="rect">
+            <a:avLst/>
+          </a:prstGeom>
+          <a:noFill/>
+        </p:spPr>
+        <p:txBody>
+          <a:bodyPr wrap="none" rtlCol="0">
+            <a:spAutoFit/>
+          </a:bodyPr>
+          <a:lstStyle/>
+          <a:p>
+            <a:r>
+              <a:rPr lang="en" altLang="ja-JP" sz="1200" dirty="0">
+                <a:latin typeface="Meiryo" panose="020B0604030504040204" pitchFamily="34" charset="-128"/>
+                <a:ea typeface="Meiryo" panose="020B0604030504040204" pitchFamily="34" charset="-128"/>
+              </a:rPr>
+              <a:t>1. </a:t>
+            </a:r>
+            <a:r>
+              <a:rPr lang="ja-JP" altLang="en-US" sz="1200">
+                <a:latin typeface="Meiryo" panose="020B0604030504040204" pitchFamily="34" charset="-128"/>
+                <a:ea typeface="Meiryo" panose="020B0604030504040204" pitchFamily="34" charset="-128"/>
+              </a:rPr>
+              <a:t>初期設定</a:t>
+            </a:r>
+            <a:endParaRPr lang="en-US" altLang="ja-JP" sz="1200" dirty="0">
+              <a:latin typeface="Meiryo" panose="020B0604030504040204" pitchFamily="34" charset="-128"/>
+              <a:ea typeface="Meiryo" panose="020B0604030504040204" pitchFamily="34" charset="-128"/>
+            </a:endParaRPr>
+          </a:p>
+        </p:txBody>
+      </p:sp>
+      <p:sp>
+        <p:nvSpPr>
+          <p:cNvPr id="7" name="テキスト ボックス 6">
+            <a:extLst>
+              <a:ext uri="{FF2B5EF4-FFF2-40B4-BE49-F238E27FC236}">
+                <a16:creationId xmlns:a16="http://schemas.microsoft.com/office/drawing/2014/main" id="{AB209CDB-AF4F-3733-5876-8B8231C1F2B3}"/>
+              </a:ext>
+            </a:extLst>
+          </p:cNvPr>
+          <p:cNvSpPr txBox="1"/>
+          <p:nvPr/>
+        </p:nvSpPr>
+        <p:spPr>
+          <a:xfrm>
+            <a:off x="285410" y="3606295"/>
+            <a:ext cx="1157689" cy="276999"/>
+          </a:xfrm>
+          <a:prstGeom prst="rect">
+            <a:avLst/>
+          </a:prstGeom>
+          <a:noFill/>
+        </p:spPr>
+        <p:txBody>
+          <a:bodyPr wrap="none" rtlCol="0">
+            <a:spAutoFit/>
+          </a:bodyPr>
+          <a:lstStyle/>
+          <a:p>
+            <a:r>
+              <a:rPr lang="en" altLang="ja-JP" sz="1200" dirty="0">
+                <a:latin typeface="Meiryo" panose="020B0604030504040204" pitchFamily="34" charset="-128"/>
+                <a:ea typeface="Meiryo" panose="020B0604030504040204" pitchFamily="34" charset="-128"/>
+              </a:rPr>
+              <a:t>2. </a:t>
+            </a:r>
+            <a:r>
+              <a:rPr lang="ja-JP" altLang="en-US" sz="1200">
+                <a:latin typeface="Meiryo" panose="020B0604030504040204" pitchFamily="34" charset="-128"/>
+                <a:ea typeface="Meiryo" panose="020B0604030504040204" pitchFamily="34" charset="-128"/>
+              </a:rPr>
+              <a:t>今年の設定</a:t>
+            </a:r>
+            <a:endParaRPr lang="en-US" altLang="ja-JP" sz="1200" dirty="0">
+              <a:latin typeface="Meiryo" panose="020B0604030504040204" pitchFamily="34" charset="-128"/>
+              <a:ea typeface="Meiryo" panose="020B0604030504040204" pitchFamily="34" charset="-128"/>
+            </a:endParaRPr>
+          </a:p>
+        </p:txBody>
+      </p:sp>
+      <p:sp>
+        <p:nvSpPr>
+          <p:cNvPr id="8" name="テキスト ボックス 7">
+            <a:extLst>
+              <a:ext uri="{FF2B5EF4-FFF2-40B4-BE49-F238E27FC236}">
+                <a16:creationId xmlns:a16="http://schemas.microsoft.com/office/drawing/2014/main" id="{B99E78B5-F164-2379-8BB2-DEEDDFDA6B5B}"/>
+              </a:ext>
+            </a:extLst>
+          </p:cNvPr>
+          <p:cNvSpPr txBox="1"/>
+          <p:nvPr/>
+        </p:nvSpPr>
+        <p:spPr>
+          <a:xfrm>
+            <a:off x="396381" y="3932547"/>
+            <a:ext cx="6085339" cy="2554545"/>
+          </a:xfrm>
+          <a:prstGeom prst="rect">
+            <a:avLst/>
+          </a:prstGeom>
+          <a:noFill/>
+        </p:spPr>
+        <p:txBody>
+          <a:bodyPr wrap="square" rtlCol="0">
+            <a:spAutoFit/>
+          </a:bodyPr>
+          <a:lstStyle/>
+          <a:p>
+            <a:r>
+              <a:rPr lang="ja-JP" altLang="en-US" sz="1000">
+                <a:latin typeface="Meiryo" panose="020B0604030504040204" pitchFamily="34" charset="-128"/>
+                <a:ea typeface="Meiryo" panose="020B0604030504040204" pitchFamily="34" charset="-128"/>
+              </a:rPr>
+              <a:t>ユーザー</a:t>
+            </a:r>
+            <a:endParaRPr lang="en-US" altLang="ja-JP" sz="1000" dirty="0">
+              <a:latin typeface="Meiryo" panose="020B0604030504040204" pitchFamily="34" charset="-128"/>
+              <a:ea typeface="Meiryo" panose="020B0604030504040204" pitchFamily="34" charset="-128"/>
+            </a:endParaRPr>
+          </a:p>
+          <a:p>
+            <a:pPr marL="228600" indent="-228600">
+              <a:buAutoNum type="arabicPeriod"/>
+            </a:pPr>
+            <a:r>
+              <a:rPr lang="ja-JP" altLang="en-US" sz="1000">
+                <a:latin typeface="Meiryo" panose="020B0604030504040204" pitchFamily="34" charset="-128"/>
+                <a:ea typeface="Meiryo" panose="020B0604030504040204" pitchFamily="34" charset="-128"/>
+              </a:rPr>
+              <a:t>今年の総営業日の設定</a:t>
+            </a:r>
+            <a:r>
+              <a:rPr lang="en-US" altLang="ja-JP" sz="1000" dirty="0">
+                <a:latin typeface="Meiryo" panose="020B0604030504040204" pitchFamily="34" charset="-128"/>
+                <a:ea typeface="Meiryo" panose="020B0604030504040204" pitchFamily="34" charset="-128"/>
+              </a:rPr>
+              <a:t>(</a:t>
+            </a:r>
+            <a:r>
+              <a:rPr lang="ja-JP" altLang="en-US" sz="1000">
+                <a:latin typeface="Meiryo" panose="020B0604030504040204" pitchFamily="34" charset="-128"/>
+                <a:ea typeface="Meiryo" panose="020B0604030504040204" pitchFamily="34" charset="-128"/>
+              </a:rPr>
+              <a:t>後でいつでも変更可能＊誤入力修正など</a:t>
+            </a:r>
+            <a:r>
+              <a:rPr lang="en-US" altLang="ja-JP" sz="1000" dirty="0">
+                <a:latin typeface="Meiryo" panose="020B0604030504040204" pitchFamily="34" charset="-128"/>
+                <a:ea typeface="Meiryo" panose="020B0604030504040204" pitchFamily="34" charset="-128"/>
+              </a:rPr>
+              <a:t>)</a:t>
+            </a:r>
+          </a:p>
+          <a:p>
+            <a:pPr marL="228600" indent="-228600">
+              <a:buAutoNum type="arabicPeriod"/>
+            </a:pPr>
+            <a:r>
+              <a:rPr lang="ja-JP" altLang="en-US" sz="1000">
+                <a:latin typeface="Meiryo" panose="020B0604030504040204" pitchFamily="34" charset="-128"/>
+                <a:ea typeface="Meiryo" panose="020B0604030504040204" pitchFamily="34" charset="-128"/>
+              </a:rPr>
+              <a:t>今年の日次売上額</a:t>
+            </a:r>
+            <a:r>
+              <a:rPr lang="en-US" altLang="ja-JP" sz="1000" dirty="0">
+                <a:latin typeface="Meiryo" panose="020B0604030504040204" pitchFamily="34" charset="-128"/>
+                <a:ea typeface="Meiryo" panose="020B0604030504040204" pitchFamily="34" charset="-128"/>
+              </a:rPr>
+              <a:t>(</a:t>
+            </a:r>
+            <a:r>
+              <a:rPr lang="ja-JP" altLang="en-US" sz="1000">
+                <a:latin typeface="Meiryo" panose="020B0604030504040204" pitchFamily="34" charset="-128"/>
+                <a:ea typeface="Meiryo" panose="020B0604030504040204" pitchFamily="34" charset="-128"/>
+              </a:rPr>
+              <a:t>後でいつでも変更可能＊誤入力修正など</a:t>
+            </a:r>
+            <a:r>
+              <a:rPr lang="en-US" altLang="ja-JP" sz="1000" dirty="0">
+                <a:latin typeface="Meiryo" panose="020B0604030504040204" pitchFamily="34" charset="-128"/>
+                <a:ea typeface="Meiryo" panose="020B0604030504040204" pitchFamily="34" charset="-128"/>
+              </a:rPr>
+              <a:t>)</a:t>
+            </a:r>
+          </a:p>
+          <a:p>
+            <a:r>
+              <a:rPr lang="ja-JP" altLang="en-US" sz="1000">
+                <a:latin typeface="Meiryo" panose="020B0604030504040204" pitchFamily="34" charset="-128"/>
+                <a:ea typeface="Meiryo" panose="020B0604030504040204" pitchFamily="34" charset="-128"/>
+              </a:rPr>
+              <a:t>＊</a:t>
+            </a:r>
+            <a:r>
+              <a:rPr lang="en-US" altLang="ja-JP" sz="1000" dirty="0">
+                <a:latin typeface="Meiryo" panose="020B0604030504040204" pitchFamily="34" charset="-128"/>
+                <a:ea typeface="Meiryo" panose="020B0604030504040204" pitchFamily="34" charset="-128"/>
+              </a:rPr>
+              <a:t>CSV</a:t>
+            </a:r>
+            <a:r>
+              <a:rPr lang="ja-JP" altLang="en-US" sz="1000">
+                <a:latin typeface="Meiryo" panose="020B0604030504040204" pitchFamily="34" charset="-128"/>
+                <a:ea typeface="Meiryo" panose="020B0604030504040204" pitchFamily="34" charset="-128"/>
+              </a:rPr>
+              <a:t>をアップロードして自動で反映もしたい。その場合の</a:t>
+            </a:r>
+            <a:r>
+              <a:rPr lang="en-US" altLang="ja-JP" sz="1000" dirty="0">
+                <a:latin typeface="Meiryo" panose="020B0604030504040204" pitchFamily="34" charset="-128"/>
+                <a:ea typeface="Meiryo" panose="020B0604030504040204" pitchFamily="34" charset="-128"/>
+              </a:rPr>
+              <a:t>CSV</a:t>
+            </a:r>
+            <a:r>
+              <a:rPr lang="ja-JP" altLang="en-US" sz="1000">
+                <a:latin typeface="Meiryo" panose="020B0604030504040204" pitchFamily="34" charset="-128"/>
+                <a:ea typeface="Meiryo" panose="020B0604030504040204" pitchFamily="34" charset="-128"/>
+              </a:rPr>
+              <a:t>のタイトルなどはユーザーにより差異があるのでそのパターンを見極められるロジックが欲しい。</a:t>
+            </a:r>
+            <a:endParaRPr lang="en-US" altLang="ja-JP" sz="1000" dirty="0">
+              <a:latin typeface="Meiryo" panose="020B0604030504040204" pitchFamily="34" charset="-128"/>
+              <a:ea typeface="Meiryo" panose="020B0604030504040204" pitchFamily="34" charset="-128"/>
+            </a:endParaRPr>
+          </a:p>
+          <a:p>
+            <a:r>
+              <a:rPr lang="en-US" altLang="ja-JP" sz="1000" dirty="0">
+                <a:latin typeface="Meiryo" panose="020B0604030504040204" pitchFamily="34" charset="-128"/>
+                <a:ea typeface="Meiryo" panose="020B0604030504040204" pitchFamily="34" charset="-128"/>
+              </a:rPr>
+              <a:t>3.</a:t>
+            </a:r>
+            <a:r>
+              <a:rPr lang="ja-JP" altLang="en-US" sz="1000">
+                <a:latin typeface="Meiryo" panose="020B0604030504040204" pitchFamily="34" charset="-128"/>
+                <a:ea typeface="Meiryo" panose="020B0604030504040204" pitchFamily="34" charset="-128"/>
+              </a:rPr>
+              <a:t>　年次目標売上額を確定</a:t>
+            </a:r>
+            <a:endParaRPr lang="en-US" altLang="ja-JP" sz="1000" dirty="0">
+              <a:latin typeface="Meiryo" panose="020B0604030504040204" pitchFamily="34" charset="-128"/>
+              <a:ea typeface="Meiryo" panose="020B0604030504040204" pitchFamily="34" charset="-128"/>
+            </a:endParaRPr>
+          </a:p>
+          <a:p>
+            <a:r>
+              <a:rPr lang="en-US" altLang="ja-JP" sz="1000" dirty="0">
+                <a:latin typeface="Meiryo" panose="020B0604030504040204" pitchFamily="34" charset="-128"/>
+                <a:ea typeface="Meiryo" panose="020B0604030504040204" pitchFamily="34" charset="-128"/>
+              </a:rPr>
+              <a:t>4.</a:t>
+            </a:r>
+            <a:r>
+              <a:rPr lang="ja-JP" altLang="en-US" sz="1000">
+                <a:latin typeface="Meiryo" panose="020B0604030504040204" pitchFamily="34" charset="-128"/>
+                <a:ea typeface="Meiryo" panose="020B0604030504040204" pitchFamily="34" charset="-128"/>
+              </a:rPr>
+              <a:t>　月次繁閑期パーセンテージ調整</a:t>
+            </a:r>
+            <a:endParaRPr lang="en-US" altLang="ja-JP" sz="1000" dirty="0">
+              <a:latin typeface="Meiryo" panose="020B0604030504040204" pitchFamily="34" charset="-128"/>
+              <a:ea typeface="Meiryo" panose="020B0604030504040204" pitchFamily="34" charset="-128"/>
+            </a:endParaRPr>
+          </a:p>
+          <a:p>
+            <a:endParaRPr lang="en-US" altLang="ja-JP" sz="1000" dirty="0">
+              <a:latin typeface="Meiryo" panose="020B0604030504040204" pitchFamily="34" charset="-128"/>
+              <a:ea typeface="Meiryo" panose="020B0604030504040204" pitchFamily="34" charset="-128"/>
+            </a:endParaRPr>
+          </a:p>
+          <a:p>
+            <a:r>
+              <a:rPr lang="en-US" altLang="ja-JP" sz="1000" dirty="0">
+                <a:latin typeface="Meiryo" panose="020B0604030504040204" pitchFamily="34" charset="-128"/>
+                <a:ea typeface="Meiryo" panose="020B0604030504040204" pitchFamily="34" charset="-128"/>
+              </a:rPr>
+              <a:t>【</a:t>
+            </a:r>
+            <a:r>
+              <a:rPr lang="ja-JP" altLang="en-US" sz="1000">
+                <a:latin typeface="Meiryo" panose="020B0604030504040204" pitchFamily="34" charset="-128"/>
+                <a:ea typeface="Meiryo" panose="020B0604030504040204" pitchFamily="34" charset="-128"/>
+              </a:rPr>
+              <a:t>ユーザー入力後に</a:t>
+            </a:r>
+            <a:r>
+              <a:rPr lang="en-US" altLang="ja-JP" sz="1000" dirty="0">
+                <a:latin typeface="Meiryo" panose="020B0604030504040204" pitchFamily="34" charset="-128"/>
+                <a:ea typeface="Meiryo" panose="020B0604030504040204" pitchFamily="34" charset="-128"/>
+              </a:rPr>
+              <a:t>Web</a:t>
+            </a:r>
+            <a:r>
+              <a:rPr lang="ja-JP" altLang="en-US" sz="1000">
+                <a:latin typeface="Meiryo" panose="020B0604030504040204" pitchFamily="34" charset="-128"/>
+                <a:ea typeface="Meiryo" panose="020B0604030504040204" pitchFamily="34" charset="-128"/>
+              </a:rPr>
+              <a:t>アプリがすること</a:t>
+            </a:r>
+            <a:r>
+              <a:rPr lang="en-US" altLang="ja-JP" sz="1000" dirty="0">
+                <a:latin typeface="Meiryo" panose="020B0604030504040204" pitchFamily="34" charset="-128"/>
+                <a:ea typeface="Meiryo" panose="020B0604030504040204" pitchFamily="34" charset="-128"/>
+              </a:rPr>
+              <a:t>】</a:t>
+            </a:r>
+          </a:p>
+          <a:p>
+            <a:r>
+              <a:rPr lang="en-US" altLang="ja-JP" sz="1000" dirty="0">
+                <a:latin typeface="Meiryo" panose="020B0604030504040204" pitchFamily="34" charset="-128"/>
+                <a:ea typeface="Meiryo" panose="020B0604030504040204" pitchFamily="34" charset="-128"/>
+              </a:rPr>
+              <a:t>	1. </a:t>
+            </a:r>
+            <a:r>
+              <a:rPr lang="ja-JP" altLang="en-US" sz="1000">
+                <a:latin typeface="Meiryo" panose="020B0604030504040204" pitchFamily="34" charset="-128"/>
+                <a:ea typeface="Meiryo" panose="020B0604030504040204" pitchFamily="34" charset="-128"/>
+              </a:rPr>
+              <a:t>年間目標売上額を年間総営業日で割る</a:t>
+            </a:r>
+            <a:endParaRPr lang="en-US" altLang="ja-JP" sz="1000" dirty="0">
+              <a:latin typeface="Meiryo" panose="020B0604030504040204" pitchFamily="34" charset="-128"/>
+              <a:ea typeface="Meiryo" panose="020B0604030504040204" pitchFamily="34" charset="-128"/>
+            </a:endParaRPr>
+          </a:p>
+          <a:p>
+            <a:r>
+              <a:rPr lang="en-US" altLang="ja-JP" sz="1000" dirty="0">
+                <a:latin typeface="Meiryo" panose="020B0604030504040204" pitchFamily="34" charset="-128"/>
+                <a:ea typeface="Meiryo" panose="020B0604030504040204" pitchFamily="34" charset="-128"/>
+              </a:rPr>
+              <a:t>	2. </a:t>
+            </a:r>
+            <a:r>
+              <a:rPr lang="ja-JP" altLang="en-US" sz="1000">
+                <a:latin typeface="Meiryo" panose="020B0604030504040204" pitchFamily="34" charset="-128"/>
+                <a:ea typeface="Meiryo" panose="020B0604030504040204" pitchFamily="34" charset="-128"/>
+              </a:rPr>
+              <a:t>日次の平均目標売上額を算出</a:t>
+            </a:r>
+            <a:r>
+              <a:rPr lang="en-US" altLang="ja-JP" sz="1000" dirty="0">
+                <a:latin typeface="Meiryo" panose="020B0604030504040204" pitchFamily="34" charset="-128"/>
+                <a:ea typeface="Meiryo" panose="020B0604030504040204" pitchFamily="34" charset="-128"/>
+              </a:rPr>
+              <a:t>(</a:t>
+            </a:r>
+            <a:r>
+              <a:rPr lang="ja-JP" altLang="en-US" sz="1000">
+                <a:latin typeface="Meiryo" panose="020B0604030504040204" pitchFamily="34" charset="-128"/>
+                <a:ea typeface="Meiryo" panose="020B0604030504040204" pitchFamily="34" charset="-128"/>
+              </a:rPr>
+              <a:t>繁閑期を割り出すための基軸となる数値</a:t>
+            </a:r>
+            <a:r>
+              <a:rPr lang="en-US" altLang="ja-JP" sz="1000" dirty="0">
+                <a:latin typeface="Meiryo" panose="020B0604030504040204" pitchFamily="34" charset="-128"/>
+                <a:ea typeface="Meiryo" panose="020B0604030504040204" pitchFamily="34" charset="-128"/>
+              </a:rPr>
+              <a:t>)</a:t>
+            </a:r>
+          </a:p>
+          <a:p>
+            <a:r>
+              <a:rPr lang="en-US" altLang="ja-JP" sz="1000" dirty="0">
+                <a:latin typeface="Meiryo" panose="020B0604030504040204" pitchFamily="34" charset="-128"/>
+                <a:ea typeface="Meiryo" panose="020B0604030504040204" pitchFamily="34" charset="-128"/>
+              </a:rPr>
+              <a:t>	3. </a:t>
+            </a:r>
+            <a:r>
+              <a:rPr lang="ja-JP" altLang="en-US" sz="1000">
+                <a:latin typeface="Meiryo" panose="020B0604030504040204" pitchFamily="34" charset="-128"/>
+                <a:ea typeface="Meiryo" panose="020B0604030504040204" pitchFamily="34" charset="-128"/>
+              </a:rPr>
+              <a:t>日次目標売上</a:t>
+            </a:r>
+            <a:r>
+              <a:rPr lang="en-US" altLang="ja-JP" sz="1000" dirty="0">
+                <a:latin typeface="Meiryo" panose="020B0604030504040204" pitchFamily="34" charset="-128"/>
+                <a:ea typeface="Meiryo" panose="020B0604030504040204" pitchFamily="34" charset="-128"/>
+              </a:rPr>
+              <a:t>×</a:t>
+            </a:r>
+            <a:r>
+              <a:rPr lang="ja-JP" altLang="en-US" sz="1000">
+                <a:latin typeface="Meiryo" panose="020B0604030504040204" pitchFamily="34" charset="-128"/>
+                <a:ea typeface="Meiryo" panose="020B0604030504040204" pitchFamily="34" charset="-128"/>
+              </a:rPr>
+              <a:t>月次営業日</a:t>
+            </a:r>
+            <a:r>
+              <a:rPr lang="en-US" altLang="ja-JP" sz="1000" dirty="0">
+                <a:latin typeface="Meiryo" panose="020B0604030504040204" pitchFamily="34" charset="-128"/>
+                <a:ea typeface="Meiryo" panose="020B0604030504040204" pitchFamily="34" charset="-128"/>
+              </a:rPr>
+              <a:t>=</a:t>
+            </a:r>
+            <a:r>
+              <a:rPr lang="ja-JP" altLang="en-US" sz="1000">
+                <a:latin typeface="Meiryo" panose="020B0604030504040204" pitchFamily="34" charset="-128"/>
+                <a:ea typeface="Meiryo" panose="020B0604030504040204" pitchFamily="34" charset="-128"/>
+              </a:rPr>
+              <a:t>目標平均月次売上額算出</a:t>
+            </a:r>
+            <a:endParaRPr lang="en-US" altLang="ja-JP" sz="1000" dirty="0">
+              <a:latin typeface="Meiryo" panose="020B0604030504040204" pitchFamily="34" charset="-128"/>
+              <a:ea typeface="Meiryo" panose="020B0604030504040204" pitchFamily="34" charset="-128"/>
+            </a:endParaRPr>
+          </a:p>
+          <a:p>
+            <a:r>
+              <a:rPr lang="en-US" altLang="ja-JP" sz="1000" dirty="0">
+                <a:latin typeface="Meiryo" panose="020B0604030504040204" pitchFamily="34" charset="-128"/>
+                <a:ea typeface="Meiryo" panose="020B0604030504040204" pitchFamily="34" charset="-128"/>
+              </a:rPr>
+              <a:t>	4. </a:t>
+            </a:r>
+            <a:r>
+              <a:rPr lang="ja-JP" altLang="en-US" sz="1000">
+                <a:latin typeface="Meiryo" panose="020B0604030504040204" pitchFamily="34" charset="-128"/>
+                <a:ea typeface="Meiryo" panose="020B0604030504040204" pitchFamily="34" charset="-128"/>
+              </a:rPr>
+              <a:t>前年の繁閑期パーセンテージと目標平均月次売上額を掛け、根拠のある目標月次売上額算出</a:t>
+            </a:r>
+            <a:endParaRPr lang="en-US" altLang="ja-JP" sz="1000" dirty="0">
+              <a:latin typeface="Meiryo" panose="020B0604030504040204" pitchFamily="34" charset="-128"/>
+              <a:ea typeface="Meiryo" panose="020B0604030504040204" pitchFamily="34" charset="-128"/>
+            </a:endParaRPr>
+          </a:p>
+          <a:p>
+            <a:r>
+              <a:rPr lang="en-US" altLang="ja-JP" sz="1000" dirty="0">
+                <a:latin typeface="Meiryo" panose="020B0604030504040204" pitchFamily="34" charset="-128"/>
+                <a:ea typeface="Meiryo" panose="020B0604030504040204" pitchFamily="34" charset="-128"/>
+              </a:rPr>
+              <a:t>	5. </a:t>
+            </a:r>
+            <a:r>
+              <a:rPr lang="ja-JP" altLang="en-US" sz="1000">
+                <a:latin typeface="Meiryo" panose="020B0604030504040204" pitchFamily="34" charset="-128"/>
+                <a:ea typeface="Meiryo" panose="020B0604030504040204" pitchFamily="34" charset="-128"/>
+              </a:rPr>
+              <a:t>各月の各曜日の繁閑パーセンテージ算出</a:t>
+            </a:r>
+            <a:r>
+              <a:rPr lang="en-US" altLang="ja-JP" sz="1000" dirty="0">
+                <a:latin typeface="Meiryo" panose="020B0604030504040204" pitchFamily="34" charset="-128"/>
+                <a:ea typeface="Meiryo" panose="020B0604030504040204" pitchFamily="34" charset="-128"/>
+              </a:rPr>
+              <a:t> </a:t>
+            </a:r>
+            <a:r>
+              <a:rPr lang="ja-JP" altLang="en-US" sz="1000">
+                <a:latin typeface="Meiryo" panose="020B0604030504040204" pitchFamily="34" charset="-128"/>
+                <a:ea typeface="Meiryo" panose="020B0604030504040204" pitchFamily="34" charset="-128"/>
+              </a:rPr>
+              <a:t>→</a:t>
+            </a:r>
+            <a:r>
+              <a:rPr lang="en-US" altLang="ja-JP" sz="1000" dirty="0">
+                <a:latin typeface="Meiryo" panose="020B0604030504040204" pitchFamily="34" charset="-128"/>
+                <a:ea typeface="Meiryo" panose="020B0604030504040204" pitchFamily="34" charset="-128"/>
+              </a:rPr>
+              <a:t> </a:t>
+            </a:r>
+            <a:r>
+              <a:rPr lang="ja-JP" altLang="en-US" sz="1000">
+                <a:latin typeface="Meiryo" panose="020B0604030504040204" pitchFamily="34" charset="-128"/>
+                <a:ea typeface="Meiryo" panose="020B0604030504040204" pitchFamily="34" charset="-128"/>
+              </a:rPr>
+              <a:t>月次の総売上を超えない額に自動調整</a:t>
+            </a:r>
+            <a:endParaRPr lang="en-US" altLang="ja-JP" sz="1000" dirty="0">
+              <a:latin typeface="Meiryo" panose="020B0604030504040204" pitchFamily="34" charset="-128"/>
+              <a:ea typeface="Meiryo" panose="020B0604030504040204" pitchFamily="34" charset="-128"/>
+            </a:endParaRPr>
+          </a:p>
+          <a:p>
+            <a:r>
+              <a:rPr lang="en-US" altLang="ja-JP" sz="1000" dirty="0">
+                <a:latin typeface="Meiryo" panose="020B0604030504040204" pitchFamily="34" charset="-128"/>
+                <a:ea typeface="Meiryo" panose="020B0604030504040204" pitchFamily="34" charset="-128"/>
+              </a:rPr>
+              <a:t>	</a:t>
+            </a:r>
+            <a:r>
+              <a:rPr lang="ja-JP" altLang="en-US" sz="1000">
+                <a:latin typeface="Meiryo" panose="020B0604030504040204" pitchFamily="34" charset="-128"/>
+                <a:ea typeface="Meiryo" panose="020B0604030504040204" pitchFamily="34" charset="-128"/>
+              </a:rPr>
+              <a:t>→今年の</a:t>
+            </a:r>
+            <a:r>
+              <a:rPr lang="en-US" altLang="ja-JP" sz="1000" dirty="0">
+                <a:latin typeface="Meiryo" panose="020B0604030504040204" pitchFamily="34" charset="-128"/>
+                <a:ea typeface="Meiryo" panose="020B0604030504040204" pitchFamily="34" charset="-128"/>
+              </a:rPr>
+              <a:t>KPI</a:t>
+            </a:r>
+            <a:r>
+              <a:rPr lang="ja-JP" altLang="en-US" sz="1000">
+                <a:latin typeface="Meiryo" panose="020B0604030504040204" pitchFamily="34" charset="-128"/>
+                <a:ea typeface="Meiryo" panose="020B0604030504040204" pitchFamily="34" charset="-128"/>
+              </a:rPr>
+              <a:t>算出に仕様</a:t>
+            </a:r>
+            <a:endParaRPr lang="en-US" altLang="ja-JP" sz="1000" dirty="0">
+              <a:latin typeface="Meiryo" panose="020B0604030504040204" pitchFamily="34" charset="-128"/>
+              <a:ea typeface="Meiryo" panose="020B0604030504040204" pitchFamily="34" charset="-128"/>
+            </a:endParaRPr>
+          </a:p>
+          <a:p>
+            <a:r>
+              <a:rPr lang="ja-JP" altLang="en-US" sz="1000" b="1">
+                <a:latin typeface="Meiryo" panose="020B0604030504040204" pitchFamily="34" charset="-128"/>
+                <a:ea typeface="Meiryo" panose="020B0604030504040204" pitchFamily="34" charset="-128"/>
+              </a:rPr>
+              <a:t>＊ユーザーが初期設定時に入力した、</a:t>
+            </a:r>
+            <a:r>
+              <a:rPr lang="en-US" altLang="ja-JP" sz="1000" b="1" dirty="0">
+                <a:latin typeface="Meiryo" panose="020B0604030504040204" pitchFamily="34" charset="-128"/>
+                <a:ea typeface="Meiryo" panose="020B0604030504040204" pitchFamily="34" charset="-128"/>
+              </a:rPr>
+              <a:t>1</a:t>
+            </a:r>
+            <a:r>
+              <a:rPr lang="ja-JP" altLang="en-US" sz="1000" b="1">
+                <a:latin typeface="Meiryo" panose="020B0604030504040204" pitchFamily="34" charset="-128"/>
+                <a:ea typeface="Meiryo" panose="020B0604030504040204" pitchFamily="34" charset="-128"/>
+              </a:rPr>
+              <a:t>と</a:t>
+            </a:r>
+            <a:r>
+              <a:rPr lang="en-US" altLang="ja-JP" sz="1000" b="1" dirty="0">
+                <a:latin typeface="Meiryo" panose="020B0604030504040204" pitchFamily="34" charset="-128"/>
+                <a:ea typeface="Meiryo" panose="020B0604030504040204" pitchFamily="34" charset="-128"/>
+              </a:rPr>
+              <a:t>2</a:t>
+            </a:r>
+            <a:r>
+              <a:rPr lang="ja-JP" altLang="en-US" sz="1000" b="1">
+                <a:latin typeface="Meiryo" panose="020B0604030504040204" pitchFamily="34" charset="-128"/>
+                <a:ea typeface="Meiryo" panose="020B0604030504040204" pitchFamily="34" charset="-128"/>
+              </a:rPr>
+              <a:t>のデータからここまでを自動計算し可視化たい。</a:t>
+            </a:r>
+            <a:endParaRPr lang="en-US" altLang="ja-JP" sz="1000" b="1" dirty="0">
+              <a:latin typeface="Meiryo" panose="020B0604030504040204" pitchFamily="34" charset="-128"/>
+              <a:ea typeface="Meiryo" panose="020B0604030504040204" pitchFamily="34" charset="-128"/>
+            </a:endParaRPr>
+          </a:p>
+        </p:txBody>
+      </p:sp>
+    </p:spTree>
+    <p:extLst>
+      <p:ext uri="{BB962C8B-B14F-4D97-AF65-F5344CB8AC3E}">
+        <p14:creationId xmlns:p14="http://schemas.microsoft.com/office/powerpoint/2010/main" val="40265774"/>
+      </p:ext>
+    </p:extLst>
+  </p:cSld>
+  <p:clrMapOvr>
+    <a:masterClrMapping/>
+  </p:clrMapOvr>
+</p:sld>
+</file>
+
+<file path=ppt/slides/slide2.xml><?xml version="1.0" encoding="utf-8"?>
+<p:sld xmlns:a="http://schemas.openxmlformats.org/drawingml/2006/main" xmlns:r="http://schemas.openxmlformats.org/officeDocument/2006/relationships" xmlns:p="http://schemas.openxmlformats.org/presentationml/2006/main">
+  <p:cSld>
+    <p:spTree>
+      <p:nvGrpSpPr>
+        <p:cNvPr id="1" name=""/>
+        <p:cNvGrpSpPr/>
+        <p:nvPr/>
+      </p:nvGrpSpPr>
+      <p:grpSpPr>
+        <a:xfrm>
+          <a:off x="0" y="0"/>
+          <a:ext cx="0" cy="0"/>
+          <a:chOff x="0" y="0"/>
+          <a:chExt cx="0" cy="0"/>
+        </a:xfrm>
+      </p:grpSpPr>
+      <p:sp>
+        <p:nvSpPr>
+          <p:cNvPr id="4" name="テキスト ボックス 3">
+            <a:extLst>
+              <a:ext uri="{FF2B5EF4-FFF2-40B4-BE49-F238E27FC236}">
+                <a16:creationId xmlns:a16="http://schemas.microsoft.com/office/drawing/2014/main" id="{A1539ACE-D6D2-827E-E0A1-26E2E467D65F}"/>
+              </a:ext>
+            </a:extLst>
+          </p:cNvPr>
+          <p:cNvSpPr txBox="1"/>
+          <p:nvPr/>
+        </p:nvSpPr>
+        <p:spPr>
+          <a:xfrm>
+            <a:off x="2051090" y="128419"/>
+            <a:ext cx="2755819" cy="369332"/>
+          </a:xfrm>
+          <a:prstGeom prst="rect">
+            <a:avLst/>
+          </a:prstGeom>
+          <a:noFill/>
+        </p:spPr>
+        <p:txBody>
+          <a:bodyPr wrap="none" rtlCol="0">
+            <a:spAutoFit/>
+          </a:bodyPr>
+          <a:lstStyle/>
+          <a:p>
+            <a:r>
+              <a:rPr kumimoji="1" lang="en-US" altLang="ja-JP" dirty="0">
+                <a:latin typeface="Meiryo" panose="020B0604030504040204" pitchFamily="34" charset="-128"/>
+                <a:ea typeface="Meiryo" panose="020B0604030504040204" pitchFamily="34" charset="-128"/>
+              </a:rPr>
+              <a:t>KPI-Navigator </a:t>
+            </a:r>
+            <a:r>
+              <a:rPr kumimoji="1" lang="ja-JP" altLang="en-US">
+                <a:latin typeface="Meiryo" panose="020B0604030504040204" pitchFamily="34" charset="-128"/>
+                <a:ea typeface="Meiryo" panose="020B0604030504040204" pitchFamily="34" charset="-128"/>
+              </a:rPr>
               <a:t>機能詳細</a:t>
+            </a:r>
+          </a:p>
+        </p:txBody>
+      </p:sp>
+      <p:sp>
+        <p:nvSpPr>
+          <p:cNvPr id="5" name="テキスト ボックス 4">
+            <a:extLst>
+              <a:ext uri="{FF2B5EF4-FFF2-40B4-BE49-F238E27FC236}">
+                <a16:creationId xmlns:a16="http://schemas.microsoft.com/office/drawing/2014/main" id="{CF4BE554-5ED6-1181-B8BF-CA97709C4E6A}"/>
+              </a:ext>
+            </a:extLst>
+          </p:cNvPr>
+          <p:cNvSpPr txBox="1"/>
+          <p:nvPr/>
+        </p:nvSpPr>
+        <p:spPr>
+          <a:xfrm>
+            <a:off x="583198" y="834644"/>
+            <a:ext cx="5709185" cy="2554545"/>
+          </a:xfrm>
+          <a:prstGeom prst="rect">
+            <a:avLst/>
+          </a:prstGeom>
+          <a:noFill/>
+        </p:spPr>
+        <p:txBody>
+          <a:bodyPr wrap="square" rtlCol="0">
+            <a:spAutoFit/>
+          </a:bodyPr>
+          <a:lstStyle/>
+          <a:p>
+            <a:r>
+              <a:rPr lang="ja-JP" altLang="en-US" sz="1000">
+                <a:latin typeface="Meiryo" panose="020B0604030504040204" pitchFamily="34" charset="-128"/>
+                <a:ea typeface="Meiryo" panose="020B0604030504040204" pitchFamily="34" charset="-128"/>
+              </a:rPr>
+              <a:t>この</a:t>
+            </a:r>
+            <a:r>
+              <a:rPr lang="en-US" altLang="ja-JP" sz="1000" dirty="0">
+                <a:latin typeface="Meiryo" panose="020B0604030504040204" pitchFamily="34" charset="-128"/>
+                <a:ea typeface="Meiryo" panose="020B0604030504040204" pitchFamily="34" charset="-128"/>
+              </a:rPr>
+              <a:t>PDF</a:t>
+            </a:r>
+            <a:r>
+              <a:rPr lang="ja-JP" altLang="en-US" sz="1000">
+                <a:latin typeface="Meiryo" panose="020B0604030504040204" pitchFamily="34" charset="-128"/>
+                <a:ea typeface="Meiryo" panose="020B0604030504040204" pitchFamily="34" charset="-128"/>
+              </a:rPr>
+              <a:t>は</a:t>
+            </a:r>
+            <a:r>
+              <a:rPr lang="en-US" altLang="ja-JP" sz="1000" dirty="0">
+                <a:latin typeface="Meiryo" panose="020B0604030504040204" pitchFamily="34" charset="-128"/>
+                <a:ea typeface="Meiryo" panose="020B0604030504040204" pitchFamily="34" charset="-128"/>
+              </a:rPr>
+              <a:t>ChatGPT Code Copilot</a:t>
+            </a:r>
+            <a:r>
+              <a:rPr lang="ja-JP" altLang="en-US" sz="1000">
+                <a:latin typeface="Meiryo" panose="020B0604030504040204" pitchFamily="34" charset="-128"/>
+                <a:ea typeface="Meiryo" panose="020B0604030504040204" pitchFamily="34" charset="-128"/>
+              </a:rPr>
+              <a:t>に現在開発中の</a:t>
+            </a:r>
+            <a:r>
+              <a:rPr lang="en-US" altLang="ja-JP" sz="1000" dirty="0">
+                <a:latin typeface="Meiryo" panose="020B0604030504040204" pitchFamily="34" charset="-128"/>
+                <a:ea typeface="Meiryo" panose="020B0604030504040204" pitchFamily="34" charset="-128"/>
+              </a:rPr>
+              <a:t>KPI Navigator</a:t>
+            </a:r>
+            <a:r>
+              <a:rPr lang="ja-JP" altLang="en-US" sz="1000">
+                <a:latin typeface="Meiryo" panose="020B0604030504040204" pitchFamily="34" charset="-128"/>
+                <a:ea typeface="Meiryo" panose="020B0604030504040204" pitchFamily="34" charset="-128"/>
+              </a:rPr>
+              <a:t>の機能詳細や</a:t>
+            </a:r>
+            <a:r>
+              <a:rPr lang="en-US" altLang="ja-JP" sz="1000" dirty="0">
+                <a:latin typeface="Meiryo" panose="020B0604030504040204" pitchFamily="34" charset="-128"/>
+                <a:ea typeface="Meiryo" panose="020B0604030504040204" pitchFamily="34" charset="-128"/>
+              </a:rPr>
+              <a:t>UI/UX</a:t>
+            </a:r>
+            <a:r>
+              <a:rPr lang="ja-JP" altLang="en-US" sz="1000">
+                <a:latin typeface="Meiryo" panose="020B0604030504040204" pitchFamily="34" charset="-128"/>
+                <a:ea typeface="Meiryo" panose="020B0604030504040204" pitchFamily="34" charset="-128"/>
+              </a:rPr>
+              <a:t>のこだわり</a:t>
+            </a:r>
+            <a:endParaRPr lang="en-US" altLang="ja-JP" sz="1000" dirty="0">
+              <a:latin typeface="Meiryo" panose="020B0604030504040204" pitchFamily="34" charset="-128"/>
+              <a:ea typeface="Meiryo" panose="020B0604030504040204" pitchFamily="34" charset="-128"/>
+            </a:endParaRPr>
+          </a:p>
+          <a:p>
+            <a:r>
+              <a:rPr lang="ja-JP" altLang="en-US" sz="1000">
+                <a:latin typeface="Meiryo" panose="020B0604030504040204" pitchFamily="34" charset="-128"/>
+                <a:ea typeface="Meiryo" panose="020B0604030504040204" pitchFamily="34" charset="-128"/>
+              </a:rPr>
+              <a:t>を伝えるために作成。</a:t>
+            </a:r>
+            <a:endParaRPr lang="en-US" altLang="ja-JP" sz="1000" dirty="0">
+              <a:latin typeface="Meiryo" panose="020B0604030504040204" pitchFamily="34" charset="-128"/>
+              <a:ea typeface="Meiryo" panose="020B0604030504040204" pitchFamily="34" charset="-128"/>
+            </a:endParaRPr>
+          </a:p>
+          <a:p>
+            <a:r>
+              <a:rPr lang="ja-JP" altLang="en-US" sz="1000">
+                <a:latin typeface="Meiryo" panose="020B0604030504040204" pitchFamily="34" charset="-128"/>
+                <a:ea typeface="Meiryo" panose="020B0604030504040204" pitchFamily="34" charset="-128"/>
+              </a:rPr>
+              <a:t>基本的に作り始めたのは</a:t>
+            </a:r>
+            <a:r>
+              <a:rPr lang="en-US" altLang="ja-JP" sz="1000" dirty="0">
+                <a:latin typeface="Meiryo" panose="020B0604030504040204" pitchFamily="34" charset="-128"/>
+                <a:ea typeface="Meiryo" panose="020B0604030504040204" pitchFamily="34" charset="-128"/>
+              </a:rPr>
+              <a:t>Google Spread Sheet</a:t>
+            </a:r>
+            <a:r>
+              <a:rPr lang="ja-JP" altLang="en-US" sz="1000">
+                <a:latin typeface="Meiryo" panose="020B0604030504040204" pitchFamily="34" charset="-128"/>
+                <a:ea typeface="Meiryo" panose="020B0604030504040204" pitchFamily="34" charset="-128"/>
+              </a:rPr>
+              <a:t>で作成に着手し、構築したものを</a:t>
+            </a:r>
+            <a:r>
+              <a:rPr lang="en-US" altLang="ja-JP" sz="1000" dirty="0">
+                <a:latin typeface="Meiryo" panose="020B0604030504040204" pitchFamily="34" charset="-128"/>
+                <a:ea typeface="Meiryo" panose="020B0604030504040204" pitchFamily="34" charset="-128"/>
+              </a:rPr>
+              <a:t>Web</a:t>
+            </a:r>
+            <a:r>
+              <a:rPr lang="ja-JP" altLang="en-US" sz="1000">
+                <a:latin typeface="Meiryo" panose="020B0604030504040204" pitchFamily="34" charset="-128"/>
+                <a:ea typeface="Meiryo" panose="020B0604030504040204" pitchFamily="34" charset="-128"/>
+              </a:rPr>
+              <a:t>アプリにし</a:t>
+            </a:r>
+            <a:endParaRPr lang="en-US" altLang="ja-JP" sz="1000" dirty="0">
+              <a:latin typeface="Meiryo" panose="020B0604030504040204" pitchFamily="34" charset="-128"/>
+              <a:ea typeface="Meiryo" panose="020B0604030504040204" pitchFamily="34" charset="-128"/>
+            </a:endParaRPr>
+          </a:p>
+          <a:p>
+            <a:r>
+              <a:rPr lang="ja-JP" altLang="en-US" sz="1000">
+                <a:latin typeface="Meiryo" panose="020B0604030504040204" pitchFamily="34" charset="-128"/>
+                <a:ea typeface="Meiryo" panose="020B0604030504040204" pitchFamily="34" charset="-128"/>
+              </a:rPr>
+              <a:t>ようと決心するほどのロジックと出来上がりでした。</a:t>
+            </a:r>
+            <a:endParaRPr lang="en-US" altLang="ja-JP" sz="1000" dirty="0">
+              <a:latin typeface="Meiryo" panose="020B0604030504040204" pitchFamily="34" charset="-128"/>
+              <a:ea typeface="Meiryo" panose="020B0604030504040204" pitchFamily="34" charset="-128"/>
+            </a:endParaRPr>
+          </a:p>
+          <a:p>
+            <a:r>
+              <a:rPr lang="en-US" altLang="ja-JP" sz="1000" dirty="0">
+                <a:latin typeface="Meiryo" panose="020B0604030504040204" pitchFamily="34" charset="-128"/>
+                <a:ea typeface="Meiryo" panose="020B0604030504040204" pitchFamily="34" charset="-128"/>
+              </a:rPr>
+              <a:t>Excel</a:t>
+            </a:r>
+            <a:r>
+              <a:rPr lang="ja-JP" altLang="en-US" sz="1000">
+                <a:latin typeface="Meiryo" panose="020B0604030504040204" pitchFamily="34" charset="-128"/>
+                <a:ea typeface="Meiryo" panose="020B0604030504040204" pitchFamily="34" charset="-128"/>
+              </a:rPr>
+              <a:t>や</a:t>
+            </a:r>
+            <a:r>
+              <a:rPr lang="en-US" altLang="ja-JP" sz="1000" dirty="0">
+                <a:latin typeface="Meiryo" panose="020B0604030504040204" pitchFamily="34" charset="-128"/>
+                <a:ea typeface="Meiryo" panose="020B0604030504040204" pitchFamily="34" charset="-128"/>
+              </a:rPr>
+              <a:t>Google Spread Sheet</a:t>
+            </a:r>
+            <a:r>
+              <a:rPr lang="ja-JP" altLang="en-US" sz="1000">
+                <a:latin typeface="Meiryo" panose="020B0604030504040204" pitchFamily="34" charset="-128"/>
+                <a:ea typeface="Meiryo" panose="020B0604030504040204" pitchFamily="34" charset="-128"/>
+              </a:rPr>
+              <a:t>は汎用性が高く、視認性</a:t>
+            </a:r>
+            <a:r>
+              <a:rPr lang="en-US" altLang="ja-JP" sz="1000" dirty="0">
+                <a:latin typeface="Meiryo" panose="020B0604030504040204" pitchFamily="34" charset="-128"/>
+                <a:ea typeface="Meiryo" panose="020B0604030504040204" pitchFamily="34" charset="-128"/>
+              </a:rPr>
+              <a:t>(UI/UX)</a:t>
+            </a:r>
+            <a:r>
+              <a:rPr lang="ja-JP" altLang="en-US" sz="1000">
+                <a:latin typeface="Meiryo" panose="020B0604030504040204" pitchFamily="34" charset="-128"/>
+                <a:ea typeface="Meiryo" panose="020B0604030504040204" pitchFamily="34" charset="-128"/>
+              </a:rPr>
+              <a:t>が悪く作り手の意味を理解しなと使いこなせない現象が起こりやすいです。いわゆる勉強が必要ということです。</a:t>
+            </a:r>
+            <a:endParaRPr lang="en-US" altLang="ja-JP" sz="1000" dirty="0">
+              <a:latin typeface="Meiryo" panose="020B0604030504040204" pitchFamily="34" charset="-128"/>
+              <a:ea typeface="Meiryo" panose="020B0604030504040204" pitchFamily="34" charset="-128"/>
+            </a:endParaRPr>
+          </a:p>
+          <a:p>
+            <a:r>
+              <a:rPr lang="ja-JP" altLang="en-US" sz="1000">
+                <a:latin typeface="Meiryo" panose="020B0604030504040204" pitchFamily="34" charset="-128"/>
+                <a:ea typeface="Meiryo" panose="020B0604030504040204" pitchFamily="34" charset="-128"/>
+              </a:rPr>
+              <a:t>自分は</a:t>
+            </a:r>
+            <a:r>
+              <a:rPr lang="en-US" altLang="ja-JP" sz="1000" dirty="0">
+                <a:latin typeface="Meiryo" panose="020B0604030504040204" pitchFamily="34" charset="-128"/>
+                <a:ea typeface="Meiryo" panose="020B0604030504040204" pitchFamily="34" charset="-128"/>
+              </a:rPr>
+              <a:t>IT</a:t>
+            </a:r>
+            <a:r>
+              <a:rPr lang="ja-JP" altLang="en-US" sz="1000">
+                <a:latin typeface="Meiryo" panose="020B0604030504040204" pitchFamily="34" charset="-128"/>
+                <a:ea typeface="Meiryo" panose="020B0604030504040204" pitchFamily="34" charset="-128"/>
+              </a:rPr>
+              <a:t>系が大好きで、同時に飲食店の広報として現場に立ちながら</a:t>
+            </a:r>
+            <a:r>
+              <a:rPr lang="en-US" altLang="ja-JP" sz="1000" dirty="0">
+                <a:latin typeface="Meiryo" panose="020B0604030504040204" pitchFamily="34" charset="-128"/>
+                <a:ea typeface="Meiryo" panose="020B0604030504040204" pitchFamily="34" charset="-128"/>
+              </a:rPr>
+              <a:t>SNS</a:t>
+            </a:r>
+            <a:r>
+              <a:rPr lang="ja-JP" altLang="en-US" sz="1000">
+                <a:latin typeface="Meiryo" panose="020B0604030504040204" pitchFamily="34" charset="-128"/>
+                <a:ea typeface="Meiryo" panose="020B0604030504040204" pitchFamily="34" charset="-128"/>
+              </a:rPr>
+              <a:t>や</a:t>
+            </a:r>
+            <a:r>
+              <a:rPr lang="en-US" altLang="ja-JP" sz="1000" dirty="0">
+                <a:latin typeface="Meiryo" panose="020B0604030504040204" pitchFamily="34" charset="-128"/>
+                <a:ea typeface="Meiryo" panose="020B0604030504040204" pitchFamily="34" charset="-128"/>
+              </a:rPr>
+              <a:t>Web</a:t>
+            </a:r>
+            <a:r>
+              <a:rPr lang="ja-JP" altLang="en-US" sz="1000">
+                <a:latin typeface="Meiryo" panose="020B0604030504040204" pitchFamily="34" charset="-128"/>
+                <a:ea typeface="Meiryo" panose="020B0604030504040204" pitchFamily="34" charset="-128"/>
+              </a:rPr>
+              <a:t>サイト構築などに従事してきました、来店方ビジネスの特徴として現場スタッフは日々多忙を極めており、拘束時間も長い中、新しいシステム導入の際に勉強や慣れるなどのフェーズは極めてストレスを感じアレルギー反応を起こします。</a:t>
+            </a:r>
+            <a:endParaRPr lang="en-US" altLang="ja-JP" sz="1000" dirty="0">
+              <a:latin typeface="Meiryo" panose="020B0604030504040204" pitchFamily="34" charset="-128"/>
+              <a:ea typeface="Meiryo" panose="020B0604030504040204" pitchFamily="34" charset="-128"/>
+            </a:endParaRPr>
+          </a:p>
+          <a:p>
+            <a:r>
+              <a:rPr lang="ja-JP" altLang="en-US" sz="1000">
+                <a:latin typeface="Meiryo" panose="020B0604030504040204" pitchFamily="34" charset="-128"/>
+                <a:ea typeface="Meiryo" panose="020B0604030504040204" pitchFamily="34" charset="-128"/>
+              </a:rPr>
+              <a:t>自分手動で</a:t>
+            </a:r>
+            <a:r>
+              <a:rPr lang="en-US" altLang="ja-JP" sz="1000" dirty="0">
+                <a:latin typeface="Meiryo" panose="020B0604030504040204" pitchFamily="34" charset="-128"/>
+                <a:ea typeface="Meiryo" panose="020B0604030504040204" pitchFamily="34" charset="-128"/>
+              </a:rPr>
+              <a:t>Web</a:t>
+            </a:r>
+            <a:r>
+              <a:rPr lang="ja-JP" altLang="en-US" sz="1000">
+                <a:latin typeface="Meiryo" panose="020B0604030504040204" pitchFamily="34" charset="-128"/>
+                <a:ea typeface="Meiryo" panose="020B0604030504040204" pitchFamily="34" charset="-128"/>
+              </a:rPr>
+              <a:t>予約システム、</a:t>
+            </a:r>
+            <a:r>
+              <a:rPr lang="en-US" altLang="ja-JP" sz="1000" dirty="0">
+                <a:latin typeface="Meiryo" panose="020B0604030504040204" pitchFamily="34" charset="-128"/>
+                <a:ea typeface="Meiryo" panose="020B0604030504040204" pitchFamily="34" charset="-128"/>
+              </a:rPr>
+              <a:t>Table Check</a:t>
+            </a:r>
+            <a:r>
+              <a:rPr lang="ja-JP" altLang="en-US" sz="1000">
+                <a:latin typeface="Meiryo" panose="020B0604030504040204" pitchFamily="34" charset="-128"/>
+                <a:ea typeface="Meiryo" panose="020B0604030504040204" pitchFamily="34" charset="-128"/>
+              </a:rPr>
+              <a:t>を導入しましたが、</a:t>
+            </a:r>
+            <a:r>
+              <a:rPr lang="en-US" altLang="ja-JP" sz="1000" dirty="0">
+                <a:latin typeface="Meiryo" panose="020B0604030504040204" pitchFamily="34" charset="-128"/>
+                <a:ea typeface="Meiryo" panose="020B0604030504040204" pitchFamily="34" charset="-128"/>
+              </a:rPr>
+              <a:t>UI/UX</a:t>
+            </a:r>
+            <a:r>
+              <a:rPr lang="ja-JP" altLang="en-US" sz="1000">
+                <a:latin typeface="Meiryo" panose="020B0604030504040204" pitchFamily="34" charset="-128"/>
+                <a:ea typeface="Meiryo" panose="020B0604030504040204" pitchFamily="34" charset="-128"/>
+              </a:rPr>
+              <a:t>使用感が悪く、自分もかなり勉強や慣れのためにいじってはいるのですが、以前としてヘルプデスクやヘルプ</a:t>
+            </a:r>
+            <a:r>
+              <a:rPr lang="en-US" altLang="ja-JP" sz="1000" dirty="0">
+                <a:latin typeface="Meiryo" panose="020B0604030504040204" pitchFamily="34" charset="-128"/>
+                <a:ea typeface="Meiryo" panose="020B0604030504040204" pitchFamily="34" charset="-128"/>
+              </a:rPr>
+              <a:t>LINE</a:t>
+            </a:r>
+            <a:r>
+              <a:rPr lang="ja-JP" altLang="en-US" sz="1000">
+                <a:latin typeface="Meiryo" panose="020B0604030504040204" pitchFamily="34" charset="-128"/>
+                <a:ea typeface="Meiryo" panose="020B0604030504040204" pitchFamily="34" charset="-128"/>
+              </a:rPr>
+              <a:t>での質問が必要でストレスを感じ、流石にこれは理解してもらうや、浸透するまでに時間がかかるなと感じました。</a:t>
+            </a:r>
+            <a:endParaRPr lang="en-US" altLang="ja-JP" sz="1000" dirty="0">
+              <a:latin typeface="Meiryo" panose="020B0604030504040204" pitchFamily="34" charset="-128"/>
+              <a:ea typeface="Meiryo" panose="020B0604030504040204" pitchFamily="34" charset="-128"/>
+            </a:endParaRPr>
+          </a:p>
+          <a:p>
+            <a:r>
+              <a:rPr lang="ja-JP" altLang="en-US" sz="1000">
+                <a:latin typeface="Meiryo" panose="020B0604030504040204" pitchFamily="34" charset="-128"/>
+                <a:ea typeface="Meiryo" panose="020B0604030504040204" pitchFamily="34" charset="-128"/>
+              </a:rPr>
+              <a:t>この体験から</a:t>
+            </a:r>
+            <a:r>
+              <a:rPr lang="en-US" altLang="ja-JP" sz="1000" dirty="0">
+                <a:latin typeface="Meiryo" panose="020B0604030504040204" pitchFamily="34" charset="-128"/>
+                <a:ea typeface="Meiryo" panose="020B0604030504040204" pitchFamily="34" charset="-128"/>
+              </a:rPr>
+              <a:t>UI/UX</a:t>
+            </a:r>
+            <a:r>
+              <a:rPr lang="ja-JP" altLang="en-US" sz="1000">
+                <a:latin typeface="Meiryo" panose="020B0604030504040204" pitchFamily="34" charset="-128"/>
+                <a:ea typeface="Meiryo" panose="020B0604030504040204" pitchFamily="34" charset="-128"/>
+              </a:rPr>
+              <a:t>の重要性を考える様になり、汎用性の低い</a:t>
+            </a:r>
+            <a:r>
+              <a:rPr lang="en-US" altLang="ja-JP" sz="1000" dirty="0">
+                <a:latin typeface="Meiryo" panose="020B0604030504040204" pitchFamily="34" charset="-128"/>
+                <a:ea typeface="Meiryo" panose="020B0604030504040204" pitchFamily="34" charset="-128"/>
+              </a:rPr>
+              <a:t>Web</a:t>
+            </a:r>
+            <a:r>
+              <a:rPr lang="ja-JP" altLang="en-US" sz="1000">
+                <a:latin typeface="Meiryo" panose="020B0604030504040204" pitchFamily="34" charset="-128"/>
+                <a:ea typeface="Meiryo" panose="020B0604030504040204" pitchFamily="34" charset="-128"/>
+              </a:rPr>
+              <a:t>アプリの開発を考える様になりました。</a:t>
+            </a:r>
+          </a:p>
+        </p:txBody>
+      </p:sp>
+      <p:sp>
+        <p:nvSpPr>
+          <p:cNvPr id="6" name="テキスト ボックス 5">
+            <a:extLst>
+              <a:ext uri="{FF2B5EF4-FFF2-40B4-BE49-F238E27FC236}">
+                <a16:creationId xmlns:a16="http://schemas.microsoft.com/office/drawing/2014/main" id="{0DAAE186-AEC8-492E-A305-DE9B81703DC2}"/>
+              </a:ext>
+            </a:extLst>
+          </p:cNvPr>
+          <p:cNvSpPr txBox="1"/>
+          <p:nvPr/>
+        </p:nvSpPr>
+        <p:spPr>
+          <a:xfrm>
+            <a:off x="239615" y="548853"/>
+            <a:ext cx="1619354" cy="276999"/>
+          </a:xfrm>
+          <a:prstGeom prst="rect">
+            <a:avLst/>
+          </a:prstGeom>
+          <a:noFill/>
+        </p:spPr>
+        <p:txBody>
+          <a:bodyPr wrap="none" rtlCol="0">
+            <a:spAutoFit/>
+          </a:bodyPr>
+          <a:lstStyle/>
+          <a:p>
+            <a:r>
+              <a:rPr lang="en" altLang="ja-JP" sz="1200" dirty="0">
+                <a:latin typeface="Meiryo" panose="020B0604030504040204" pitchFamily="34" charset="-128"/>
+                <a:ea typeface="Meiryo" panose="020B0604030504040204" pitchFamily="34" charset="-128"/>
+              </a:rPr>
+              <a:t>1. </a:t>
+            </a:r>
+            <a:r>
+              <a:rPr lang="ja-JP" altLang="en-US" sz="1200">
+                <a:latin typeface="Meiryo" panose="020B0604030504040204" pitchFamily="34" charset="-128"/>
+                <a:ea typeface="Meiryo" panose="020B0604030504040204" pitchFamily="34" charset="-128"/>
+              </a:rPr>
+              <a:t>開発に至った経緯</a:t>
+            </a:r>
+            <a:endParaRPr lang="en-US" altLang="ja-JP" sz="1200" dirty="0">
+              <a:latin typeface="Meiryo" panose="020B0604030504040204" pitchFamily="34" charset="-128"/>
+              <a:ea typeface="Meiryo" panose="020B0604030504040204" pitchFamily="34" charset="-128"/>
+            </a:endParaRPr>
+          </a:p>
+        </p:txBody>
+      </p:sp>
+      <p:sp>
+        <p:nvSpPr>
+          <p:cNvPr id="7" name="テキスト ボックス 6">
+            <a:extLst>
+              <a:ext uri="{FF2B5EF4-FFF2-40B4-BE49-F238E27FC236}">
+                <a16:creationId xmlns:a16="http://schemas.microsoft.com/office/drawing/2014/main" id="{997AAE8A-3026-CF3E-9901-99FE98537790}"/>
+              </a:ext>
+            </a:extLst>
+          </p:cNvPr>
+          <p:cNvSpPr txBox="1"/>
+          <p:nvPr/>
+        </p:nvSpPr>
+        <p:spPr>
+          <a:xfrm>
+            <a:off x="239615" y="3459427"/>
+            <a:ext cx="1619354" cy="276999"/>
+          </a:xfrm>
+          <a:prstGeom prst="rect">
+            <a:avLst/>
+          </a:prstGeom>
+          <a:noFill/>
+        </p:spPr>
+        <p:txBody>
+          <a:bodyPr wrap="none" rtlCol="0">
+            <a:spAutoFit/>
+          </a:bodyPr>
+          <a:lstStyle/>
+          <a:p>
+            <a:r>
+              <a:rPr lang="en" altLang="ja-JP" sz="1200" dirty="0">
+                <a:latin typeface="Meiryo" panose="020B0604030504040204" pitchFamily="34" charset="-128"/>
+                <a:ea typeface="Meiryo" panose="020B0604030504040204" pitchFamily="34" charset="-128"/>
+              </a:rPr>
+              <a:t>2. </a:t>
+            </a:r>
+            <a:r>
+              <a:rPr lang="ja-JP" altLang="en-US" sz="1200">
+                <a:latin typeface="Meiryo" panose="020B0604030504040204" pitchFamily="34" charset="-128"/>
+                <a:ea typeface="Meiryo" panose="020B0604030504040204" pitchFamily="34" charset="-128"/>
+              </a:rPr>
+              <a:t>こだわりポイント</a:t>
+            </a:r>
+            <a:endParaRPr lang="en-US" altLang="ja-JP" sz="1200" dirty="0">
+              <a:latin typeface="Meiryo" panose="020B0604030504040204" pitchFamily="34" charset="-128"/>
+              <a:ea typeface="Meiryo" panose="020B0604030504040204" pitchFamily="34" charset="-128"/>
+            </a:endParaRPr>
+          </a:p>
+        </p:txBody>
+      </p:sp>
+      <p:sp>
+        <p:nvSpPr>
+          <p:cNvPr id="8" name="テキスト ボックス 7">
+            <a:extLst>
+              <a:ext uri="{FF2B5EF4-FFF2-40B4-BE49-F238E27FC236}">
+                <a16:creationId xmlns:a16="http://schemas.microsoft.com/office/drawing/2014/main" id="{8021F559-D715-9CA8-2932-3DD236363A7E}"/>
+              </a:ext>
+            </a:extLst>
+          </p:cNvPr>
+          <p:cNvSpPr txBox="1"/>
+          <p:nvPr/>
+        </p:nvSpPr>
+        <p:spPr>
+          <a:xfrm>
+            <a:off x="583198" y="3727534"/>
+            <a:ext cx="5709185" cy="1477328"/>
+          </a:xfrm>
+          <a:prstGeom prst="rect">
+            <a:avLst/>
+          </a:prstGeom>
+          <a:noFill/>
+        </p:spPr>
+        <p:txBody>
+          <a:bodyPr wrap="square" rtlCol="0">
+            <a:spAutoFit/>
+          </a:bodyPr>
+          <a:lstStyle/>
+          <a:p>
+            <a:r>
+              <a:rPr lang="ja-JP" altLang="en-US" sz="1000">
+                <a:latin typeface="Meiryo" panose="020B0604030504040204" pitchFamily="34" charset="-128"/>
+                <a:ea typeface="Meiryo" panose="020B0604030504040204" pitchFamily="34" charset="-128"/>
+              </a:rPr>
+              <a:t>・利用いただく方へ、そのお店の過去の売り上げデータから、根拠ある</a:t>
+            </a:r>
+            <a:r>
+              <a:rPr lang="en-US" altLang="ja-JP" sz="1000" dirty="0">
+                <a:latin typeface="Meiryo" panose="020B0604030504040204" pitchFamily="34" charset="-128"/>
+                <a:ea typeface="Meiryo" panose="020B0604030504040204" pitchFamily="34" charset="-128"/>
+              </a:rPr>
+              <a:t>KPI</a:t>
+            </a:r>
+            <a:r>
+              <a:rPr lang="ja-JP" altLang="en-US" sz="1000">
+                <a:latin typeface="Meiryo" panose="020B0604030504040204" pitchFamily="34" charset="-128"/>
+                <a:ea typeface="Meiryo" panose="020B0604030504040204" pitchFamily="34" charset="-128"/>
+              </a:rPr>
+              <a:t>を提供するが一番のこだわり機能</a:t>
+            </a:r>
+            <a:r>
+              <a:rPr lang="en-US" altLang="ja-JP" sz="1000" dirty="0">
+                <a:latin typeface="Meiryo" panose="020B0604030504040204" pitchFamily="34" charset="-128"/>
+                <a:ea typeface="Meiryo" panose="020B0604030504040204" pitchFamily="34" charset="-128"/>
+              </a:rPr>
+              <a:t>(</a:t>
+            </a:r>
+            <a:r>
+              <a:rPr lang="ja-JP" altLang="en-US" sz="1000">
+                <a:latin typeface="Meiryo" panose="020B0604030504040204" pitchFamily="34" charset="-128"/>
+                <a:ea typeface="Meiryo" panose="020B0604030504040204" pitchFamily="34" charset="-128"/>
+              </a:rPr>
+              <a:t>ツールを乗り換えてもらいたいので収支を記録する機能も搭載する→</a:t>
+            </a:r>
+            <a:r>
+              <a:rPr lang="en-US" altLang="ja-JP" sz="1000" dirty="0">
+                <a:latin typeface="Meiryo" panose="020B0604030504040204" pitchFamily="34" charset="-128"/>
+                <a:ea typeface="Meiryo" panose="020B0604030504040204" pitchFamily="34" charset="-128"/>
+              </a:rPr>
+              <a:t>PL</a:t>
+            </a:r>
+            <a:r>
+              <a:rPr lang="ja-JP" altLang="en-US" sz="1000">
+                <a:latin typeface="Meiryo" panose="020B0604030504040204" pitchFamily="34" charset="-128"/>
+                <a:ea typeface="Meiryo" panose="020B0604030504040204" pitchFamily="34" charset="-128"/>
+              </a:rPr>
+              <a:t>表自動作成</a:t>
+            </a:r>
+            <a:r>
+              <a:rPr lang="en-US" altLang="ja-JP" sz="1000" dirty="0">
+                <a:latin typeface="Meiryo" panose="020B0604030504040204" pitchFamily="34" charset="-128"/>
+                <a:ea typeface="Meiryo" panose="020B0604030504040204" pitchFamily="34" charset="-128"/>
+              </a:rPr>
+              <a:t>)</a:t>
+            </a:r>
+          </a:p>
+          <a:p>
+            <a:r>
+              <a:rPr lang="ja-JP" altLang="en-US" sz="1000">
+                <a:latin typeface="Meiryo" panose="020B0604030504040204" pitchFamily="34" charset="-128"/>
+                <a:ea typeface="Meiryo" panose="020B0604030504040204" pitchFamily="34" charset="-128"/>
+              </a:rPr>
+              <a:t>・</a:t>
+            </a:r>
+            <a:r>
+              <a:rPr lang="en-US" altLang="ja-JP" sz="1000" dirty="0">
+                <a:latin typeface="Meiryo" panose="020B0604030504040204" pitchFamily="34" charset="-128"/>
+                <a:ea typeface="Meiryo" panose="020B0604030504040204" pitchFamily="34" charset="-128"/>
+              </a:rPr>
+              <a:t>UI/UX</a:t>
+            </a:r>
+            <a:r>
+              <a:rPr lang="ja-JP" altLang="en-US" sz="1000">
+                <a:latin typeface="Meiryo" panose="020B0604030504040204" pitchFamily="34" charset="-128"/>
+                <a:ea typeface="Meiryo" panose="020B0604030504040204" pitchFamily="34" charset="-128"/>
+              </a:rPr>
+              <a:t>の簡略化、</a:t>
+            </a:r>
+            <a:r>
+              <a:rPr lang="en-US" altLang="ja-JP" sz="1000" dirty="0">
+                <a:latin typeface="Meiryo" panose="020B0604030504040204" pitchFamily="34" charset="-128"/>
+                <a:ea typeface="Meiryo" panose="020B0604030504040204" pitchFamily="34" charset="-128"/>
+              </a:rPr>
+              <a:t>Apple</a:t>
+            </a:r>
+            <a:r>
+              <a:rPr lang="ja-JP" altLang="en-US" sz="1000">
+                <a:latin typeface="Meiryo" panose="020B0604030504040204" pitchFamily="34" charset="-128"/>
+                <a:ea typeface="Meiryo" panose="020B0604030504040204" pitchFamily="34" charset="-128"/>
+              </a:rPr>
+              <a:t>製品をお手本とした説明書要らずの</a:t>
+            </a:r>
+            <a:r>
+              <a:rPr lang="en-US" altLang="ja-JP" sz="1000" dirty="0">
+                <a:latin typeface="Meiryo" panose="020B0604030504040204" pitchFamily="34" charset="-128"/>
+                <a:ea typeface="Meiryo" panose="020B0604030504040204" pitchFamily="34" charset="-128"/>
+              </a:rPr>
+              <a:t>UI</a:t>
+            </a:r>
+            <a:r>
+              <a:rPr lang="ja-JP" altLang="en-US" sz="1000">
+                <a:latin typeface="Meiryo" panose="020B0604030504040204" pitchFamily="34" charset="-128"/>
+                <a:ea typeface="Meiryo" panose="020B0604030504040204" pitchFamily="34" charset="-128"/>
+              </a:rPr>
+              <a:t>を目指したい</a:t>
+            </a:r>
+            <a:endParaRPr lang="en-US" altLang="ja-JP" sz="1000" dirty="0">
+              <a:latin typeface="Meiryo" panose="020B0604030504040204" pitchFamily="34" charset="-128"/>
+              <a:ea typeface="Meiryo" panose="020B0604030504040204" pitchFamily="34" charset="-128"/>
+            </a:endParaRPr>
+          </a:p>
+          <a:p>
+            <a:r>
+              <a:rPr lang="ja-JP" altLang="en-US" sz="1000">
+                <a:latin typeface="Meiryo" panose="020B0604030504040204" pitchFamily="34" charset="-128"/>
+                <a:ea typeface="Meiryo" panose="020B0604030504040204" pitchFamily="34" charset="-128"/>
+              </a:rPr>
+              <a:t>・攻殻機動隊好き、ビジネスシーンでも使ってもらえる程度の</a:t>
+            </a:r>
+            <a:r>
+              <a:rPr lang="en-US" altLang="ja-JP" sz="1000" dirty="0">
+                <a:latin typeface="Meiryo" panose="020B0604030504040204" pitchFamily="34" charset="-128"/>
+                <a:ea typeface="Meiryo" panose="020B0604030504040204" pitchFamily="34" charset="-128"/>
+              </a:rPr>
+              <a:t>Si-Fi</a:t>
+            </a:r>
+            <a:r>
+              <a:rPr lang="ja-JP" altLang="en-US" sz="1000">
+                <a:latin typeface="Meiryo" panose="020B0604030504040204" pitchFamily="34" charset="-128"/>
+                <a:ea typeface="Meiryo" panose="020B0604030504040204" pitchFamily="34" charset="-128"/>
+              </a:rPr>
+              <a:t>要素を散りばめたい</a:t>
+            </a:r>
+            <a:endParaRPr lang="en-US" altLang="ja-JP" sz="1000" dirty="0">
+              <a:latin typeface="Meiryo" panose="020B0604030504040204" pitchFamily="34" charset="-128"/>
+              <a:ea typeface="Meiryo" panose="020B0604030504040204" pitchFamily="34" charset="-128"/>
+            </a:endParaRPr>
+          </a:p>
+          <a:p>
+            <a:r>
+              <a:rPr lang="ja-JP" altLang="en-US" sz="1000">
+                <a:latin typeface="Meiryo" panose="020B0604030504040204" pitchFamily="34" charset="-128"/>
+                <a:ea typeface="Meiryo" panose="020B0604030504040204" pitchFamily="34" charset="-128"/>
+              </a:rPr>
+              <a:t>・アニメーション的動きを導入して視覚的に</a:t>
+            </a:r>
+            <a:r>
+              <a:rPr lang="en-US" altLang="ja-JP" sz="1000" dirty="0">
+                <a:latin typeface="Meiryo" panose="020B0604030504040204" pitchFamily="34" charset="-128"/>
+                <a:ea typeface="Meiryo" panose="020B0604030504040204" pitchFamily="34" charset="-128"/>
+              </a:rPr>
+              <a:t>『</a:t>
+            </a:r>
+            <a:r>
+              <a:rPr lang="ja-JP" altLang="en-US" sz="1000">
+                <a:latin typeface="Meiryo" panose="020B0604030504040204" pitchFamily="34" charset="-128"/>
+                <a:ea typeface="Meiryo" panose="020B0604030504040204" pitchFamily="34" charset="-128"/>
+              </a:rPr>
+              <a:t>触って楽しい</a:t>
+            </a:r>
+            <a:r>
+              <a:rPr lang="en-US" altLang="ja-JP" sz="1000" dirty="0">
+                <a:latin typeface="Meiryo" panose="020B0604030504040204" pitchFamily="34" charset="-128"/>
+                <a:ea typeface="Meiryo" panose="020B0604030504040204" pitchFamily="34" charset="-128"/>
+              </a:rPr>
+              <a:t>』</a:t>
+            </a:r>
+            <a:r>
+              <a:rPr lang="ja-JP" altLang="en-US" sz="1000">
+                <a:latin typeface="Meiryo" panose="020B0604030504040204" pitchFamily="34" charset="-128"/>
+                <a:ea typeface="Meiryo" panose="020B0604030504040204" pitchFamily="34" charset="-128"/>
+              </a:rPr>
+              <a:t>を経験してもらいたい</a:t>
+            </a:r>
+            <a:endParaRPr lang="en-US" altLang="ja-JP" sz="1000" dirty="0">
+              <a:latin typeface="Meiryo" panose="020B0604030504040204" pitchFamily="34" charset="-128"/>
+              <a:ea typeface="Meiryo" panose="020B0604030504040204" pitchFamily="34" charset="-128"/>
+            </a:endParaRPr>
+          </a:p>
+          <a:p>
+            <a:r>
+              <a:rPr lang="ja-JP" altLang="en-US" sz="1000">
+                <a:latin typeface="Meiryo" panose="020B0604030504040204" pitchFamily="34" charset="-128"/>
+                <a:ea typeface="Meiryo" panose="020B0604030504040204" pitchFamily="34" charset="-128"/>
+              </a:rPr>
+              <a:t>・昔の</a:t>
+            </a:r>
+            <a:r>
+              <a:rPr lang="en-US" altLang="ja-JP" sz="1000" dirty="0">
+                <a:latin typeface="Meiryo" panose="020B0604030504040204" pitchFamily="34" charset="-128"/>
+                <a:ea typeface="Meiryo" panose="020B0604030504040204" pitchFamily="34" charset="-128"/>
+              </a:rPr>
+              <a:t>iPod</a:t>
+            </a:r>
+            <a:r>
+              <a:rPr lang="ja-JP" altLang="en-US" sz="1000">
+                <a:latin typeface="Meiryo" panose="020B0604030504040204" pitchFamily="34" charset="-128"/>
+                <a:ea typeface="Meiryo" panose="020B0604030504040204" pitchFamily="34" charset="-128"/>
+              </a:rPr>
+              <a:t>のホイールクリック音を使いたい</a:t>
+            </a:r>
+            <a:r>
+              <a:rPr lang="en-US" altLang="ja-JP" sz="1000" dirty="0">
+                <a:latin typeface="Meiryo" panose="020B0604030504040204" pitchFamily="34" charset="-128"/>
+                <a:ea typeface="Meiryo" panose="020B0604030504040204" pitchFamily="34" charset="-128"/>
+              </a:rPr>
+              <a:t>(</a:t>
+            </a:r>
+            <a:r>
+              <a:rPr lang="ja-JP" altLang="en-US" sz="1000">
+                <a:latin typeface="Meiryo" panose="020B0604030504040204" pitchFamily="34" charset="-128"/>
+                <a:ea typeface="Meiryo" panose="020B0604030504040204" pitchFamily="34" charset="-128"/>
+              </a:rPr>
+              <a:t>眼鏡</a:t>
+            </a:r>
+            <a:r>
+              <a:rPr lang="en-US" altLang="ja-JP" sz="1000" dirty="0">
+                <a:latin typeface="Meiryo" panose="020B0604030504040204" pitchFamily="34" charset="-128"/>
+                <a:ea typeface="Meiryo" panose="020B0604030504040204" pitchFamily="34" charset="-128"/>
+              </a:rPr>
+              <a:t>Bar</a:t>
+            </a:r>
+            <a:r>
+              <a:rPr lang="ja-JP" altLang="en-US" sz="1000">
+                <a:latin typeface="Meiryo" panose="020B0604030504040204" pitchFamily="34" charset="-128"/>
+                <a:ea typeface="Meiryo" panose="020B0604030504040204" pitchFamily="34" charset="-128"/>
+              </a:rPr>
+              <a:t>：後ほど説明</a:t>
+            </a:r>
+            <a:r>
+              <a:rPr lang="en-US" altLang="ja-JP" sz="1000" dirty="0">
+                <a:latin typeface="Meiryo" panose="020B0604030504040204" pitchFamily="34" charset="-128"/>
+                <a:ea typeface="Meiryo" panose="020B0604030504040204" pitchFamily="34" charset="-128"/>
+              </a:rPr>
+              <a:t>)</a:t>
+            </a:r>
+          </a:p>
+          <a:p>
+            <a:r>
+              <a:rPr lang="ja-JP" altLang="en-US" sz="1000">
+                <a:latin typeface="Meiryo" panose="020B0604030504040204" pitchFamily="34" charset="-128"/>
+                <a:ea typeface="Meiryo" panose="020B0604030504040204" pitchFamily="34" charset="-128"/>
+              </a:rPr>
+              <a:t>・ローディング時なのか、利用者に何かを待ってもらう時は</a:t>
+            </a:r>
+            <a:r>
+              <a:rPr lang="en-US" altLang="ja-JP" sz="1000" dirty="0">
+                <a:latin typeface="Meiryo" panose="020B0604030504040204" pitchFamily="34" charset="-128"/>
+                <a:ea typeface="Meiryo" panose="020B0604030504040204" pitchFamily="34" charset="-128"/>
+              </a:rPr>
+              <a:t>『</a:t>
+            </a:r>
+            <a:r>
+              <a:rPr lang="ja-JP" altLang="en-US" sz="1000">
+                <a:latin typeface="Meiryo" panose="020B0604030504040204" pitchFamily="34" charset="-128"/>
+                <a:ea typeface="Meiryo" panose="020B0604030504040204" pitchFamily="34" charset="-128"/>
+              </a:rPr>
+              <a:t>タチコマの目</a:t>
+            </a:r>
+            <a:r>
+              <a:rPr lang="en-US" altLang="ja-JP" sz="1000" dirty="0">
+                <a:latin typeface="Meiryo" panose="020B0604030504040204" pitchFamily="34" charset="-128"/>
+                <a:ea typeface="Meiryo" panose="020B0604030504040204" pitchFamily="34" charset="-128"/>
+              </a:rPr>
+              <a:t>』</a:t>
+            </a:r>
+            <a:r>
+              <a:rPr lang="ja-JP" altLang="en-US" sz="1000">
+                <a:latin typeface="Meiryo" panose="020B0604030504040204" pitchFamily="34" charset="-128"/>
+                <a:ea typeface="Meiryo" panose="020B0604030504040204" pitchFamily="34" charset="-128"/>
+              </a:rPr>
+              <a:t>が</a:t>
+            </a:r>
+            <a:r>
+              <a:rPr lang="en-US" altLang="ja-JP" sz="1000" dirty="0">
+                <a:latin typeface="Meiryo" panose="020B0604030504040204" pitchFamily="34" charset="-128"/>
+                <a:ea typeface="Meiryo" panose="020B0604030504040204" pitchFamily="34" charset="-128"/>
+              </a:rPr>
+              <a:t>X</a:t>
+            </a:r>
+            <a:r>
+              <a:rPr lang="ja-JP" altLang="en-US" sz="1000">
+                <a:latin typeface="Meiryo" panose="020B0604030504040204" pitchFamily="34" charset="-128"/>
+                <a:ea typeface="Meiryo" panose="020B0604030504040204" pitchFamily="34" charset="-128"/>
+              </a:rPr>
+              <a:t>軸、</a:t>
+            </a:r>
+            <a:r>
+              <a:rPr lang="en-US" altLang="ja-JP" sz="1000" dirty="0">
+                <a:latin typeface="Meiryo" panose="020B0604030504040204" pitchFamily="34" charset="-128"/>
+                <a:ea typeface="Meiryo" panose="020B0604030504040204" pitchFamily="34" charset="-128"/>
+              </a:rPr>
+              <a:t>Y</a:t>
+            </a:r>
+            <a:r>
+              <a:rPr lang="ja-JP" altLang="en-US" sz="1000">
+                <a:latin typeface="Meiryo" panose="020B0604030504040204" pitchFamily="34" charset="-128"/>
+                <a:ea typeface="Meiryo" panose="020B0604030504040204" pitchFamily="34" charset="-128"/>
+              </a:rPr>
+              <a:t>軸、</a:t>
+            </a:r>
+            <a:r>
+              <a:rPr lang="en-US" altLang="ja-JP" sz="1000" dirty="0">
+                <a:latin typeface="Meiryo" panose="020B0604030504040204" pitchFamily="34" charset="-128"/>
+                <a:ea typeface="Meiryo" panose="020B0604030504040204" pitchFamily="34" charset="-128"/>
+              </a:rPr>
+              <a:t>Z</a:t>
+            </a:r>
+            <a:r>
+              <a:rPr lang="ja-JP" altLang="en-US" sz="1000">
+                <a:latin typeface="Meiryo" panose="020B0604030504040204" pitchFamily="34" charset="-128"/>
+                <a:ea typeface="Meiryo" panose="020B0604030504040204" pitchFamily="34" charset="-128"/>
+              </a:rPr>
+              <a:t>軸でくるくるランダムに回る</a:t>
+            </a:r>
+            <a:endParaRPr lang="en-US" altLang="ja-JP" sz="1000" dirty="0">
+              <a:latin typeface="Meiryo" panose="020B0604030504040204" pitchFamily="34" charset="-128"/>
+              <a:ea typeface="Meiryo" panose="020B0604030504040204" pitchFamily="34" charset="-128"/>
+            </a:endParaRPr>
+          </a:p>
+        </p:txBody>
+      </p:sp>
+      <p:sp>
+        <p:nvSpPr>
+          <p:cNvPr id="9" name="テキスト ボックス 8">
+            <a:extLst>
+              <a:ext uri="{FF2B5EF4-FFF2-40B4-BE49-F238E27FC236}">
+                <a16:creationId xmlns:a16="http://schemas.microsoft.com/office/drawing/2014/main" id="{71C73791-B711-E028-1E7C-96F1541C871D}"/>
+              </a:ext>
+            </a:extLst>
+          </p:cNvPr>
+          <p:cNvSpPr txBox="1"/>
+          <p:nvPr/>
+        </p:nvSpPr>
+        <p:spPr>
+          <a:xfrm>
+            <a:off x="239615" y="5250496"/>
+            <a:ext cx="1003801" cy="276999"/>
+          </a:xfrm>
+          <a:prstGeom prst="rect">
+            <a:avLst/>
+          </a:prstGeom>
+          <a:noFill/>
+        </p:spPr>
+        <p:txBody>
+          <a:bodyPr wrap="none" rtlCol="0">
+            <a:spAutoFit/>
+          </a:bodyPr>
+          <a:lstStyle/>
+          <a:p>
+            <a:r>
+              <a:rPr lang="en" altLang="ja-JP" sz="1200" dirty="0">
+                <a:latin typeface="Meiryo" panose="020B0604030504040204" pitchFamily="34" charset="-128"/>
+                <a:ea typeface="Meiryo" panose="020B0604030504040204" pitchFamily="34" charset="-128"/>
+              </a:rPr>
+              <a:t>3. </a:t>
+            </a:r>
+            <a:r>
+              <a:rPr lang="ja-JP" altLang="en-US" sz="1200">
+                <a:latin typeface="Meiryo" panose="020B0604030504040204" pitchFamily="34" charset="-128"/>
+                <a:ea typeface="Meiryo" panose="020B0604030504040204" pitchFamily="34" charset="-128"/>
+              </a:rPr>
+              <a:t>機能説明</a:t>
+            </a:r>
+            <a:endParaRPr lang="en-US" altLang="ja-JP" sz="1200" dirty="0">
+              <a:latin typeface="Meiryo" panose="020B0604030504040204" pitchFamily="34" charset="-128"/>
+              <a:ea typeface="Meiryo" panose="020B0604030504040204" pitchFamily="34" charset="-128"/>
+            </a:endParaRPr>
+          </a:p>
+        </p:txBody>
+      </p:sp>
+      <p:sp>
+        <p:nvSpPr>
+          <p:cNvPr id="10" name="テキスト ボックス 9">
+            <a:extLst>
+              <a:ext uri="{FF2B5EF4-FFF2-40B4-BE49-F238E27FC236}">
+                <a16:creationId xmlns:a16="http://schemas.microsoft.com/office/drawing/2014/main" id="{3A515E39-5D83-974D-39AA-B3F7104DD5EF}"/>
+              </a:ext>
+            </a:extLst>
+          </p:cNvPr>
+          <p:cNvSpPr txBox="1"/>
+          <p:nvPr/>
+        </p:nvSpPr>
+        <p:spPr>
+          <a:xfrm>
+            <a:off x="583198" y="5509811"/>
+            <a:ext cx="5709185" cy="4247317"/>
+          </a:xfrm>
+          <a:prstGeom prst="rect">
+            <a:avLst/>
+          </a:prstGeom>
+          <a:noFill/>
+        </p:spPr>
+        <p:txBody>
+          <a:bodyPr wrap="square" rtlCol="0">
+            <a:spAutoFit/>
+          </a:bodyPr>
+          <a:lstStyle/>
+          <a:p>
+            <a:r>
+              <a:rPr lang="ja-JP" altLang="en-US" sz="1000">
+                <a:latin typeface="Meiryo" panose="020B0604030504040204" pitchFamily="34" charset="-128"/>
+                <a:ea typeface="Meiryo" panose="020B0604030504040204" pitchFamily="34" charset="-128"/>
+              </a:rPr>
+              <a:t>・今年の</a:t>
+            </a:r>
+            <a:r>
+              <a:rPr lang="en-US" altLang="ja-JP" sz="1000" dirty="0">
+                <a:latin typeface="Meiryo" panose="020B0604030504040204" pitchFamily="34" charset="-128"/>
+                <a:ea typeface="Meiryo" panose="020B0604030504040204" pitchFamily="34" charset="-128"/>
+              </a:rPr>
+              <a:t>KPI</a:t>
+            </a:r>
+            <a:r>
+              <a:rPr lang="ja-JP" altLang="en-US" sz="1000">
+                <a:latin typeface="Meiryo" panose="020B0604030504040204" pitchFamily="34" charset="-128"/>
+                <a:ea typeface="Meiryo" panose="020B0604030504040204" pitchFamily="34" charset="-128"/>
+              </a:rPr>
+              <a:t>設定方法</a:t>
+            </a:r>
+            <a:endParaRPr lang="en-US" altLang="ja-JP" sz="1000" dirty="0">
+              <a:latin typeface="Meiryo" panose="020B0604030504040204" pitchFamily="34" charset="-128"/>
+              <a:ea typeface="Meiryo" panose="020B0604030504040204" pitchFamily="34" charset="-128"/>
+            </a:endParaRPr>
+          </a:p>
+          <a:p>
+            <a:pPr marL="228600" indent="-228600">
+              <a:buAutoNum type="arabicPeriod"/>
+            </a:pPr>
+            <a:r>
+              <a:rPr lang="ja-JP" altLang="en-US" sz="1000">
+                <a:latin typeface="Meiryo" panose="020B0604030504040204" pitchFamily="34" charset="-128"/>
+                <a:ea typeface="Meiryo" panose="020B0604030504040204" pitchFamily="34" charset="-128"/>
+              </a:rPr>
+              <a:t>前年の日次の売上額を入力</a:t>
+            </a:r>
+            <a:endParaRPr lang="en-US" altLang="ja-JP" sz="1000" dirty="0">
+              <a:latin typeface="Meiryo" panose="020B0604030504040204" pitchFamily="34" charset="-128"/>
+              <a:ea typeface="Meiryo" panose="020B0604030504040204" pitchFamily="34" charset="-128"/>
+            </a:endParaRPr>
+          </a:p>
+          <a:p>
+            <a:pPr marL="228600" indent="-228600">
+              <a:buAutoNum type="arabicPeriod"/>
+            </a:pPr>
+            <a:r>
+              <a:rPr lang="ja-JP" altLang="en-US" sz="1000">
+                <a:latin typeface="Meiryo" panose="020B0604030504040204" pitchFamily="34" charset="-128"/>
+                <a:ea typeface="Meiryo" panose="020B0604030504040204" pitchFamily="34" charset="-128"/>
+              </a:rPr>
+              <a:t>前年の年次の総売上を把握</a:t>
+            </a:r>
+            <a:endParaRPr lang="en-US" altLang="ja-JP" sz="1000" dirty="0">
+              <a:latin typeface="Meiryo" panose="020B0604030504040204" pitchFamily="34" charset="-128"/>
+              <a:ea typeface="Meiryo" panose="020B0604030504040204" pitchFamily="34" charset="-128"/>
+            </a:endParaRPr>
+          </a:p>
+          <a:p>
+            <a:pPr marL="228600" indent="-228600">
+              <a:buAutoNum type="arabicPeriod"/>
+            </a:pPr>
+            <a:r>
+              <a:rPr lang="ja-JP" altLang="en-US" sz="1000">
+                <a:latin typeface="Meiryo" panose="020B0604030504040204" pitchFamily="34" charset="-128"/>
+                <a:ea typeface="Meiryo" panose="020B0604030504040204" pitchFamily="34" charset="-128"/>
+              </a:rPr>
+              <a:t>前年の総営業日数を設定・算出</a:t>
+            </a:r>
+            <a:endParaRPr lang="en-US" altLang="ja-JP" sz="1000" dirty="0">
+              <a:latin typeface="Meiryo" panose="020B0604030504040204" pitchFamily="34" charset="-128"/>
+              <a:ea typeface="Meiryo" panose="020B0604030504040204" pitchFamily="34" charset="-128"/>
+            </a:endParaRPr>
+          </a:p>
+          <a:p>
+            <a:pPr marL="228600" indent="-228600">
+              <a:buAutoNum type="arabicPeriod"/>
+            </a:pPr>
+            <a:r>
+              <a:rPr lang="ja-JP" altLang="en-US" sz="1000">
+                <a:latin typeface="Meiryo" panose="020B0604030504040204" pitchFamily="34" charset="-128"/>
+                <a:ea typeface="Meiryo" panose="020B0604030504040204" pitchFamily="34" charset="-128"/>
+              </a:rPr>
+              <a:t>営業日を月次に振り分ける→月次の営業日数算出</a:t>
+            </a:r>
+            <a:endParaRPr lang="en-US" altLang="ja-JP" sz="1000" dirty="0">
+              <a:latin typeface="Meiryo" panose="020B0604030504040204" pitchFamily="34" charset="-128"/>
+              <a:ea typeface="Meiryo" panose="020B0604030504040204" pitchFamily="34" charset="-128"/>
+            </a:endParaRPr>
+          </a:p>
+          <a:p>
+            <a:pPr marL="228600" indent="-228600">
+              <a:buAutoNum type="arabicPeriod"/>
+            </a:pPr>
+            <a:r>
+              <a:rPr lang="en-US" altLang="ja-JP" sz="1000" dirty="0">
+                <a:latin typeface="Meiryo" panose="020B0604030504040204" pitchFamily="34" charset="-128"/>
+                <a:ea typeface="Meiryo" panose="020B0604030504040204" pitchFamily="34" charset="-128"/>
+              </a:rPr>
+              <a:t>2</a:t>
+            </a:r>
+            <a:r>
+              <a:rPr lang="ja-JP" altLang="en-US" sz="1000">
+                <a:latin typeface="Meiryo" panose="020B0604030504040204" pitchFamily="34" charset="-128"/>
+                <a:ea typeface="Meiryo" panose="020B0604030504040204" pitchFamily="34" charset="-128"/>
+              </a:rPr>
+              <a:t>で出た前年総売上を前年総営業日数で割り、日次平均売上額を算出</a:t>
+            </a:r>
+            <a:endParaRPr lang="en-US" altLang="ja-JP" sz="1000" dirty="0">
+              <a:latin typeface="Meiryo" panose="020B0604030504040204" pitchFamily="34" charset="-128"/>
+              <a:ea typeface="Meiryo" panose="020B0604030504040204" pitchFamily="34" charset="-128"/>
+            </a:endParaRPr>
+          </a:p>
+          <a:p>
+            <a:pPr marL="228600" indent="-228600">
+              <a:buAutoNum type="arabicPeriod"/>
+            </a:pPr>
+            <a:r>
+              <a:rPr lang="ja-JP" altLang="en-US" sz="1000">
+                <a:latin typeface="Meiryo" panose="020B0604030504040204" pitchFamily="34" charset="-128"/>
+                <a:ea typeface="Meiryo" panose="020B0604030504040204" pitchFamily="34" charset="-128"/>
+              </a:rPr>
+              <a:t>日次平均売上と月次営業日数をかけて、月次平均売上を算出</a:t>
+            </a:r>
+            <a:endParaRPr lang="en-US" altLang="ja-JP" sz="1000" dirty="0">
+              <a:latin typeface="Meiryo" panose="020B0604030504040204" pitchFamily="34" charset="-128"/>
+              <a:ea typeface="Meiryo" panose="020B0604030504040204" pitchFamily="34" charset="-128"/>
+            </a:endParaRPr>
+          </a:p>
+          <a:p>
+            <a:pPr marL="228600" indent="-228600">
+              <a:buAutoNum type="arabicPeriod"/>
+            </a:pPr>
+            <a:r>
+              <a:rPr lang="en-US" altLang="ja-JP" sz="1000" dirty="0">
+                <a:latin typeface="Meiryo" panose="020B0604030504040204" pitchFamily="34" charset="-128"/>
+                <a:ea typeface="Meiryo" panose="020B0604030504040204" pitchFamily="34" charset="-128"/>
+              </a:rPr>
+              <a:t>6</a:t>
+            </a:r>
+            <a:r>
+              <a:rPr lang="ja-JP" altLang="en-US" sz="1000">
+                <a:latin typeface="Meiryo" panose="020B0604030504040204" pitchFamily="34" charset="-128"/>
+                <a:ea typeface="Meiryo" panose="020B0604030504040204" pitchFamily="34" charset="-128"/>
+              </a:rPr>
+              <a:t>で算出した月次平均売上と月次実績売上から閑散期パーセンテージを算出</a:t>
+            </a:r>
+            <a:endParaRPr lang="en-US" altLang="ja-JP" sz="1000" dirty="0">
+              <a:latin typeface="Meiryo" panose="020B0604030504040204" pitchFamily="34" charset="-128"/>
+              <a:ea typeface="Meiryo" panose="020B0604030504040204" pitchFamily="34" charset="-128"/>
+            </a:endParaRPr>
+          </a:p>
+          <a:p>
+            <a:pPr marL="228600" indent="-228600">
+              <a:buAutoNum type="arabicPeriod"/>
+            </a:pPr>
+            <a:r>
+              <a:rPr lang="ja-JP" altLang="en-US" sz="1000">
+                <a:latin typeface="Meiryo" panose="020B0604030504040204" pitchFamily="34" charset="-128"/>
+                <a:ea typeface="Meiryo" panose="020B0604030504040204" pitchFamily="34" charset="-128"/>
+              </a:rPr>
+              <a:t>各月の各曜日の平均売上額算出</a:t>
+            </a:r>
+            <a:r>
+              <a:rPr lang="en-US" altLang="ja-JP" sz="1000" dirty="0">
+                <a:latin typeface="Meiryo" panose="020B0604030504040204" pitchFamily="34" charset="-128"/>
+                <a:ea typeface="Meiryo" panose="020B0604030504040204" pitchFamily="34" charset="-128"/>
+              </a:rPr>
+              <a:t>(</a:t>
+            </a:r>
+            <a:r>
+              <a:rPr lang="ja-JP" altLang="en-US" sz="1000">
+                <a:latin typeface="Meiryo" panose="020B0604030504040204" pitchFamily="34" charset="-128"/>
+                <a:ea typeface="Meiryo" panose="020B0604030504040204" pitchFamily="34" charset="-128"/>
+              </a:rPr>
+              <a:t>月曜日</a:t>
+            </a:r>
+            <a:r>
+              <a:rPr lang="en-US" altLang="ja-JP" sz="1000" dirty="0">
+                <a:latin typeface="Meiryo" panose="020B0604030504040204" pitchFamily="34" charset="-128"/>
+                <a:ea typeface="Meiryo" panose="020B0604030504040204" pitchFamily="34" charset="-128"/>
+              </a:rPr>
+              <a:t>〜</a:t>
+            </a:r>
+            <a:r>
+              <a:rPr lang="ja-JP" altLang="en-US" sz="1000">
+                <a:latin typeface="Meiryo" panose="020B0604030504040204" pitchFamily="34" charset="-128"/>
+                <a:ea typeface="Meiryo" panose="020B0604030504040204" pitchFamily="34" charset="-128"/>
+              </a:rPr>
+              <a:t>日曜日</a:t>
+            </a:r>
+            <a:r>
+              <a:rPr lang="en-US" altLang="ja-JP" sz="1000" dirty="0">
+                <a:latin typeface="Meiryo" panose="020B0604030504040204" pitchFamily="34" charset="-128"/>
+                <a:ea typeface="Meiryo" panose="020B0604030504040204" pitchFamily="34" charset="-128"/>
+              </a:rPr>
+              <a:t>)</a:t>
+            </a:r>
+          </a:p>
+          <a:p>
+            <a:pPr marL="228600" indent="-228600">
+              <a:buAutoNum type="arabicPeriod"/>
+            </a:pPr>
+            <a:r>
+              <a:rPr lang="en-US" altLang="ja-JP" sz="1000" dirty="0">
+                <a:latin typeface="Meiryo" panose="020B0604030504040204" pitchFamily="34" charset="-128"/>
+                <a:ea typeface="Meiryo" panose="020B0604030504040204" pitchFamily="34" charset="-128"/>
+              </a:rPr>
+              <a:t>2025</a:t>
+            </a:r>
+            <a:r>
+              <a:rPr lang="ja-JP" altLang="en-US" sz="1000">
+                <a:latin typeface="Meiryo" panose="020B0604030504040204" pitchFamily="34" charset="-128"/>
+                <a:ea typeface="Meiryo" panose="020B0604030504040204" pitchFamily="34" charset="-128"/>
+              </a:rPr>
+              <a:t>年の年間目標売上額設定</a:t>
+            </a:r>
+            <a:r>
+              <a:rPr lang="en-US" altLang="ja-JP" sz="1000" dirty="0">
+                <a:latin typeface="Meiryo" panose="020B0604030504040204" pitchFamily="34" charset="-128"/>
+                <a:ea typeface="Meiryo" panose="020B0604030504040204" pitchFamily="34" charset="-128"/>
+              </a:rPr>
+              <a:t>(</a:t>
+            </a:r>
+            <a:r>
+              <a:rPr lang="ja-JP" altLang="en-US" sz="1000">
+                <a:latin typeface="Meiryo" panose="020B0604030504040204" pitchFamily="34" charset="-128"/>
+                <a:ea typeface="Meiryo" panose="020B0604030504040204" pitchFamily="34" charset="-128"/>
+              </a:rPr>
+              <a:t>前年対比から現実味のある設定必須</a:t>
+            </a:r>
+            <a:r>
+              <a:rPr lang="en-US" altLang="ja-JP" sz="1000" dirty="0">
+                <a:latin typeface="Meiryo" panose="020B0604030504040204" pitchFamily="34" charset="-128"/>
+                <a:ea typeface="Meiryo" panose="020B0604030504040204" pitchFamily="34" charset="-128"/>
+              </a:rPr>
+              <a:t>)</a:t>
+            </a:r>
+            <a:r>
+              <a:rPr lang="ja-JP" altLang="en-US" sz="1000">
+                <a:latin typeface="Meiryo" panose="020B0604030504040204" pitchFamily="34" charset="-128"/>
+                <a:ea typeface="Meiryo" panose="020B0604030504040204" pitchFamily="34" charset="-128"/>
+              </a:rPr>
+              <a:t> </a:t>
+            </a:r>
+            <a:endParaRPr lang="en-US" altLang="ja-JP" sz="1000" dirty="0">
+              <a:latin typeface="Meiryo" panose="020B0604030504040204" pitchFamily="34" charset="-128"/>
+              <a:ea typeface="Meiryo" panose="020B0604030504040204" pitchFamily="34" charset="-128"/>
+            </a:endParaRPr>
+          </a:p>
+          <a:p>
+            <a:pPr marL="228600" indent="-228600">
+              <a:buAutoNum type="arabicPeriod"/>
+            </a:pPr>
+            <a:r>
+              <a:rPr lang="en-US" altLang="ja-JP" sz="1000" dirty="0">
+                <a:latin typeface="Meiryo" panose="020B0604030504040204" pitchFamily="34" charset="-128"/>
+                <a:ea typeface="Meiryo" panose="020B0604030504040204" pitchFamily="34" charset="-128"/>
+              </a:rPr>
+              <a:t>2025</a:t>
+            </a:r>
+            <a:r>
+              <a:rPr lang="ja-JP" altLang="en-US" sz="1000">
+                <a:latin typeface="Meiryo" panose="020B0604030504040204" pitchFamily="34" charset="-128"/>
+                <a:ea typeface="Meiryo" panose="020B0604030504040204" pitchFamily="34" charset="-128"/>
+              </a:rPr>
+              <a:t>年の総営業日数設定</a:t>
+            </a:r>
+            <a:endParaRPr lang="en-US" altLang="ja-JP" sz="1000" dirty="0">
+              <a:latin typeface="Meiryo" panose="020B0604030504040204" pitchFamily="34" charset="-128"/>
+              <a:ea typeface="Meiryo" panose="020B0604030504040204" pitchFamily="34" charset="-128"/>
+            </a:endParaRPr>
+          </a:p>
+          <a:p>
+            <a:pPr marL="228600" indent="-228600">
+              <a:buAutoNum type="arabicPeriod"/>
+            </a:pPr>
+            <a:r>
+              <a:rPr lang="ja-JP" altLang="en-US" sz="1000">
+                <a:latin typeface="Meiryo" panose="020B0604030504040204" pitchFamily="34" charset="-128"/>
+                <a:ea typeface="Meiryo" panose="020B0604030504040204" pitchFamily="34" charset="-128"/>
+              </a:rPr>
+              <a:t>各月の営業日算出</a:t>
+            </a:r>
+            <a:endParaRPr lang="en-US" altLang="ja-JP" sz="1000" dirty="0">
+              <a:latin typeface="Meiryo" panose="020B0604030504040204" pitchFamily="34" charset="-128"/>
+              <a:ea typeface="Meiryo" panose="020B0604030504040204" pitchFamily="34" charset="-128"/>
+            </a:endParaRPr>
+          </a:p>
+          <a:p>
+            <a:pPr marL="228600" indent="-228600">
+              <a:buAutoNum type="arabicPeriod"/>
+            </a:pPr>
+            <a:r>
+              <a:rPr lang="ja-JP" altLang="en-US" sz="1000">
+                <a:latin typeface="Meiryo" panose="020B0604030504040204" pitchFamily="34" charset="-128"/>
+                <a:ea typeface="Meiryo" panose="020B0604030504040204" pitchFamily="34" charset="-128"/>
+              </a:rPr>
+              <a:t>各月の目標平均売上額算出</a:t>
+            </a:r>
+            <a:endParaRPr lang="en-US" altLang="ja-JP" sz="1000" dirty="0">
+              <a:latin typeface="Meiryo" panose="020B0604030504040204" pitchFamily="34" charset="-128"/>
+              <a:ea typeface="Meiryo" panose="020B0604030504040204" pitchFamily="34" charset="-128"/>
+            </a:endParaRPr>
+          </a:p>
+          <a:p>
+            <a:pPr marL="228600" indent="-228600">
+              <a:buAutoNum type="arabicPeriod"/>
+            </a:pPr>
+            <a:r>
+              <a:rPr lang="en-US" altLang="ja-JP" sz="1000" dirty="0">
+                <a:latin typeface="Meiryo" panose="020B0604030504040204" pitchFamily="34" charset="-128"/>
+                <a:ea typeface="Meiryo" panose="020B0604030504040204" pitchFamily="34" charset="-128"/>
+              </a:rPr>
+              <a:t>2025</a:t>
+            </a:r>
+            <a:r>
+              <a:rPr lang="ja-JP" altLang="en-US" sz="1000">
+                <a:latin typeface="Meiryo" panose="020B0604030504040204" pitchFamily="34" charset="-128"/>
+                <a:ea typeface="Meiryo" panose="020B0604030504040204" pitchFamily="34" charset="-128"/>
+              </a:rPr>
+              <a:t>年の各月に</a:t>
+            </a:r>
+            <a:r>
+              <a:rPr lang="en-US" altLang="ja-JP" sz="1000" dirty="0">
+                <a:latin typeface="Meiryo" panose="020B0604030504040204" pitchFamily="34" charset="-128"/>
+                <a:ea typeface="Meiryo" panose="020B0604030504040204" pitchFamily="34" charset="-128"/>
+              </a:rPr>
+              <a:t>2024</a:t>
+            </a:r>
+            <a:r>
+              <a:rPr lang="ja-JP" altLang="en-US" sz="1000">
+                <a:latin typeface="Meiryo" panose="020B0604030504040204" pitchFamily="34" charset="-128"/>
+                <a:ea typeface="Meiryo" panose="020B0604030504040204" pitchFamily="34" charset="-128"/>
+              </a:rPr>
+              <a:t>年各月の繁閑期パーセンテージを設定、根拠のある目標額算出</a:t>
+            </a:r>
+            <a:endParaRPr lang="en-US" altLang="ja-JP" sz="1000" dirty="0">
+              <a:latin typeface="Meiryo" panose="020B0604030504040204" pitchFamily="34" charset="-128"/>
+              <a:ea typeface="Meiryo" panose="020B0604030504040204" pitchFamily="34" charset="-128"/>
+            </a:endParaRPr>
+          </a:p>
+          <a:p>
+            <a:pPr marL="228600" indent="-228600">
+              <a:buAutoNum type="arabicPeriod"/>
+            </a:pPr>
+            <a:r>
+              <a:rPr lang="en-US" altLang="ja-JP" sz="1000" dirty="0">
+                <a:latin typeface="Meiryo" panose="020B0604030504040204" pitchFamily="34" charset="-128"/>
+                <a:ea typeface="Meiryo" panose="020B0604030504040204" pitchFamily="34" charset="-128"/>
+              </a:rPr>
+              <a:t>13</a:t>
+            </a:r>
+            <a:r>
+              <a:rPr lang="ja-JP" altLang="en-US" sz="1000">
+                <a:latin typeface="Meiryo" panose="020B0604030504040204" pitchFamily="34" charset="-128"/>
+                <a:ea typeface="Meiryo" panose="020B0604030504040204" pitchFamily="34" charset="-128"/>
+              </a:rPr>
+              <a:t>で得た各月繁閑期目標額を</a:t>
+            </a:r>
+            <a:r>
+              <a:rPr lang="en-US" altLang="ja-JP" sz="1000" dirty="0">
+                <a:latin typeface="Meiryo" panose="020B0604030504040204" pitchFamily="34" charset="-128"/>
+                <a:ea typeface="Meiryo" panose="020B0604030504040204" pitchFamily="34" charset="-128"/>
+              </a:rPr>
+              <a:t>100%</a:t>
+            </a:r>
+            <a:r>
+              <a:rPr lang="ja-JP" altLang="en-US" sz="1000">
+                <a:latin typeface="Meiryo" panose="020B0604030504040204" pitchFamily="34" charset="-128"/>
+                <a:ea typeface="Meiryo" panose="020B0604030504040204" pitchFamily="34" charset="-128"/>
+              </a:rPr>
+              <a:t>とした、前年の各曜日の平均売上額を考慮した</a:t>
+            </a:r>
+            <a:r>
+              <a:rPr lang="en-US" altLang="ja-JP" sz="1000" dirty="0">
+                <a:latin typeface="Meiryo" panose="020B0604030504040204" pitchFamily="34" charset="-128"/>
+                <a:ea typeface="Meiryo" panose="020B0604030504040204" pitchFamily="34" charset="-128"/>
+              </a:rPr>
+              <a:t>『</a:t>
+            </a:r>
+            <a:r>
+              <a:rPr lang="ja-JP" altLang="en-US" sz="1000">
+                <a:latin typeface="Meiryo" panose="020B0604030504040204" pitchFamily="34" charset="-128"/>
+                <a:ea typeface="Meiryo" panose="020B0604030504040204" pitchFamily="34" charset="-128"/>
+              </a:rPr>
+              <a:t>各月の各曜日の平均売上額</a:t>
+            </a:r>
+            <a:r>
+              <a:rPr lang="en-US" altLang="ja-JP" sz="1000" dirty="0">
+                <a:latin typeface="Meiryo" panose="020B0604030504040204" pitchFamily="34" charset="-128"/>
+                <a:ea typeface="Meiryo" panose="020B0604030504040204" pitchFamily="34" charset="-128"/>
+              </a:rPr>
+              <a:t>』</a:t>
+            </a:r>
+            <a:r>
+              <a:rPr lang="ja-JP" altLang="en-US" sz="1000">
+                <a:latin typeface="Meiryo" panose="020B0604030504040204" pitchFamily="34" charset="-128"/>
+                <a:ea typeface="Meiryo" panose="020B0604030504040204" pitchFamily="34" charset="-128"/>
+              </a:rPr>
+              <a:t>を各月の各曜日の目標額に設定</a:t>
+            </a:r>
+            <a:endParaRPr lang="en-US" altLang="ja-JP" sz="1000" dirty="0">
+              <a:latin typeface="Meiryo" panose="020B0604030504040204" pitchFamily="34" charset="-128"/>
+              <a:ea typeface="Meiryo" panose="020B0604030504040204" pitchFamily="34" charset="-128"/>
+            </a:endParaRPr>
+          </a:p>
+          <a:p>
+            <a:pPr marL="228600" indent="-228600">
+              <a:buAutoNum type="arabicPeriod"/>
+            </a:pPr>
+            <a:r>
+              <a:rPr lang="ja-JP" altLang="en-US" sz="1000">
+                <a:latin typeface="Meiryo" panose="020B0604030504040204" pitchFamily="34" charset="-128"/>
+                <a:ea typeface="Meiryo" panose="020B0604030504040204" pitchFamily="34" charset="-128"/>
+              </a:rPr>
+              <a:t>ユーザーが毎営業日に売上を入力</a:t>
+            </a:r>
+            <a:endParaRPr lang="en-US" altLang="ja-JP" sz="1000" dirty="0">
+              <a:latin typeface="Meiryo" panose="020B0604030504040204" pitchFamily="34" charset="-128"/>
+              <a:ea typeface="Meiryo" panose="020B0604030504040204" pitchFamily="34" charset="-128"/>
+            </a:endParaRPr>
+          </a:p>
+          <a:p>
+            <a:pPr marL="228600" indent="-228600">
+              <a:buAutoNum type="arabicPeriod"/>
+            </a:pPr>
+            <a:r>
+              <a:rPr lang="ja-JP" altLang="en-US" sz="1000">
+                <a:latin typeface="Meiryo" panose="020B0604030504040204" pitchFamily="34" charset="-128"/>
+                <a:ea typeface="Meiryo" panose="020B0604030504040204" pitchFamily="34" charset="-128"/>
+              </a:rPr>
+              <a:t>日次、月次、年次各カテゴリーの実質売上、目標額、差額、達成率を表記。＊月次では負けていても年次では勝っているパターンなど、後々の繁閑期率の上方下方修正のために使用。</a:t>
+            </a:r>
+            <a:endParaRPr lang="en-US" altLang="ja-JP" sz="1000" dirty="0">
+              <a:latin typeface="Meiryo" panose="020B0604030504040204" pitchFamily="34" charset="-128"/>
+              <a:ea typeface="Meiryo" panose="020B0604030504040204" pitchFamily="34" charset="-128"/>
+            </a:endParaRPr>
+          </a:p>
+          <a:p>
+            <a:pPr marL="228600" indent="-228600">
+              <a:buAutoNum type="arabicPeriod"/>
+            </a:pPr>
+            <a:r>
+              <a:rPr lang="ja-JP" altLang="en-US" sz="1000">
+                <a:latin typeface="Meiryo" panose="020B0604030504040204" pitchFamily="34" charset="-128"/>
+                <a:ea typeface="Meiryo" panose="020B0604030504040204" pitchFamily="34" charset="-128"/>
+              </a:rPr>
+              <a:t>支出管理、発注もの、現金小口ものの支出を管理する表、</a:t>
+            </a:r>
+            <a:endParaRPr lang="en-US" altLang="ja-JP" sz="1000" dirty="0">
+              <a:latin typeface="Meiryo" panose="020B0604030504040204" pitchFamily="34" charset="-128"/>
+              <a:ea typeface="Meiryo" panose="020B0604030504040204" pitchFamily="34" charset="-128"/>
+            </a:endParaRPr>
+          </a:p>
+          <a:p>
+            <a:pPr marL="228600" indent="-228600">
+              <a:buAutoNum type="arabicPeriod"/>
+            </a:pPr>
+            <a:r>
+              <a:rPr lang="en-US" altLang="ja-JP" sz="1000" dirty="0">
+                <a:latin typeface="Meiryo" panose="020B0604030504040204" pitchFamily="34" charset="-128"/>
+                <a:ea typeface="Meiryo" panose="020B0604030504040204" pitchFamily="34" charset="-128"/>
+              </a:rPr>
+              <a:t>PL</a:t>
+            </a:r>
+            <a:r>
+              <a:rPr lang="ja-JP" altLang="en-US" sz="1000">
+                <a:latin typeface="Meiryo" panose="020B0604030504040204" pitchFamily="34" charset="-128"/>
+                <a:ea typeface="Meiryo" panose="020B0604030504040204" pitchFamily="34" charset="-128"/>
+              </a:rPr>
+              <a:t>表自動作成</a:t>
+            </a:r>
+            <a:endParaRPr lang="en-US" altLang="ja-JP" sz="1000" dirty="0">
+              <a:latin typeface="Meiryo" panose="020B0604030504040204" pitchFamily="34" charset="-128"/>
+              <a:ea typeface="Meiryo" panose="020B0604030504040204" pitchFamily="34" charset="-128"/>
+            </a:endParaRPr>
+          </a:p>
+          <a:p>
+            <a:pPr marL="228600" indent="-228600">
+              <a:buAutoNum type="arabicPeriod"/>
+            </a:pPr>
+            <a:endParaRPr lang="en-US" altLang="ja-JP" sz="1000" dirty="0">
+              <a:latin typeface="Meiryo" panose="020B0604030504040204" pitchFamily="34" charset="-128"/>
+              <a:ea typeface="Meiryo" panose="020B0604030504040204" pitchFamily="34" charset="-128"/>
+            </a:endParaRPr>
+          </a:p>
+          <a:p>
+            <a:r>
+              <a:rPr lang="ja-JP" altLang="en-US" sz="1000">
+                <a:latin typeface="Meiryo" panose="020B0604030504040204" pitchFamily="34" charset="-128"/>
+                <a:ea typeface="Meiryo" panose="020B0604030504040204" pitchFamily="34" charset="-128"/>
+              </a:rPr>
+              <a:t>将来機能として、予約管理、シフト管理機能を持たせ経営に関してワンストップで網羅できる機能を持ちたい、</a:t>
+            </a:r>
+            <a:r>
+              <a:rPr lang="en-US" altLang="ja-JP" sz="1000" dirty="0">
+                <a:latin typeface="Meiryo" panose="020B0604030504040204" pitchFamily="34" charset="-128"/>
+                <a:ea typeface="Meiryo" panose="020B0604030504040204" pitchFamily="34" charset="-128"/>
+              </a:rPr>
+              <a:t>Table Check</a:t>
+            </a:r>
+            <a:r>
+              <a:rPr lang="ja-JP" altLang="en-US" sz="1000">
+                <a:latin typeface="Meiryo" panose="020B0604030504040204" pitchFamily="34" charset="-128"/>
+                <a:ea typeface="Meiryo" panose="020B0604030504040204" pitchFamily="34" charset="-128"/>
+              </a:rPr>
+              <a:t>の</a:t>
+            </a:r>
+            <a:r>
+              <a:rPr lang="en-US" altLang="ja-JP" sz="1000" dirty="0">
+                <a:latin typeface="Meiryo" panose="020B0604030504040204" pitchFamily="34" charset="-128"/>
+                <a:ea typeface="Meiryo" panose="020B0604030504040204" pitchFamily="34" charset="-128"/>
+              </a:rPr>
+              <a:t>API</a:t>
+            </a:r>
+            <a:r>
+              <a:rPr lang="ja-JP" altLang="en-US" sz="1000">
+                <a:latin typeface="Meiryo" panose="020B0604030504040204" pitchFamily="34" charset="-128"/>
+                <a:ea typeface="Meiryo" panose="020B0604030504040204" pitchFamily="34" charset="-128"/>
+              </a:rPr>
+              <a:t>機能</a:t>
+            </a:r>
+            <a:r>
+              <a:rPr lang="en-US" altLang="ja-JP" sz="1000" dirty="0">
+                <a:latin typeface="Meiryo" panose="020B0604030504040204" pitchFamily="34" charset="-128"/>
+                <a:ea typeface="Meiryo" panose="020B0604030504040204" pitchFamily="34" charset="-128"/>
+              </a:rPr>
+              <a:t> or KPI Navigator</a:t>
+            </a:r>
+            <a:r>
+              <a:rPr lang="ja-JP" altLang="en-US" sz="1000">
+                <a:latin typeface="Meiryo" panose="020B0604030504040204" pitchFamily="34" charset="-128"/>
+                <a:ea typeface="Meiryo" panose="020B0604030504040204" pitchFamily="34" charset="-128"/>
+              </a:rPr>
+              <a:t>を</a:t>
+            </a:r>
+            <a:r>
+              <a:rPr lang="en-US" altLang="ja-JP" sz="1000" dirty="0">
+                <a:latin typeface="Meiryo" panose="020B0604030504040204" pitchFamily="34" charset="-128"/>
+                <a:ea typeface="Meiryo" panose="020B0604030504040204" pitchFamily="34" charset="-128"/>
+              </a:rPr>
+              <a:t>API</a:t>
+            </a:r>
+            <a:r>
+              <a:rPr lang="ja-JP" altLang="en-US" sz="1000">
+                <a:latin typeface="Meiryo" panose="020B0604030504040204" pitchFamily="34" charset="-128"/>
+                <a:ea typeface="Meiryo" panose="020B0604030504040204" pitchFamily="34" charset="-128"/>
+              </a:rPr>
+              <a:t>化</a:t>
+            </a:r>
+            <a:r>
+              <a:rPr lang="en-US" altLang="ja-JP" sz="1000" dirty="0">
+                <a:latin typeface="Meiryo" panose="020B0604030504040204" pitchFamily="34" charset="-128"/>
+                <a:ea typeface="Meiryo" panose="020B0604030504040204" pitchFamily="34" charset="-128"/>
+              </a:rPr>
+              <a:t>Table Check</a:t>
+            </a:r>
+            <a:r>
+              <a:rPr lang="ja-JP" altLang="en-US" sz="1000">
+                <a:latin typeface="Meiryo" panose="020B0604030504040204" pitchFamily="34" charset="-128"/>
+                <a:ea typeface="Meiryo" panose="020B0604030504040204" pitchFamily="34" charset="-128"/>
+              </a:rPr>
+              <a:t>ユーザーに訴求できる？</a:t>
+            </a:r>
+            <a:endParaRPr lang="en-US" altLang="ja-JP" sz="1000" dirty="0">
+              <a:latin typeface="Meiryo" panose="020B0604030504040204" pitchFamily="34" charset="-128"/>
+              <a:ea typeface="Meiryo" panose="020B0604030504040204" pitchFamily="34" charset="-128"/>
+            </a:endParaRPr>
+          </a:p>
+          <a:p>
+            <a:endParaRPr lang="en-US" altLang="ja-JP" sz="1000" dirty="0">
+              <a:latin typeface="Meiryo" panose="020B0604030504040204" pitchFamily="34" charset="-128"/>
+              <a:ea typeface="Meiryo" panose="020B0604030504040204" pitchFamily="34" charset="-128"/>
+            </a:endParaRPr>
+          </a:p>
+          <a:p>
+            <a:r>
+              <a:rPr lang="ja-JP" altLang="en-US" sz="1000">
+                <a:latin typeface="Meiryo" panose="020B0604030504040204" pitchFamily="34" charset="-128"/>
+                <a:ea typeface="Meiryo" panose="020B0604030504040204" pitchFamily="34" charset="-128"/>
+              </a:rPr>
+              <a:t>＊追記必須項目随時更新</a:t>
+            </a:r>
+            <a:endParaRPr lang="en-US" altLang="ja-JP" sz="1000" dirty="0">
+              <a:latin typeface="Meiryo" panose="020B0604030504040204" pitchFamily="34" charset="-128"/>
+              <a:ea typeface="Meiryo" panose="020B0604030504040204" pitchFamily="34" charset="-128"/>
+            </a:endParaRPr>
+          </a:p>
+        </p:txBody>
+      </p:sp>
+    </p:spTree>
+    <p:extLst>
+      <p:ext uri="{BB962C8B-B14F-4D97-AF65-F5344CB8AC3E}">
+        <p14:creationId xmlns:p14="http://schemas.microsoft.com/office/powerpoint/2010/main" val="185382288"/>
+      </p:ext>
+    </p:extLst>
+  </p:cSld>
+  <p:clrMapOvr>
+    <a:masterClrMapping/>
+  </p:clrMapOvr>
+</p:sld>
+</file>
+
+<file path=ppt/slides/slide3.xml><?xml version="1.0" encoding="utf-8"?>
+<p:sld xmlns:a="http://schemas.openxmlformats.org/drawingml/2006/main" xmlns:r="http://schemas.openxmlformats.org/officeDocument/2006/relationships" xmlns:p="http://schemas.openxmlformats.org/presentationml/2006/main">
+  <p:cSld>
+    <p:spTree>
+      <p:nvGrpSpPr>
+        <p:cNvPr id="1" name=""/>
+        <p:cNvGrpSpPr/>
+        <p:nvPr/>
+      </p:nvGrpSpPr>
+      <p:grpSpPr>
+        <a:xfrm>
+          <a:off x="0" y="0"/>
+          <a:ext cx="0" cy="0"/>
+          <a:chOff x="0" y="0"/>
+          <a:chExt cx="0" cy="0"/>
+        </a:xfrm>
+      </p:grpSpPr>
+      <p:sp>
+        <p:nvSpPr>
+          <p:cNvPr id="4" name="テキスト ボックス 3">
+            <a:extLst>
+              <a:ext uri="{FF2B5EF4-FFF2-40B4-BE49-F238E27FC236}">
+                <a16:creationId xmlns:a16="http://schemas.microsoft.com/office/drawing/2014/main" id="{AE99DE16-AD02-4A09-A39B-B73330EFA7CD}"/>
+              </a:ext>
+            </a:extLst>
+          </p:cNvPr>
+          <p:cNvSpPr txBox="1"/>
+          <p:nvPr/>
+        </p:nvSpPr>
+        <p:spPr>
+          <a:xfrm>
+            <a:off x="1934715" y="128419"/>
+            <a:ext cx="2986651" cy="369332"/>
+          </a:xfrm>
+          <a:prstGeom prst="rect">
+            <a:avLst/>
+          </a:prstGeom>
+          <a:noFill/>
+        </p:spPr>
+        <p:txBody>
+          <a:bodyPr wrap="none" rtlCol="0">
+            <a:spAutoFit/>
+          </a:bodyPr>
+          <a:lstStyle/>
+          <a:p>
+            <a:r>
+              <a:rPr kumimoji="1" lang="en-US" altLang="ja-JP" dirty="0">
+                <a:latin typeface="Meiryo" panose="020B0604030504040204" pitchFamily="34" charset="-128"/>
+                <a:ea typeface="Meiryo" panose="020B0604030504040204" pitchFamily="34" charset="-128"/>
+              </a:rPr>
+              <a:t>KPI-Navigator </a:t>
+            </a:r>
+            <a:r>
+              <a:rPr kumimoji="1" lang="ja-JP" altLang="en-US">
+                <a:latin typeface="Meiryo" panose="020B0604030504040204" pitchFamily="34" charset="-128"/>
+                <a:ea typeface="Meiryo" panose="020B0604030504040204" pitchFamily="34" charset="-128"/>
+              </a:rPr>
+              <a:t>各機能詳細</a:t>
             </a:r>
           </a:p>
         </p:txBody>
@@ -4540,7 +7291,7 @@
 </p:sld>
 </file>
 
-<file path=ppt/slides/slide2.xml><?xml version="1.0" encoding="utf-8"?>
+<file path=ppt/slides/slide4.xml><?xml version="1.0" encoding="utf-8"?>
 <p:sld xmlns:a="http://schemas.openxmlformats.org/drawingml/2006/main" xmlns:r="http://schemas.openxmlformats.org/officeDocument/2006/relationships" xmlns:p="http://schemas.openxmlformats.org/presentationml/2006/main">
   <p:cSld>
     <p:spTree>
@@ -5985,6 +8736,1789 @@
     <p:extLst>
       <p:ext uri="{BB962C8B-B14F-4D97-AF65-F5344CB8AC3E}">
         <p14:creationId xmlns:p14="http://schemas.microsoft.com/office/powerpoint/2010/main" val="3531807860"/>
+      </p:ext>
+    </p:extLst>
+  </p:cSld>
+  <p:clrMapOvr>
+    <a:masterClrMapping/>
+  </p:clrMapOvr>
+</p:sld>
+</file>
+
+<file path=ppt/slides/slide5.xml><?xml version="1.0" encoding="utf-8"?>
+<p:sld xmlns:a="http://schemas.openxmlformats.org/drawingml/2006/main" xmlns:r="http://schemas.openxmlformats.org/officeDocument/2006/relationships" xmlns:p="http://schemas.openxmlformats.org/presentationml/2006/main">
+  <p:cSld>
+    <p:spTree>
+      <p:nvGrpSpPr>
+        <p:cNvPr id="1" name=""/>
+        <p:cNvGrpSpPr/>
+        <p:nvPr/>
+      </p:nvGrpSpPr>
+      <p:grpSpPr>
+        <a:xfrm>
+          <a:off x="0" y="0"/>
+          <a:ext cx="0" cy="0"/>
+          <a:chOff x="0" y="0"/>
+          <a:chExt cx="0" cy="0"/>
+        </a:xfrm>
+      </p:grpSpPr>
+      <p:sp>
+        <p:nvSpPr>
+          <p:cNvPr id="4" name="テキスト ボックス 3">
+            <a:extLst>
+              <a:ext uri="{FF2B5EF4-FFF2-40B4-BE49-F238E27FC236}">
+                <a16:creationId xmlns:a16="http://schemas.microsoft.com/office/drawing/2014/main" id="{B97A206F-A3CA-0FAF-6ED0-7C1A375CC6F1}"/>
+              </a:ext>
+            </a:extLst>
+          </p:cNvPr>
+          <p:cNvSpPr txBox="1"/>
+          <p:nvPr/>
+        </p:nvSpPr>
+        <p:spPr>
+          <a:xfrm>
+            <a:off x="2174492" y="262458"/>
+            <a:ext cx="2509021" cy="276999"/>
+          </a:xfrm>
+          <a:prstGeom prst="rect">
+            <a:avLst/>
+          </a:prstGeom>
+          <a:noFill/>
+        </p:spPr>
+        <p:txBody>
+          <a:bodyPr wrap="none" rtlCol="0">
+            <a:spAutoFit/>
+          </a:bodyPr>
+          <a:lstStyle/>
+          <a:p>
+            <a:pPr algn="ctr"/>
+            <a:r>
+              <a:rPr lang="en-US" altLang="ja-JP" sz="1200" dirty="0">
+                <a:latin typeface="Meiryo" panose="020B0604030504040204" pitchFamily="34" charset="-128"/>
+                <a:ea typeface="Meiryo" panose="020B0604030504040204" pitchFamily="34" charset="-128"/>
+              </a:rPr>
+              <a:t>③</a:t>
+            </a:r>
+            <a:r>
+              <a:rPr lang="en" altLang="ja-JP" sz="1200" dirty="0">
+                <a:latin typeface="Meiryo" panose="020B0604030504040204" pitchFamily="34" charset="-128"/>
+                <a:ea typeface="Meiryo" panose="020B0604030504040204" pitchFamily="34" charset="-128"/>
+              </a:rPr>
+              <a:t>【</a:t>
+            </a:r>
+            <a:r>
+              <a:rPr lang="ja-JP" altLang="en-US" sz="1200">
+                <a:latin typeface="Meiryo" panose="020B0604030504040204" pitchFamily="34" charset="-128"/>
+                <a:ea typeface="Meiryo" panose="020B0604030504040204" pitchFamily="34" charset="-128"/>
+              </a:rPr>
+              <a:t>デザインイメージ</a:t>
+            </a:r>
+            <a:r>
+              <a:rPr lang="en-US" altLang="ja-JP" sz="1200" dirty="0">
+                <a:latin typeface="Meiryo" panose="020B0604030504040204" pitchFamily="34" charset="-128"/>
+                <a:ea typeface="Meiryo" panose="020B0604030504040204" pitchFamily="34" charset="-128"/>
+              </a:rPr>
+              <a:t> / Figma</a:t>
+            </a:r>
+            <a:r>
+              <a:rPr lang="en" altLang="ja-JP" sz="1200" dirty="0">
+                <a:latin typeface="Meiryo" panose="020B0604030504040204" pitchFamily="34" charset="-128"/>
+                <a:ea typeface="Meiryo" panose="020B0604030504040204" pitchFamily="34" charset="-128"/>
+              </a:rPr>
+              <a:t>】</a:t>
+            </a:r>
+          </a:p>
+        </p:txBody>
+      </p:sp>
+      <p:pic>
+        <p:nvPicPr>
+          <p:cNvPr id="6" name="図 5" descr="グラフィカル ユーザー インターフェイス, アプリケーション, テーブル&#10;&#10;AI 生成コンテンツは誤りを含む可能性があります。">
+            <a:extLst>
+              <a:ext uri="{FF2B5EF4-FFF2-40B4-BE49-F238E27FC236}">
+                <a16:creationId xmlns:a16="http://schemas.microsoft.com/office/drawing/2014/main" id="{2D4B4FB6-AA81-4575-0CB1-FC32B77D5601}"/>
+              </a:ext>
+            </a:extLst>
+          </p:cNvPr>
+          <p:cNvPicPr>
+            <a:picLocks noChangeAspect="1"/>
+          </p:cNvPicPr>
+          <p:nvPr/>
+        </p:nvPicPr>
+        <p:blipFill>
+          <a:blip r:embed="rId2"/>
+          <a:stretch>
+            <a:fillRect/>
+          </a:stretch>
+        </p:blipFill>
+        <p:spPr>
+          <a:xfrm>
+            <a:off x="147782" y="803543"/>
+            <a:ext cx="3236631" cy="2331068"/>
+          </a:xfrm>
+          <a:prstGeom prst="rect">
+            <a:avLst/>
+          </a:prstGeom>
+        </p:spPr>
+      </p:pic>
+      <p:pic>
+        <p:nvPicPr>
+          <p:cNvPr id="8" name="図 7" descr="グラフィカル ユーザー インターフェイス, アプリケーション, テーブル, Excel&#10;&#10;AI 生成コンテンツは誤りを含む可能性があります。">
+            <a:extLst>
+              <a:ext uri="{FF2B5EF4-FFF2-40B4-BE49-F238E27FC236}">
+                <a16:creationId xmlns:a16="http://schemas.microsoft.com/office/drawing/2014/main" id="{5CC93D2C-D99D-1A36-4FE0-360BF8016EA5}"/>
+              </a:ext>
+            </a:extLst>
+          </p:cNvPr>
+          <p:cNvPicPr>
+            <a:picLocks noChangeAspect="1"/>
+          </p:cNvPicPr>
+          <p:nvPr/>
+        </p:nvPicPr>
+        <p:blipFill>
+          <a:blip r:embed="rId3"/>
+          <a:stretch>
+            <a:fillRect/>
+          </a:stretch>
+        </p:blipFill>
+        <p:spPr>
+          <a:xfrm>
+            <a:off x="3512058" y="803544"/>
+            <a:ext cx="3198160" cy="2331067"/>
+          </a:xfrm>
+          <a:prstGeom prst="rect">
+            <a:avLst/>
+          </a:prstGeom>
+        </p:spPr>
+      </p:pic>
+      <p:cxnSp>
+        <p:nvCxnSpPr>
+          <p:cNvPr id="10" name="直線矢印コネクタ 9">
+            <a:extLst>
+              <a:ext uri="{FF2B5EF4-FFF2-40B4-BE49-F238E27FC236}">
+                <a16:creationId xmlns:a16="http://schemas.microsoft.com/office/drawing/2014/main" id="{5265D5BA-4615-C3F6-F447-5AFA1888CAA5}"/>
+              </a:ext>
+            </a:extLst>
+          </p:cNvPr>
+          <p:cNvCxnSpPr>
+            <a:cxnSpLocks/>
+          </p:cNvCxnSpPr>
+          <p:nvPr/>
+        </p:nvCxnSpPr>
+        <p:spPr>
+          <a:xfrm>
+            <a:off x="2893222" y="3190524"/>
+            <a:ext cx="1117600" cy="0"/>
+          </a:xfrm>
+          <a:prstGeom prst="straightConnector1">
+            <a:avLst/>
+          </a:prstGeom>
+          <a:ln>
+            <a:tailEnd type="triangle"/>
+          </a:ln>
+        </p:spPr>
+        <p:style>
+          <a:lnRef idx="2">
+            <a:schemeClr val="accent1"/>
+          </a:lnRef>
+          <a:fillRef idx="0">
+            <a:schemeClr val="accent1"/>
+          </a:fillRef>
+          <a:effectRef idx="1">
+            <a:schemeClr val="accent1"/>
+          </a:effectRef>
+          <a:fontRef idx="minor">
+            <a:schemeClr val="tx1"/>
+          </a:fontRef>
+        </p:style>
+      </p:cxnSp>
+      <p:sp>
+        <p:nvSpPr>
+          <p:cNvPr id="12" name="テキスト ボックス 11">
+            <a:extLst>
+              <a:ext uri="{FF2B5EF4-FFF2-40B4-BE49-F238E27FC236}">
+                <a16:creationId xmlns:a16="http://schemas.microsoft.com/office/drawing/2014/main" id="{CD68543E-50AA-D9A6-5D56-2D9807C50CD4}"/>
+              </a:ext>
+            </a:extLst>
+          </p:cNvPr>
+          <p:cNvSpPr txBox="1"/>
+          <p:nvPr/>
+        </p:nvSpPr>
+        <p:spPr>
+          <a:xfrm>
+            <a:off x="1598852" y="3172052"/>
+            <a:ext cx="1107997" cy="215444"/>
+          </a:xfrm>
+          <a:prstGeom prst="rect">
+            <a:avLst/>
+          </a:prstGeom>
+          <a:noFill/>
+        </p:spPr>
+        <p:txBody>
+          <a:bodyPr wrap="none" rtlCol="0">
+            <a:spAutoFit/>
+          </a:bodyPr>
+          <a:lstStyle/>
+          <a:p>
+            <a:pPr algn="ctr"/>
+            <a:r>
+              <a:rPr kumimoji="1" lang="en-US" altLang="ja-JP" sz="800" dirty="0">
+                <a:latin typeface="Meiryo" panose="020B0604030504040204" pitchFamily="34" charset="-128"/>
+                <a:ea typeface="Meiryo" panose="020B0604030504040204" pitchFamily="34" charset="-128"/>
+              </a:rPr>
+              <a:t>『</a:t>
+            </a:r>
+            <a:r>
+              <a:rPr kumimoji="1" lang="ja-JP" altLang="en-US" sz="800">
+                <a:latin typeface="Meiryo" panose="020B0604030504040204" pitchFamily="34" charset="-128"/>
+                <a:ea typeface="Meiryo" panose="020B0604030504040204" pitchFamily="34" charset="-128"/>
+              </a:rPr>
+              <a:t>追加表示</a:t>
+            </a:r>
+            <a:r>
+              <a:rPr kumimoji="1" lang="en-US" altLang="ja-JP" sz="800" dirty="0">
+                <a:latin typeface="Meiryo" panose="020B0604030504040204" pitchFamily="34" charset="-128"/>
+                <a:ea typeface="Meiryo" panose="020B0604030504040204" pitchFamily="34" charset="-128"/>
+              </a:rPr>
+              <a:t>』</a:t>
+            </a:r>
+            <a:r>
+              <a:rPr kumimoji="1" lang="ja-JP" altLang="en-US" sz="800">
+                <a:latin typeface="Meiryo" panose="020B0604030504040204" pitchFamily="34" charset="-128"/>
+                <a:ea typeface="Meiryo" panose="020B0604030504040204" pitchFamily="34" charset="-128"/>
+              </a:rPr>
+              <a:t>ボタン</a:t>
+            </a:r>
+          </a:p>
+        </p:txBody>
+      </p:sp>
+      <p:cxnSp>
+        <p:nvCxnSpPr>
+          <p:cNvPr id="13" name="直線矢印コネクタ 12">
+            <a:extLst>
+              <a:ext uri="{FF2B5EF4-FFF2-40B4-BE49-F238E27FC236}">
+                <a16:creationId xmlns:a16="http://schemas.microsoft.com/office/drawing/2014/main" id="{ADF5AAFB-27A1-2AAA-32C1-E140B3A2E82F}"/>
+              </a:ext>
+            </a:extLst>
+          </p:cNvPr>
+          <p:cNvCxnSpPr>
+            <a:cxnSpLocks/>
+          </p:cNvCxnSpPr>
+          <p:nvPr/>
+        </p:nvCxnSpPr>
+        <p:spPr>
+          <a:xfrm flipH="1">
+            <a:off x="2893222" y="3327464"/>
+            <a:ext cx="1117600" cy="0"/>
+          </a:xfrm>
+          <a:prstGeom prst="straightConnector1">
+            <a:avLst/>
+          </a:prstGeom>
+          <a:ln>
+            <a:tailEnd type="triangle"/>
+          </a:ln>
+        </p:spPr>
+        <p:style>
+          <a:lnRef idx="2">
+            <a:schemeClr val="accent1"/>
+          </a:lnRef>
+          <a:fillRef idx="0">
+            <a:schemeClr val="accent1"/>
+          </a:fillRef>
+          <a:effectRef idx="1">
+            <a:schemeClr val="accent1"/>
+          </a:effectRef>
+          <a:fontRef idx="minor">
+            <a:schemeClr val="tx1"/>
+          </a:fontRef>
+        </p:style>
+      </p:cxnSp>
+      <p:sp>
+        <p:nvSpPr>
+          <p:cNvPr id="16" name="テキスト ボックス 15">
+            <a:extLst>
+              <a:ext uri="{FF2B5EF4-FFF2-40B4-BE49-F238E27FC236}">
+                <a16:creationId xmlns:a16="http://schemas.microsoft.com/office/drawing/2014/main" id="{57A0589C-5547-A325-5642-CA4E4C400803}"/>
+              </a:ext>
+            </a:extLst>
+          </p:cNvPr>
+          <p:cNvSpPr txBox="1"/>
+          <p:nvPr/>
+        </p:nvSpPr>
+        <p:spPr>
+          <a:xfrm>
+            <a:off x="4231713" y="3162816"/>
+            <a:ext cx="1005404" cy="215444"/>
+          </a:xfrm>
+          <a:prstGeom prst="rect">
+            <a:avLst/>
+          </a:prstGeom>
+          <a:noFill/>
+        </p:spPr>
+        <p:txBody>
+          <a:bodyPr wrap="none" rtlCol="0">
+            <a:spAutoFit/>
+          </a:bodyPr>
+          <a:lstStyle/>
+          <a:p>
+            <a:pPr algn="ctr"/>
+            <a:r>
+              <a:rPr kumimoji="1" lang="en-US" altLang="ja-JP" sz="800" dirty="0">
+                <a:latin typeface="Meiryo" panose="020B0604030504040204" pitchFamily="34" charset="-128"/>
+                <a:ea typeface="Meiryo" panose="020B0604030504040204" pitchFamily="34" charset="-128"/>
+              </a:rPr>
+              <a:t>『</a:t>
+            </a:r>
+            <a:r>
+              <a:rPr kumimoji="1" lang="ja-JP" altLang="en-US" sz="800">
+                <a:latin typeface="Meiryo" panose="020B0604030504040204" pitchFamily="34" charset="-128"/>
+                <a:ea typeface="Meiryo" panose="020B0604030504040204" pitchFamily="34" charset="-128"/>
+              </a:rPr>
+              <a:t>閉じる</a:t>
+            </a:r>
+            <a:r>
+              <a:rPr kumimoji="1" lang="en-US" altLang="ja-JP" sz="800" dirty="0">
+                <a:latin typeface="Meiryo" panose="020B0604030504040204" pitchFamily="34" charset="-128"/>
+                <a:ea typeface="Meiryo" panose="020B0604030504040204" pitchFamily="34" charset="-128"/>
+              </a:rPr>
+              <a:t>』</a:t>
+            </a:r>
+            <a:r>
+              <a:rPr kumimoji="1" lang="ja-JP" altLang="en-US" sz="800">
+                <a:latin typeface="Meiryo" panose="020B0604030504040204" pitchFamily="34" charset="-128"/>
+                <a:ea typeface="Meiryo" panose="020B0604030504040204" pitchFamily="34" charset="-128"/>
+              </a:rPr>
+              <a:t>ボタン</a:t>
+            </a:r>
+          </a:p>
+        </p:txBody>
+      </p:sp>
+      <p:sp>
+        <p:nvSpPr>
+          <p:cNvPr id="17" name="テキスト ボックス 16">
+            <a:extLst>
+              <a:ext uri="{FF2B5EF4-FFF2-40B4-BE49-F238E27FC236}">
+                <a16:creationId xmlns:a16="http://schemas.microsoft.com/office/drawing/2014/main" id="{B23AD43C-4D51-AE0A-9CEF-B82BB5F990A7}"/>
+              </a:ext>
+            </a:extLst>
+          </p:cNvPr>
+          <p:cNvSpPr txBox="1"/>
+          <p:nvPr/>
+        </p:nvSpPr>
+        <p:spPr>
+          <a:xfrm>
+            <a:off x="1951672" y="3461389"/>
+            <a:ext cx="2954655" cy="338554"/>
+          </a:xfrm>
+          <a:prstGeom prst="rect">
+            <a:avLst/>
+          </a:prstGeom>
+          <a:noFill/>
+        </p:spPr>
+        <p:txBody>
+          <a:bodyPr wrap="none" rtlCol="0">
+            <a:spAutoFit/>
+          </a:bodyPr>
+          <a:lstStyle/>
+          <a:p>
+            <a:pPr algn="ctr"/>
+            <a:r>
+              <a:rPr kumimoji="1" lang="en-US" altLang="ja-JP" sz="800" dirty="0">
+                <a:latin typeface="Meiryo" panose="020B0604030504040204" pitchFamily="34" charset="-128"/>
+                <a:ea typeface="Meiryo" panose="020B0604030504040204" pitchFamily="34" charset="-128"/>
+              </a:rPr>
+              <a:t>daily bar</a:t>
+            </a:r>
+            <a:r>
+              <a:rPr kumimoji="1" lang="ja-JP" altLang="en-US" sz="800">
+                <a:latin typeface="Meiryo" panose="020B0604030504040204" pitchFamily="34" charset="-128"/>
+                <a:ea typeface="Meiryo" panose="020B0604030504040204" pitchFamily="34" charset="-128"/>
+              </a:rPr>
+              <a:t>デフォルト表示は日次のみだが</a:t>
+            </a:r>
+            <a:endParaRPr kumimoji="1" lang="en-US" altLang="ja-JP" sz="800" dirty="0">
+              <a:latin typeface="Meiryo" panose="020B0604030504040204" pitchFamily="34" charset="-128"/>
+              <a:ea typeface="Meiryo" panose="020B0604030504040204" pitchFamily="34" charset="-128"/>
+            </a:endParaRPr>
+          </a:p>
+          <a:p>
+            <a:pPr algn="ctr"/>
+            <a:r>
+              <a:rPr kumimoji="1" lang="en-US" altLang="ja-JP" sz="800" dirty="0">
+                <a:latin typeface="Meiryo" panose="020B0604030504040204" pitchFamily="34" charset="-128"/>
+                <a:ea typeface="Meiryo" panose="020B0604030504040204" pitchFamily="34" charset="-128"/>
+              </a:rPr>
+              <a:t>『</a:t>
+            </a:r>
+            <a:r>
+              <a:rPr kumimoji="1" lang="ja-JP" altLang="en-US" sz="800">
+                <a:latin typeface="Meiryo" panose="020B0604030504040204" pitchFamily="34" charset="-128"/>
+                <a:ea typeface="Meiryo" panose="020B0604030504040204" pitchFamily="34" charset="-128"/>
+              </a:rPr>
+              <a:t>追加表示</a:t>
+            </a:r>
+            <a:r>
+              <a:rPr kumimoji="1" lang="en-US" altLang="ja-JP" sz="800" dirty="0">
+                <a:latin typeface="Meiryo" panose="020B0604030504040204" pitchFamily="34" charset="-128"/>
+                <a:ea typeface="Meiryo" panose="020B0604030504040204" pitchFamily="34" charset="-128"/>
+              </a:rPr>
+              <a:t>』</a:t>
+            </a:r>
+            <a:r>
+              <a:rPr kumimoji="1" lang="ja-JP" altLang="en-US" sz="800">
+                <a:latin typeface="Meiryo" panose="020B0604030504040204" pitchFamily="34" charset="-128"/>
+                <a:ea typeface="Meiryo" panose="020B0604030504040204" pitchFamily="34" charset="-128"/>
+              </a:rPr>
+              <a:t>ボタンを押すと、月次・年次の領域が出てくる</a:t>
+            </a:r>
+          </a:p>
+        </p:txBody>
+      </p:sp>
+      <p:sp>
+        <p:nvSpPr>
+          <p:cNvPr id="18" name="フレーム 17">
+            <a:extLst>
+              <a:ext uri="{FF2B5EF4-FFF2-40B4-BE49-F238E27FC236}">
+                <a16:creationId xmlns:a16="http://schemas.microsoft.com/office/drawing/2014/main" id="{F30911E3-0B91-373C-E156-4EFD8BF52E59}"/>
+              </a:ext>
+            </a:extLst>
+          </p:cNvPr>
+          <p:cNvSpPr>
+            <a:spLocks/>
+          </p:cNvSpPr>
+          <p:nvPr/>
+        </p:nvSpPr>
+        <p:spPr>
+          <a:xfrm>
+            <a:off x="1070112" y="1667635"/>
+            <a:ext cx="1318591" cy="215348"/>
+          </a:xfrm>
+          <a:prstGeom prst="frame">
+            <a:avLst>
+              <a:gd name="adj1" fmla="val 0"/>
+            </a:avLst>
+          </a:prstGeom>
+          <a:noFill/>
+          <a:ln w="9525">
+            <a:solidFill>
+              <a:srgbClr val="FF0000"/>
+            </a:solidFill>
+            <a:prstDash val="dash"/>
+          </a:ln>
+        </p:spPr>
+        <p:style>
+          <a:lnRef idx="2">
+            <a:schemeClr val="accent1">
+              <a:shade val="15000"/>
+            </a:schemeClr>
+          </a:lnRef>
+          <a:fillRef idx="1">
+            <a:schemeClr val="accent1"/>
+          </a:fillRef>
+          <a:effectRef idx="0">
+            <a:schemeClr val="accent1"/>
+          </a:effectRef>
+          <a:fontRef idx="minor">
+            <a:schemeClr val="lt1"/>
+          </a:fontRef>
+        </p:style>
+        <p:txBody>
+          <a:bodyPr rtlCol="0" anchor="ctr"/>
+          <a:lstStyle/>
+          <a:p>
+            <a:pPr algn="ctr"/>
+            <a:endParaRPr kumimoji="1" lang="ja-JP" altLang="en-US">
+              <a:solidFill>
+                <a:schemeClr val="tx1"/>
+              </a:solidFill>
+            </a:endParaRPr>
+          </a:p>
+        </p:txBody>
+      </p:sp>
+      <p:cxnSp>
+        <p:nvCxnSpPr>
+          <p:cNvPr id="20" name="直線矢印コネクタ 19">
+            <a:extLst>
+              <a:ext uri="{FF2B5EF4-FFF2-40B4-BE49-F238E27FC236}">
+                <a16:creationId xmlns:a16="http://schemas.microsoft.com/office/drawing/2014/main" id="{56C5B5EC-9D32-3FEB-362A-EBD27260CFF1}"/>
+              </a:ext>
+            </a:extLst>
+          </p:cNvPr>
+          <p:cNvCxnSpPr>
+            <a:cxnSpLocks/>
+            <a:stCxn id="25" idx="0"/>
+          </p:cNvCxnSpPr>
+          <p:nvPr/>
+        </p:nvCxnSpPr>
+        <p:spPr>
+          <a:xfrm flipH="1" flipV="1">
+            <a:off x="2259496" y="2085078"/>
+            <a:ext cx="483675" cy="312534"/>
+          </a:xfrm>
+          <a:prstGeom prst="straightConnector1">
+            <a:avLst/>
+          </a:prstGeom>
+          <a:ln w="9525">
+            <a:solidFill>
+              <a:srgbClr val="FF0000"/>
+            </a:solidFill>
+            <a:tailEnd type="triangle"/>
+          </a:ln>
+        </p:spPr>
+        <p:style>
+          <a:lnRef idx="2">
+            <a:schemeClr val="accent1"/>
+          </a:lnRef>
+          <a:fillRef idx="0">
+            <a:schemeClr val="accent1"/>
+          </a:fillRef>
+          <a:effectRef idx="1">
+            <a:schemeClr val="accent1"/>
+          </a:effectRef>
+          <a:fontRef idx="minor">
+            <a:schemeClr val="tx1"/>
+          </a:fontRef>
+        </p:style>
+      </p:cxnSp>
+      <p:sp>
+        <p:nvSpPr>
+          <p:cNvPr id="25" name="テキスト ボックス 24">
+            <a:extLst>
+              <a:ext uri="{FF2B5EF4-FFF2-40B4-BE49-F238E27FC236}">
+                <a16:creationId xmlns:a16="http://schemas.microsoft.com/office/drawing/2014/main" id="{9BDBFE04-B5A9-DDA5-5A2E-60A7B009D1A6}"/>
+              </a:ext>
+            </a:extLst>
+          </p:cNvPr>
+          <p:cNvSpPr txBox="1">
+            <a:spLocks/>
+          </p:cNvSpPr>
+          <p:nvPr/>
+        </p:nvSpPr>
+        <p:spPr>
+          <a:xfrm>
+            <a:off x="2425616" y="2397612"/>
+            <a:ext cx="635110" cy="215444"/>
+          </a:xfrm>
+          <a:prstGeom prst="rect">
+            <a:avLst/>
+          </a:prstGeom>
+          <a:noFill/>
+        </p:spPr>
+        <p:txBody>
+          <a:bodyPr wrap="none" rtlCol="0">
+            <a:spAutoFit/>
+          </a:bodyPr>
+          <a:lstStyle/>
+          <a:p>
+            <a:pPr algn="ctr"/>
+            <a:r>
+              <a:rPr kumimoji="1" lang="en-US" altLang="ja-JP" sz="800" dirty="0">
+                <a:latin typeface="Meiryo" panose="020B0604030504040204" pitchFamily="34" charset="-128"/>
+                <a:ea typeface="Meiryo" panose="020B0604030504040204" pitchFamily="34" charset="-128"/>
+              </a:rPr>
+              <a:t>Daily Bar</a:t>
+            </a:r>
+            <a:endParaRPr kumimoji="1" lang="ja-JP" altLang="en-US" sz="800">
+              <a:latin typeface="Meiryo" panose="020B0604030504040204" pitchFamily="34" charset="-128"/>
+              <a:ea typeface="Meiryo" panose="020B0604030504040204" pitchFamily="34" charset="-128"/>
+            </a:endParaRPr>
+          </a:p>
+        </p:txBody>
+      </p:sp>
+      <p:cxnSp>
+        <p:nvCxnSpPr>
+          <p:cNvPr id="27" name="直線矢印コネクタ 26">
+            <a:extLst>
+              <a:ext uri="{FF2B5EF4-FFF2-40B4-BE49-F238E27FC236}">
+                <a16:creationId xmlns:a16="http://schemas.microsoft.com/office/drawing/2014/main" id="{3CF71132-935E-2186-55FF-FE7CDD910D62}"/>
+              </a:ext>
+            </a:extLst>
+          </p:cNvPr>
+          <p:cNvCxnSpPr>
+            <a:cxnSpLocks/>
+            <a:stCxn id="30" idx="0"/>
+          </p:cNvCxnSpPr>
+          <p:nvPr/>
+        </p:nvCxnSpPr>
+        <p:spPr>
+          <a:xfrm flipV="1">
+            <a:off x="632796" y="1775309"/>
+            <a:ext cx="437316" cy="250592"/>
+          </a:xfrm>
+          <a:prstGeom prst="straightConnector1">
+            <a:avLst/>
+          </a:prstGeom>
+          <a:ln w="9525">
+            <a:solidFill>
+              <a:srgbClr val="FF0000"/>
+            </a:solidFill>
+            <a:tailEnd type="triangle"/>
+          </a:ln>
+        </p:spPr>
+        <p:style>
+          <a:lnRef idx="2">
+            <a:schemeClr val="accent1"/>
+          </a:lnRef>
+          <a:fillRef idx="0">
+            <a:schemeClr val="accent1"/>
+          </a:fillRef>
+          <a:effectRef idx="1">
+            <a:schemeClr val="accent1"/>
+          </a:effectRef>
+          <a:fontRef idx="minor">
+            <a:schemeClr val="tx1"/>
+          </a:fontRef>
+        </p:style>
+      </p:cxnSp>
+      <p:sp>
+        <p:nvSpPr>
+          <p:cNvPr id="30" name="テキスト ボックス 29">
+            <a:extLst>
+              <a:ext uri="{FF2B5EF4-FFF2-40B4-BE49-F238E27FC236}">
+                <a16:creationId xmlns:a16="http://schemas.microsoft.com/office/drawing/2014/main" id="{01186E27-59E2-637B-076E-BF731380BD3D}"/>
+              </a:ext>
+            </a:extLst>
+          </p:cNvPr>
+          <p:cNvSpPr txBox="1">
+            <a:spLocks/>
+          </p:cNvSpPr>
+          <p:nvPr/>
+        </p:nvSpPr>
+        <p:spPr>
+          <a:xfrm>
+            <a:off x="161352" y="2025901"/>
+            <a:ext cx="942887" cy="215444"/>
+          </a:xfrm>
+          <a:prstGeom prst="rect">
+            <a:avLst/>
+          </a:prstGeom>
+          <a:noFill/>
+        </p:spPr>
+        <p:txBody>
+          <a:bodyPr wrap="none" rtlCol="0">
+            <a:spAutoFit/>
+          </a:bodyPr>
+          <a:lstStyle/>
+          <a:p>
+            <a:pPr algn="ctr"/>
+            <a:r>
+              <a:rPr kumimoji="1" lang="ja-JP" altLang="en-US" sz="800">
+                <a:latin typeface="Meiryo" panose="020B0604030504040204" pitchFamily="34" charset="-128"/>
+                <a:ea typeface="Meiryo" panose="020B0604030504040204" pitchFamily="34" charset="-128"/>
+              </a:rPr>
+              <a:t>虫眼鏡</a:t>
+            </a:r>
+            <a:r>
+              <a:rPr kumimoji="1" lang="en-US" altLang="ja-JP" sz="800" dirty="0">
+                <a:latin typeface="Meiryo" panose="020B0604030504040204" pitchFamily="34" charset="-128"/>
+                <a:ea typeface="Meiryo" panose="020B0604030504040204" pitchFamily="34" charset="-128"/>
+              </a:rPr>
+              <a:t>Daily Bar</a:t>
+            </a:r>
+            <a:endParaRPr kumimoji="1" lang="ja-JP" altLang="en-US" sz="800">
+              <a:latin typeface="Meiryo" panose="020B0604030504040204" pitchFamily="34" charset="-128"/>
+              <a:ea typeface="Meiryo" panose="020B0604030504040204" pitchFamily="34" charset="-128"/>
+            </a:endParaRPr>
+          </a:p>
+        </p:txBody>
+      </p:sp>
+      <p:pic>
+        <p:nvPicPr>
+          <p:cNvPr id="33" name="図 32" descr="テーブル&#10;&#10;AI 生成コンテンツは誤りを含む可能性があります。">
+            <a:extLst>
+              <a:ext uri="{FF2B5EF4-FFF2-40B4-BE49-F238E27FC236}">
+                <a16:creationId xmlns:a16="http://schemas.microsoft.com/office/drawing/2014/main" id="{0D7A9C37-F83D-034B-5AA1-EE8991D5BA8E}"/>
+              </a:ext>
+            </a:extLst>
+          </p:cNvPr>
+          <p:cNvPicPr>
+            <a:picLocks noChangeAspect="1"/>
+          </p:cNvPicPr>
+          <p:nvPr/>
+        </p:nvPicPr>
+        <p:blipFill>
+          <a:blip r:embed="rId4"/>
+          <a:stretch>
+            <a:fillRect/>
+          </a:stretch>
+        </p:blipFill>
+        <p:spPr>
+          <a:xfrm>
+            <a:off x="176549" y="4487610"/>
+            <a:ext cx="3169395" cy="2312693"/>
+          </a:xfrm>
+          <a:prstGeom prst="rect">
+            <a:avLst/>
+          </a:prstGeom>
+        </p:spPr>
+      </p:pic>
+      <p:pic>
+        <p:nvPicPr>
+          <p:cNvPr id="35" name="図 34" descr="テーブル&#10;&#10;AI 生成コンテンツは誤りを含む可能性があります。">
+            <a:extLst>
+              <a:ext uri="{FF2B5EF4-FFF2-40B4-BE49-F238E27FC236}">
+                <a16:creationId xmlns:a16="http://schemas.microsoft.com/office/drawing/2014/main" id="{95F8A94D-F7FC-2FE5-6CD3-9F7EDC9AD4C2}"/>
+              </a:ext>
+            </a:extLst>
+          </p:cNvPr>
+          <p:cNvPicPr>
+            <a:picLocks noChangeAspect="1"/>
+          </p:cNvPicPr>
+          <p:nvPr/>
+        </p:nvPicPr>
+        <p:blipFill>
+          <a:blip r:embed="rId5"/>
+          <a:stretch>
+            <a:fillRect/>
+          </a:stretch>
+        </p:blipFill>
+        <p:spPr>
+          <a:xfrm>
+            <a:off x="3526125" y="4512378"/>
+            <a:ext cx="3169393" cy="2297710"/>
+          </a:xfrm>
+          <a:prstGeom prst="rect">
+            <a:avLst/>
+          </a:prstGeom>
+        </p:spPr>
+      </p:pic>
+      <p:sp>
+        <p:nvSpPr>
+          <p:cNvPr id="36" name="テキスト ボックス 35">
+            <a:extLst>
+              <a:ext uri="{FF2B5EF4-FFF2-40B4-BE49-F238E27FC236}">
+                <a16:creationId xmlns:a16="http://schemas.microsoft.com/office/drawing/2014/main" id="{45098D45-BD2A-305C-C319-258926B1B757}"/>
+              </a:ext>
+            </a:extLst>
+          </p:cNvPr>
+          <p:cNvSpPr txBox="1"/>
+          <p:nvPr/>
+        </p:nvSpPr>
+        <p:spPr>
+          <a:xfrm>
+            <a:off x="2801269" y="560389"/>
+            <a:ext cx="1255472" cy="215444"/>
+          </a:xfrm>
+          <a:prstGeom prst="rect">
+            <a:avLst/>
+          </a:prstGeom>
+          <a:noFill/>
+        </p:spPr>
+        <p:txBody>
+          <a:bodyPr wrap="none" rtlCol="0">
+            <a:spAutoFit/>
+          </a:bodyPr>
+          <a:lstStyle/>
+          <a:p>
+            <a:pPr algn="ctr"/>
+            <a:r>
+              <a:rPr kumimoji="1" lang="en-US" altLang="ja-JP" sz="800" dirty="0">
+                <a:latin typeface="Meiryo" panose="020B0604030504040204" pitchFamily="34" charset="-128"/>
+                <a:ea typeface="Meiryo" panose="020B0604030504040204" pitchFamily="34" charset="-128"/>
+              </a:rPr>
+              <a:t>1. </a:t>
+            </a:r>
+            <a:r>
+              <a:rPr kumimoji="1" lang="ja-JP" altLang="en-US" sz="800">
+                <a:latin typeface="Meiryo" panose="020B0604030504040204" pitchFamily="34" charset="-128"/>
+                <a:ea typeface="Meiryo" panose="020B0604030504040204" pitchFamily="34" charset="-128"/>
+              </a:rPr>
+              <a:t>基本画面</a:t>
+            </a:r>
+            <a:r>
+              <a:rPr kumimoji="1" lang="en-US" altLang="ja-JP" sz="800" dirty="0">
+                <a:latin typeface="Meiryo" panose="020B0604030504040204" pitchFamily="34" charset="-128"/>
+                <a:ea typeface="Meiryo" panose="020B0604030504040204" pitchFamily="34" charset="-128"/>
+              </a:rPr>
+              <a:t> : </a:t>
+            </a:r>
+            <a:r>
+              <a:rPr kumimoji="1" lang="ja-JP" altLang="en-US" sz="800">
+                <a:latin typeface="Meiryo" panose="020B0604030504040204" pitchFamily="34" charset="-128"/>
+                <a:ea typeface="Meiryo" panose="020B0604030504040204" pitchFamily="34" charset="-128"/>
+              </a:rPr>
+              <a:t>年次画面</a:t>
+            </a:r>
+          </a:p>
+        </p:txBody>
+      </p:sp>
+      <p:sp>
+        <p:nvSpPr>
+          <p:cNvPr id="37" name="テキスト ボックス 36">
+            <a:extLst>
+              <a:ext uri="{FF2B5EF4-FFF2-40B4-BE49-F238E27FC236}">
+                <a16:creationId xmlns:a16="http://schemas.microsoft.com/office/drawing/2014/main" id="{66B1EB1D-7CAE-C2FF-DB72-CA9138BB615C}"/>
+              </a:ext>
+            </a:extLst>
+          </p:cNvPr>
+          <p:cNvSpPr txBox="1"/>
+          <p:nvPr/>
+        </p:nvSpPr>
+        <p:spPr>
+          <a:xfrm>
+            <a:off x="3067762" y="4286643"/>
+            <a:ext cx="729687" cy="215444"/>
+          </a:xfrm>
+          <a:prstGeom prst="rect">
+            <a:avLst/>
+          </a:prstGeom>
+          <a:noFill/>
+        </p:spPr>
+        <p:txBody>
+          <a:bodyPr wrap="none" rtlCol="0">
+            <a:spAutoFit/>
+          </a:bodyPr>
+          <a:lstStyle/>
+          <a:p>
+            <a:pPr algn="ctr"/>
+            <a:r>
+              <a:rPr kumimoji="1" lang="en-US" altLang="ja-JP" sz="800" dirty="0">
+                <a:latin typeface="Meiryo" panose="020B0604030504040204" pitchFamily="34" charset="-128"/>
+                <a:ea typeface="Meiryo" panose="020B0604030504040204" pitchFamily="34" charset="-128"/>
+              </a:rPr>
+              <a:t>2. </a:t>
+            </a:r>
+            <a:r>
+              <a:rPr kumimoji="1" lang="ja-JP" altLang="en-US" sz="800">
+                <a:latin typeface="Meiryo" panose="020B0604030504040204" pitchFamily="34" charset="-128"/>
+                <a:ea typeface="Meiryo" panose="020B0604030504040204" pitchFamily="34" charset="-128"/>
+              </a:rPr>
+              <a:t>月次画面</a:t>
+            </a:r>
+          </a:p>
+        </p:txBody>
+      </p:sp>
+      <p:pic>
+        <p:nvPicPr>
+          <p:cNvPr id="39" name="図 38" descr="テーブル&#10;&#10;AI 生成コンテンツは誤りを含む可能性があります。">
+            <a:extLst>
+              <a:ext uri="{FF2B5EF4-FFF2-40B4-BE49-F238E27FC236}">
+                <a16:creationId xmlns:a16="http://schemas.microsoft.com/office/drawing/2014/main" id="{C89AD02D-180F-ED23-4170-0B7EE4A63BE5}"/>
+              </a:ext>
+            </a:extLst>
+          </p:cNvPr>
+          <p:cNvPicPr>
+            <a:picLocks noChangeAspect="1"/>
+          </p:cNvPicPr>
+          <p:nvPr/>
+        </p:nvPicPr>
+        <p:blipFill>
+          <a:blip r:embed="rId6"/>
+          <a:stretch>
+            <a:fillRect/>
+          </a:stretch>
+        </p:blipFill>
+        <p:spPr>
+          <a:xfrm>
+            <a:off x="152615" y="7900417"/>
+            <a:ext cx="3173888" cy="2312693"/>
+          </a:xfrm>
+          <a:prstGeom prst="rect">
+            <a:avLst/>
+          </a:prstGeom>
+        </p:spPr>
+      </p:pic>
+      <p:pic>
+        <p:nvPicPr>
+          <p:cNvPr id="41" name="図 40" descr="テーブル&#10;&#10;AI 生成コンテンツは誤りを含む可能性があります。">
+            <a:extLst>
+              <a:ext uri="{FF2B5EF4-FFF2-40B4-BE49-F238E27FC236}">
+                <a16:creationId xmlns:a16="http://schemas.microsoft.com/office/drawing/2014/main" id="{839BE2F1-24E2-4BBB-239E-44705EB9F728}"/>
+              </a:ext>
+            </a:extLst>
+          </p:cNvPr>
+          <p:cNvPicPr>
+            <a:picLocks noChangeAspect="1"/>
+          </p:cNvPicPr>
+          <p:nvPr/>
+        </p:nvPicPr>
+        <p:blipFill>
+          <a:blip r:embed="rId7"/>
+          <a:stretch>
+            <a:fillRect/>
+          </a:stretch>
+        </p:blipFill>
+        <p:spPr>
+          <a:xfrm>
+            <a:off x="3526125" y="7900417"/>
+            <a:ext cx="3168421" cy="2297710"/>
+          </a:xfrm>
+          <a:prstGeom prst="rect">
+            <a:avLst/>
+          </a:prstGeom>
+        </p:spPr>
+      </p:pic>
+      <p:sp>
+        <p:nvSpPr>
+          <p:cNvPr id="42" name="テキスト ボックス 41">
+            <a:extLst>
+              <a:ext uri="{FF2B5EF4-FFF2-40B4-BE49-F238E27FC236}">
+                <a16:creationId xmlns:a16="http://schemas.microsoft.com/office/drawing/2014/main" id="{A3CBFC6E-15A2-9019-D398-7D7B90304619}"/>
+              </a:ext>
+            </a:extLst>
+          </p:cNvPr>
+          <p:cNvSpPr txBox="1"/>
+          <p:nvPr/>
+        </p:nvSpPr>
+        <p:spPr>
+          <a:xfrm>
+            <a:off x="1363217" y="6845364"/>
+            <a:ext cx="1579278" cy="215444"/>
+          </a:xfrm>
+          <a:prstGeom prst="rect">
+            <a:avLst/>
+          </a:prstGeom>
+          <a:noFill/>
+        </p:spPr>
+        <p:txBody>
+          <a:bodyPr wrap="none" rtlCol="0">
+            <a:spAutoFit/>
+          </a:bodyPr>
+          <a:lstStyle/>
+          <a:p>
+            <a:pPr algn="ctr"/>
+            <a:r>
+              <a:rPr kumimoji="1" lang="ja-JP" altLang="en-US" sz="800">
+                <a:latin typeface="Meiryo" panose="020B0604030504040204" pitchFamily="34" charset="-128"/>
+                <a:ea typeface="Meiryo" panose="020B0604030504040204" pitchFamily="34" charset="-128"/>
+              </a:rPr>
+              <a:t>月次表記</a:t>
+            </a:r>
+            <a:r>
+              <a:rPr kumimoji="1" lang="en-US" altLang="ja-JP" sz="800" dirty="0">
+                <a:latin typeface="Meiryo" panose="020B0604030504040204" pitchFamily="34" charset="-128"/>
+                <a:ea typeface="Meiryo" panose="020B0604030504040204" pitchFamily="34" charset="-128"/>
+              </a:rPr>
+              <a:t> </a:t>
+            </a:r>
+            <a:r>
+              <a:rPr kumimoji="1" lang="ja-JP" altLang="en-US" sz="800">
+                <a:latin typeface="Meiryo" panose="020B0604030504040204" pitchFamily="34" charset="-128"/>
+                <a:ea typeface="Meiryo" panose="020B0604030504040204" pitchFamily="34" charset="-128"/>
+              </a:rPr>
+              <a:t>虫眼鏡</a:t>
+            </a:r>
+            <a:r>
+              <a:rPr kumimoji="1" lang="en-US" altLang="ja-JP" sz="800" dirty="0">
+                <a:latin typeface="Meiryo" panose="020B0604030504040204" pitchFamily="34" charset="-128"/>
+                <a:ea typeface="Meiryo" panose="020B0604030504040204" pitchFamily="34" charset="-128"/>
+              </a:rPr>
+              <a:t>daily Bar</a:t>
+            </a:r>
+            <a:r>
+              <a:rPr kumimoji="1" lang="ja-JP" altLang="en-US" sz="800">
+                <a:latin typeface="Meiryo" panose="020B0604030504040204" pitchFamily="34" charset="-128"/>
+                <a:ea typeface="Meiryo" panose="020B0604030504040204" pitchFamily="34" charset="-128"/>
+              </a:rPr>
+              <a:t>左端</a:t>
+            </a:r>
+          </a:p>
+        </p:txBody>
+      </p:sp>
+      <p:sp>
+        <p:nvSpPr>
+          <p:cNvPr id="43" name="テキスト ボックス 42">
+            <a:extLst>
+              <a:ext uri="{FF2B5EF4-FFF2-40B4-BE49-F238E27FC236}">
+                <a16:creationId xmlns:a16="http://schemas.microsoft.com/office/drawing/2014/main" id="{0265AEB9-73CA-8CBB-F1D1-EB9FAB55B50F}"/>
+              </a:ext>
+            </a:extLst>
+          </p:cNvPr>
+          <p:cNvSpPr txBox="1"/>
+          <p:nvPr/>
+        </p:nvSpPr>
+        <p:spPr>
+          <a:xfrm>
+            <a:off x="4111487" y="6845364"/>
+            <a:ext cx="1819729" cy="215444"/>
+          </a:xfrm>
+          <a:prstGeom prst="rect">
+            <a:avLst/>
+          </a:prstGeom>
+          <a:noFill/>
+        </p:spPr>
+        <p:txBody>
+          <a:bodyPr wrap="none" rtlCol="0">
+            <a:spAutoFit/>
+          </a:bodyPr>
+          <a:lstStyle/>
+          <a:p>
+            <a:pPr algn="ctr"/>
+            <a:r>
+              <a:rPr kumimoji="1" lang="ja-JP" altLang="en-US" sz="800">
+                <a:latin typeface="Meiryo" panose="020B0604030504040204" pitchFamily="34" charset="-128"/>
+                <a:ea typeface="Meiryo" panose="020B0604030504040204" pitchFamily="34" charset="-128"/>
+              </a:rPr>
+              <a:t>月次表記</a:t>
+            </a:r>
+            <a:r>
+              <a:rPr kumimoji="1" lang="en-US" altLang="ja-JP" sz="800" dirty="0">
+                <a:latin typeface="Meiryo" panose="020B0604030504040204" pitchFamily="34" charset="-128"/>
+                <a:ea typeface="Meiryo" panose="020B0604030504040204" pitchFamily="34" charset="-128"/>
+              </a:rPr>
+              <a:t> </a:t>
+            </a:r>
+            <a:r>
+              <a:rPr kumimoji="1" lang="ja-JP" altLang="en-US" sz="800">
+                <a:latin typeface="Meiryo" panose="020B0604030504040204" pitchFamily="34" charset="-128"/>
+                <a:ea typeface="Meiryo" panose="020B0604030504040204" pitchFamily="34" charset="-128"/>
+              </a:rPr>
+              <a:t>虫眼鏡</a:t>
+            </a:r>
+            <a:r>
+              <a:rPr kumimoji="1" lang="en-US" altLang="ja-JP" sz="800" dirty="0">
+                <a:latin typeface="Meiryo" panose="020B0604030504040204" pitchFamily="34" charset="-128"/>
+                <a:ea typeface="Meiryo" panose="020B0604030504040204" pitchFamily="34" charset="-128"/>
+              </a:rPr>
+              <a:t>daily Bar </a:t>
+            </a:r>
+            <a:r>
+              <a:rPr kumimoji="1" lang="ja-JP" altLang="en-US" sz="800">
+                <a:latin typeface="Meiryo" panose="020B0604030504040204" pitchFamily="34" charset="-128"/>
+                <a:ea typeface="Meiryo" panose="020B0604030504040204" pitchFamily="34" charset="-128"/>
+              </a:rPr>
+              <a:t>中央より</a:t>
+            </a:r>
+          </a:p>
+        </p:txBody>
+      </p:sp>
+      <p:cxnSp>
+        <p:nvCxnSpPr>
+          <p:cNvPr id="45" name="直線矢印コネクタ 44">
+            <a:extLst>
+              <a:ext uri="{FF2B5EF4-FFF2-40B4-BE49-F238E27FC236}">
+                <a16:creationId xmlns:a16="http://schemas.microsoft.com/office/drawing/2014/main" id="{A8561A8F-BA1D-F53D-86E4-B1157015465E}"/>
+              </a:ext>
+            </a:extLst>
+          </p:cNvPr>
+          <p:cNvCxnSpPr>
+            <a:cxnSpLocks/>
+            <a:stCxn id="48" idx="0"/>
+          </p:cNvCxnSpPr>
+          <p:nvPr/>
+        </p:nvCxnSpPr>
+        <p:spPr>
+          <a:xfrm flipH="1" flipV="1">
+            <a:off x="329642" y="6520375"/>
+            <a:ext cx="836277" cy="511810"/>
+          </a:xfrm>
+          <a:prstGeom prst="straightConnector1">
+            <a:avLst/>
+          </a:prstGeom>
+          <a:ln>
+            <a:solidFill>
+              <a:srgbClr val="FF0000"/>
+            </a:solidFill>
+            <a:tailEnd type="triangle"/>
+          </a:ln>
+        </p:spPr>
+        <p:style>
+          <a:lnRef idx="2">
+            <a:schemeClr val="accent1"/>
+          </a:lnRef>
+          <a:fillRef idx="0">
+            <a:schemeClr val="accent1"/>
+          </a:fillRef>
+          <a:effectRef idx="1">
+            <a:schemeClr val="accent1"/>
+          </a:effectRef>
+          <a:fontRef idx="minor">
+            <a:schemeClr val="tx1"/>
+          </a:fontRef>
+        </p:style>
+      </p:cxnSp>
+      <p:sp>
+        <p:nvSpPr>
+          <p:cNvPr id="48" name="テキスト ボックス 47">
+            <a:extLst>
+              <a:ext uri="{FF2B5EF4-FFF2-40B4-BE49-F238E27FC236}">
+                <a16:creationId xmlns:a16="http://schemas.microsoft.com/office/drawing/2014/main" id="{253B2A1E-946A-EDC6-F774-FD39200A2AB2}"/>
+              </a:ext>
+            </a:extLst>
+          </p:cNvPr>
+          <p:cNvSpPr txBox="1"/>
+          <p:nvPr/>
+        </p:nvSpPr>
+        <p:spPr>
+          <a:xfrm>
+            <a:off x="131020" y="7032185"/>
+            <a:ext cx="2069797" cy="307777"/>
+          </a:xfrm>
+          <a:prstGeom prst="rect">
+            <a:avLst/>
+          </a:prstGeom>
+          <a:noFill/>
+        </p:spPr>
+        <p:txBody>
+          <a:bodyPr wrap="none" rtlCol="0">
+            <a:spAutoFit/>
+          </a:bodyPr>
+          <a:lstStyle/>
+          <a:p>
+            <a:pPr algn="ctr"/>
+            <a:r>
+              <a:rPr kumimoji="1" lang="en-US" altLang="ja-JP" sz="700" dirty="0">
+                <a:latin typeface="Meiryo" panose="020B0604030504040204" pitchFamily="34" charset="-128"/>
+                <a:ea typeface="Meiryo" panose="020B0604030504040204" pitchFamily="34" charset="-128"/>
+              </a:rPr>
+              <a:t>Mac Finder</a:t>
+            </a:r>
+            <a:r>
+              <a:rPr kumimoji="1" lang="ja-JP" altLang="en-US" sz="700">
+                <a:latin typeface="Meiryo" panose="020B0604030504040204" pitchFamily="34" charset="-128"/>
+                <a:ea typeface="Meiryo" panose="020B0604030504040204" pitchFamily="34" charset="-128"/>
+              </a:rPr>
+              <a:t>のギャラリー表記の様な仕様</a:t>
+            </a:r>
+            <a:endParaRPr kumimoji="1" lang="en-US" altLang="ja-JP" sz="700" dirty="0">
+              <a:latin typeface="Meiryo" panose="020B0604030504040204" pitchFamily="34" charset="-128"/>
+              <a:ea typeface="Meiryo" panose="020B0604030504040204" pitchFamily="34" charset="-128"/>
+            </a:endParaRPr>
+          </a:p>
+          <a:p>
+            <a:pPr algn="ctr"/>
+            <a:r>
+              <a:rPr kumimoji="1" lang="ja-JP" altLang="en-US" sz="700">
+                <a:latin typeface="Meiryo" panose="020B0604030504040204" pitchFamily="34" charset="-128"/>
+                <a:ea typeface="Meiryo" panose="020B0604030504040204" pitchFamily="34" charset="-128"/>
+              </a:rPr>
+              <a:t>前月、前々月、翌月、翌々月のシートが見える</a:t>
+            </a:r>
+          </a:p>
+        </p:txBody>
+      </p:sp>
+      <p:cxnSp>
+        <p:nvCxnSpPr>
+          <p:cNvPr id="51" name="直線矢印コネクタ 50">
+            <a:extLst>
+              <a:ext uri="{FF2B5EF4-FFF2-40B4-BE49-F238E27FC236}">
+                <a16:creationId xmlns:a16="http://schemas.microsoft.com/office/drawing/2014/main" id="{279D22DC-450E-1121-5110-11AB8EC1A85A}"/>
+              </a:ext>
+            </a:extLst>
+          </p:cNvPr>
+          <p:cNvCxnSpPr>
+            <a:cxnSpLocks/>
+            <a:stCxn id="48" idx="3"/>
+          </p:cNvCxnSpPr>
+          <p:nvPr/>
+        </p:nvCxnSpPr>
+        <p:spPr>
+          <a:xfrm flipV="1">
+            <a:off x="2200817" y="6421902"/>
+            <a:ext cx="1442715" cy="764172"/>
+          </a:xfrm>
+          <a:prstGeom prst="straightConnector1">
+            <a:avLst/>
+          </a:prstGeom>
+          <a:ln>
+            <a:solidFill>
+              <a:srgbClr val="FF0000"/>
+            </a:solidFill>
+            <a:tailEnd type="triangle"/>
+          </a:ln>
+        </p:spPr>
+        <p:style>
+          <a:lnRef idx="2">
+            <a:schemeClr val="accent1"/>
+          </a:lnRef>
+          <a:fillRef idx="0">
+            <a:schemeClr val="accent1"/>
+          </a:fillRef>
+          <a:effectRef idx="1">
+            <a:schemeClr val="accent1"/>
+          </a:effectRef>
+          <a:fontRef idx="minor">
+            <a:schemeClr val="tx1"/>
+          </a:fontRef>
+        </p:style>
+      </p:cxnSp>
+      <p:sp>
+        <p:nvSpPr>
+          <p:cNvPr id="54" name="テキスト ボックス 53">
+            <a:extLst>
+              <a:ext uri="{FF2B5EF4-FFF2-40B4-BE49-F238E27FC236}">
+                <a16:creationId xmlns:a16="http://schemas.microsoft.com/office/drawing/2014/main" id="{D99BDEAA-2F0D-C896-756B-B3B9C6B7371A}"/>
+              </a:ext>
+            </a:extLst>
+          </p:cNvPr>
+          <p:cNvSpPr txBox="1"/>
+          <p:nvPr/>
+        </p:nvSpPr>
+        <p:spPr>
+          <a:xfrm>
+            <a:off x="1131418" y="7645384"/>
+            <a:ext cx="934871" cy="215444"/>
+          </a:xfrm>
+          <a:prstGeom prst="rect">
+            <a:avLst/>
+          </a:prstGeom>
+          <a:noFill/>
+        </p:spPr>
+        <p:txBody>
+          <a:bodyPr wrap="none" rtlCol="0">
+            <a:spAutoFit/>
+          </a:bodyPr>
+          <a:lstStyle/>
+          <a:p>
+            <a:pPr algn="ctr"/>
+            <a:r>
+              <a:rPr kumimoji="1" lang="en-US" altLang="ja-JP" sz="800" dirty="0">
+                <a:latin typeface="Meiryo" panose="020B0604030504040204" pitchFamily="34" charset="-128"/>
+                <a:ea typeface="Meiryo" panose="020B0604030504040204" pitchFamily="34" charset="-128"/>
+              </a:rPr>
+              <a:t>3. </a:t>
+            </a:r>
+            <a:r>
+              <a:rPr kumimoji="1" lang="ja-JP" altLang="en-US" sz="800">
+                <a:latin typeface="Meiryo" panose="020B0604030504040204" pitchFamily="34" charset="-128"/>
+                <a:ea typeface="Meiryo" panose="020B0604030504040204" pitchFamily="34" charset="-128"/>
+              </a:rPr>
+              <a:t>基本設定画面</a:t>
+            </a:r>
+          </a:p>
+        </p:txBody>
+      </p:sp>
+      <p:sp>
+        <p:nvSpPr>
+          <p:cNvPr id="55" name="テキスト ボックス 54">
+            <a:extLst>
+              <a:ext uri="{FF2B5EF4-FFF2-40B4-BE49-F238E27FC236}">
+                <a16:creationId xmlns:a16="http://schemas.microsoft.com/office/drawing/2014/main" id="{11D29709-BB10-6332-6942-AA04708747AB}"/>
+              </a:ext>
+            </a:extLst>
+          </p:cNvPr>
+          <p:cNvSpPr txBox="1"/>
+          <p:nvPr/>
+        </p:nvSpPr>
+        <p:spPr>
+          <a:xfrm>
+            <a:off x="4734812" y="7637544"/>
+            <a:ext cx="832279" cy="215444"/>
+          </a:xfrm>
+          <a:prstGeom prst="rect">
+            <a:avLst/>
+          </a:prstGeom>
+          <a:noFill/>
+        </p:spPr>
+        <p:txBody>
+          <a:bodyPr wrap="none" rtlCol="0">
+            <a:spAutoFit/>
+          </a:bodyPr>
+          <a:lstStyle/>
+          <a:p>
+            <a:pPr algn="ctr"/>
+            <a:r>
+              <a:rPr kumimoji="1" lang="en-US" altLang="ja-JP" sz="800" dirty="0">
+                <a:latin typeface="Meiryo" panose="020B0604030504040204" pitchFamily="34" charset="-128"/>
+                <a:ea typeface="Meiryo" panose="020B0604030504040204" pitchFamily="34" charset="-128"/>
+              </a:rPr>
+              <a:t>4. </a:t>
+            </a:r>
+            <a:r>
+              <a:rPr kumimoji="1" lang="ja-JP" altLang="en-US" sz="800">
+                <a:latin typeface="Meiryo" panose="020B0604030504040204" pitchFamily="34" charset="-128"/>
+                <a:ea typeface="Meiryo" panose="020B0604030504040204" pitchFamily="34" charset="-128"/>
+              </a:rPr>
+              <a:t>平均値画面</a:t>
+            </a:r>
+          </a:p>
+        </p:txBody>
+      </p:sp>
+      <p:sp>
+        <p:nvSpPr>
+          <p:cNvPr id="56" name="テキスト ボックス 55">
+            <a:extLst>
+              <a:ext uri="{FF2B5EF4-FFF2-40B4-BE49-F238E27FC236}">
+                <a16:creationId xmlns:a16="http://schemas.microsoft.com/office/drawing/2014/main" id="{67A1D92F-19B9-6A4F-A7A4-1AFE9B1090BB}"/>
+              </a:ext>
+            </a:extLst>
+          </p:cNvPr>
+          <p:cNvSpPr txBox="1"/>
+          <p:nvPr/>
+        </p:nvSpPr>
+        <p:spPr>
+          <a:xfrm>
+            <a:off x="341854" y="10189393"/>
+            <a:ext cx="2775119" cy="2062103"/>
+          </a:xfrm>
+          <a:prstGeom prst="rect">
+            <a:avLst/>
+          </a:prstGeom>
+          <a:noFill/>
+        </p:spPr>
+        <p:txBody>
+          <a:bodyPr wrap="none" rtlCol="0">
+            <a:spAutoFit/>
+          </a:bodyPr>
+          <a:lstStyle/>
+          <a:p>
+            <a:pPr algn="ctr"/>
+            <a:r>
+              <a:rPr kumimoji="1" lang="ja-JP" altLang="en-US" sz="800">
+                <a:latin typeface="Meiryo" panose="020B0604030504040204" pitchFamily="34" charset="-128"/>
+                <a:ea typeface="Meiryo" panose="020B0604030504040204" pitchFamily="34" charset="-128"/>
+              </a:rPr>
+              <a:t>基本設定する画面</a:t>
+            </a:r>
+            <a:endParaRPr kumimoji="1" lang="en-US" altLang="ja-JP" sz="800" dirty="0">
+              <a:latin typeface="Meiryo" panose="020B0604030504040204" pitchFamily="34" charset="-128"/>
+              <a:ea typeface="Meiryo" panose="020B0604030504040204" pitchFamily="34" charset="-128"/>
+            </a:endParaRPr>
+          </a:p>
+          <a:p>
+            <a:pPr algn="ctr"/>
+            <a:r>
+              <a:rPr kumimoji="1" lang="ja-JP" altLang="en-US" sz="800">
+                <a:latin typeface="Meiryo" panose="020B0604030504040204" pitchFamily="34" charset="-128"/>
+                <a:ea typeface="Meiryo" panose="020B0604030504040204" pitchFamily="34" charset="-128"/>
+              </a:rPr>
+              <a:t>前年、今年などの年が選べる</a:t>
+            </a:r>
+            <a:endParaRPr kumimoji="1" lang="en-US" altLang="ja-JP" sz="800" dirty="0">
+              <a:latin typeface="Meiryo" panose="020B0604030504040204" pitchFamily="34" charset="-128"/>
+              <a:ea typeface="Meiryo" panose="020B0604030504040204" pitchFamily="34" charset="-128"/>
+            </a:endParaRPr>
+          </a:p>
+          <a:p>
+            <a:pPr algn="ctr"/>
+            <a:r>
+              <a:rPr kumimoji="1" lang="ja-JP" altLang="en-US" sz="800">
+                <a:latin typeface="Meiryo" panose="020B0604030504040204" pitchFamily="34" charset="-128"/>
+                <a:ea typeface="Meiryo" panose="020B0604030504040204" pitchFamily="34" charset="-128"/>
+              </a:rPr>
+              <a:t>最初は前年を選択し繁閑期設定をする</a:t>
+            </a:r>
+            <a:endParaRPr kumimoji="1" lang="en-US" altLang="ja-JP" sz="800" dirty="0">
+              <a:latin typeface="Meiryo" panose="020B0604030504040204" pitchFamily="34" charset="-128"/>
+              <a:ea typeface="Meiryo" panose="020B0604030504040204" pitchFamily="34" charset="-128"/>
+            </a:endParaRPr>
+          </a:p>
+          <a:p>
+            <a:pPr marL="228600" indent="-228600" algn="ctr">
+              <a:buAutoNum type="arabicPeriod"/>
+            </a:pPr>
+            <a:r>
+              <a:rPr kumimoji="1" lang="ja-JP" altLang="en-US" sz="800">
+                <a:latin typeface="Meiryo" panose="020B0604030504040204" pitchFamily="34" charset="-128"/>
+                <a:ea typeface="Meiryo" panose="020B0604030504040204" pitchFamily="34" charset="-128"/>
+              </a:rPr>
+              <a:t>年次目標金額設定</a:t>
+            </a:r>
+            <a:endParaRPr kumimoji="1" lang="en-US" altLang="ja-JP" sz="800" dirty="0">
+              <a:latin typeface="Meiryo" panose="020B0604030504040204" pitchFamily="34" charset="-128"/>
+              <a:ea typeface="Meiryo" panose="020B0604030504040204" pitchFamily="34" charset="-128"/>
+            </a:endParaRPr>
+          </a:p>
+          <a:p>
+            <a:pPr marL="228600" indent="-228600" algn="ctr">
+              <a:buAutoNum type="arabicPeriod"/>
+            </a:pPr>
+            <a:r>
+              <a:rPr kumimoji="1" lang="ja-JP" altLang="en-US" sz="800">
+                <a:latin typeface="Meiryo" panose="020B0604030504040204" pitchFamily="34" charset="-128"/>
+                <a:ea typeface="Meiryo" panose="020B0604030504040204" pitchFamily="34" charset="-128"/>
+              </a:rPr>
+              <a:t>年次総営業日数設定</a:t>
+            </a:r>
+            <a:endParaRPr kumimoji="1" lang="en-US" altLang="ja-JP" sz="800" dirty="0">
+              <a:latin typeface="Meiryo" panose="020B0604030504040204" pitchFamily="34" charset="-128"/>
+              <a:ea typeface="Meiryo" panose="020B0604030504040204" pitchFamily="34" charset="-128"/>
+            </a:endParaRPr>
+          </a:p>
+          <a:p>
+            <a:pPr marL="228600" indent="-228600" algn="ctr">
+              <a:buAutoNum type="arabicPeriod"/>
+            </a:pPr>
+            <a:r>
+              <a:rPr kumimoji="1" lang="ja-JP" altLang="en-US" sz="800">
+                <a:latin typeface="Meiryo" panose="020B0604030504040204" pitchFamily="34" charset="-128"/>
+                <a:ea typeface="Meiryo" panose="020B0604030504040204" pitchFamily="34" charset="-128"/>
+              </a:rPr>
+              <a:t>繁閑期パーセンテージ算出</a:t>
+            </a:r>
+            <a:endParaRPr kumimoji="1" lang="en-US" altLang="ja-JP" sz="800" dirty="0">
+              <a:latin typeface="Meiryo" panose="020B0604030504040204" pitchFamily="34" charset="-128"/>
+              <a:ea typeface="Meiryo" panose="020B0604030504040204" pitchFamily="34" charset="-128"/>
+            </a:endParaRPr>
+          </a:p>
+          <a:p>
+            <a:pPr marL="228600" indent="-228600" algn="ctr">
+              <a:buAutoNum type="arabicPeriod"/>
+            </a:pPr>
+            <a:r>
+              <a:rPr kumimoji="1" lang="ja-JP" altLang="en-US" sz="800">
+                <a:latin typeface="Meiryo" panose="020B0604030504040204" pitchFamily="34" charset="-128"/>
+                <a:ea typeface="Meiryo" panose="020B0604030504040204" pitchFamily="34" charset="-128"/>
+              </a:rPr>
+              <a:t>各月、各曜日平均売上額＆繁閑パーセンテージ算出</a:t>
+            </a:r>
+            <a:endParaRPr kumimoji="1" lang="en-US" altLang="ja-JP" sz="800" dirty="0">
+              <a:latin typeface="Meiryo" panose="020B0604030504040204" pitchFamily="34" charset="-128"/>
+              <a:ea typeface="Meiryo" panose="020B0604030504040204" pitchFamily="34" charset="-128"/>
+            </a:endParaRPr>
+          </a:p>
+          <a:p>
+            <a:pPr marL="228600" indent="-228600" algn="ctr">
+              <a:buAutoNum type="arabicPeriod"/>
+            </a:pPr>
+            <a:endParaRPr kumimoji="1" lang="en-US" altLang="ja-JP" sz="800" dirty="0">
+              <a:latin typeface="Meiryo" panose="020B0604030504040204" pitchFamily="34" charset="-128"/>
+              <a:ea typeface="Meiryo" panose="020B0604030504040204" pitchFamily="34" charset="-128"/>
+            </a:endParaRPr>
+          </a:p>
+          <a:p>
+            <a:pPr marL="228600" indent="-228600" algn="ctr">
+              <a:buAutoNum type="arabicPeriod"/>
+            </a:pPr>
+            <a:r>
+              <a:rPr kumimoji="1" lang="ja-JP" altLang="en-US" sz="800">
+                <a:latin typeface="Meiryo" panose="020B0604030504040204" pitchFamily="34" charset="-128"/>
+                <a:ea typeface="Meiryo" panose="020B0604030504040204" pitchFamily="34" charset="-128"/>
+              </a:rPr>
+              <a:t>今年の目標金額設定</a:t>
+            </a:r>
+            <a:endParaRPr kumimoji="1" lang="en-US" altLang="ja-JP" sz="800" dirty="0">
+              <a:latin typeface="Meiryo" panose="020B0604030504040204" pitchFamily="34" charset="-128"/>
+              <a:ea typeface="Meiryo" panose="020B0604030504040204" pitchFamily="34" charset="-128"/>
+            </a:endParaRPr>
+          </a:p>
+          <a:p>
+            <a:pPr marL="228600" indent="-228600" algn="ctr">
+              <a:buAutoNum type="arabicPeriod"/>
+            </a:pPr>
+            <a:r>
+              <a:rPr kumimoji="1" lang="ja-JP" altLang="en-US" sz="800">
+                <a:latin typeface="Meiryo" panose="020B0604030504040204" pitchFamily="34" charset="-128"/>
+                <a:ea typeface="Meiryo" panose="020B0604030504040204" pitchFamily="34" charset="-128"/>
+              </a:rPr>
+              <a:t>今年の年次総営業日数設定</a:t>
+            </a:r>
+            <a:endParaRPr kumimoji="1" lang="en-US" altLang="ja-JP" sz="800" dirty="0">
+              <a:latin typeface="Meiryo" panose="020B0604030504040204" pitchFamily="34" charset="-128"/>
+              <a:ea typeface="Meiryo" panose="020B0604030504040204" pitchFamily="34" charset="-128"/>
+            </a:endParaRPr>
+          </a:p>
+          <a:p>
+            <a:pPr marL="228600" indent="-228600" algn="ctr">
+              <a:buAutoNum type="arabicPeriod"/>
+            </a:pPr>
+            <a:r>
+              <a:rPr kumimoji="1" lang="ja-JP" altLang="en-US" sz="800">
+                <a:latin typeface="Meiryo" panose="020B0604030504040204" pitchFamily="34" charset="-128"/>
+                <a:ea typeface="Meiryo" panose="020B0604030504040204" pitchFamily="34" charset="-128"/>
+              </a:rPr>
+              <a:t>月次目標売上額算出</a:t>
+            </a:r>
+            <a:endParaRPr kumimoji="1" lang="en-US" altLang="ja-JP" sz="800" dirty="0">
+              <a:latin typeface="Meiryo" panose="020B0604030504040204" pitchFamily="34" charset="-128"/>
+              <a:ea typeface="Meiryo" panose="020B0604030504040204" pitchFamily="34" charset="-128"/>
+            </a:endParaRPr>
+          </a:p>
+          <a:p>
+            <a:pPr marL="228600" indent="-228600" algn="ctr">
+              <a:buAutoNum type="arabicPeriod"/>
+            </a:pPr>
+            <a:r>
+              <a:rPr kumimoji="1" lang="ja-JP" altLang="en-US" sz="800">
+                <a:latin typeface="Meiryo" panose="020B0604030504040204" pitchFamily="34" charset="-128"/>
+                <a:ea typeface="Meiryo" panose="020B0604030504040204" pitchFamily="34" charset="-128"/>
+              </a:rPr>
+              <a:t>繁閑期パーセンテージ設定</a:t>
+            </a:r>
+            <a:endParaRPr kumimoji="1" lang="en-US" altLang="ja-JP" sz="800" dirty="0">
+              <a:latin typeface="Meiryo" panose="020B0604030504040204" pitchFamily="34" charset="-128"/>
+              <a:ea typeface="Meiryo" panose="020B0604030504040204" pitchFamily="34" charset="-128"/>
+            </a:endParaRPr>
+          </a:p>
+          <a:p>
+            <a:pPr marL="228600" indent="-228600" algn="ctr">
+              <a:buAutoNum type="arabicPeriod"/>
+            </a:pPr>
+            <a:r>
+              <a:rPr kumimoji="1" lang="ja-JP" altLang="en-US" sz="800">
+                <a:latin typeface="Meiryo" panose="020B0604030504040204" pitchFamily="34" charset="-128"/>
+                <a:ea typeface="Meiryo" panose="020B0604030504040204" pitchFamily="34" charset="-128"/>
+              </a:rPr>
+              <a:t>月次リアルヴァージョン目標売上額設定</a:t>
+            </a:r>
+            <a:endParaRPr kumimoji="1" lang="en-US" altLang="ja-JP" sz="800" dirty="0">
+              <a:latin typeface="Meiryo" panose="020B0604030504040204" pitchFamily="34" charset="-128"/>
+              <a:ea typeface="Meiryo" panose="020B0604030504040204" pitchFamily="34" charset="-128"/>
+            </a:endParaRPr>
+          </a:p>
+          <a:p>
+            <a:pPr marL="228600" indent="-228600" algn="ctr">
+              <a:buAutoNum type="arabicPeriod"/>
+            </a:pPr>
+            <a:r>
+              <a:rPr kumimoji="1" lang="ja-JP" altLang="en-US" sz="800">
+                <a:latin typeface="Meiryo" panose="020B0604030504040204" pitchFamily="34" charset="-128"/>
+                <a:ea typeface="Meiryo" panose="020B0604030504040204" pitchFamily="34" charset="-128"/>
+              </a:rPr>
+              <a:t>日次</a:t>
+            </a:r>
+            <a:r>
+              <a:rPr kumimoji="1" lang="en-US" altLang="ja-JP" sz="800" dirty="0">
+                <a:latin typeface="Meiryo" panose="020B0604030504040204" pitchFamily="34" charset="-128"/>
+                <a:ea typeface="Meiryo" panose="020B0604030504040204" pitchFamily="34" charset="-128"/>
+              </a:rPr>
+              <a:t>(</a:t>
+            </a:r>
+            <a:r>
+              <a:rPr kumimoji="1" lang="ja-JP" altLang="en-US" sz="800">
+                <a:latin typeface="Meiryo" panose="020B0604030504040204" pitchFamily="34" charset="-128"/>
+                <a:ea typeface="Meiryo" panose="020B0604030504040204" pitchFamily="34" charset="-128"/>
+              </a:rPr>
+              <a:t>曜日目標売上額設定、曜日平均で算出</a:t>
+            </a:r>
+            <a:endParaRPr kumimoji="1" lang="en-US" altLang="ja-JP" sz="800" dirty="0">
+              <a:latin typeface="Meiryo" panose="020B0604030504040204" pitchFamily="34" charset="-128"/>
+              <a:ea typeface="Meiryo" panose="020B0604030504040204" pitchFamily="34" charset="-128"/>
+            </a:endParaRPr>
+          </a:p>
+          <a:p>
+            <a:pPr algn="ctr"/>
+            <a:r>
+              <a:rPr kumimoji="1" lang="ja-JP" altLang="en-US" sz="800">
+                <a:latin typeface="Meiryo" panose="020B0604030504040204" pitchFamily="34" charset="-128"/>
+                <a:ea typeface="Meiryo" panose="020B0604030504040204" pitchFamily="34" charset="-128"/>
+              </a:rPr>
+              <a:t>上記機能を使うための前年基本設定などの</a:t>
+            </a:r>
+            <a:endParaRPr kumimoji="1" lang="en-US" altLang="ja-JP" sz="800" dirty="0">
+              <a:latin typeface="Meiryo" panose="020B0604030504040204" pitchFamily="34" charset="-128"/>
+              <a:ea typeface="Meiryo" panose="020B0604030504040204" pitchFamily="34" charset="-128"/>
+            </a:endParaRPr>
+          </a:p>
+          <a:p>
+            <a:pPr algn="ctr"/>
+            <a:r>
+              <a:rPr kumimoji="1" lang="ja-JP" altLang="en-US" sz="800">
+                <a:latin typeface="Meiryo" panose="020B0604030504040204" pitchFamily="34" charset="-128"/>
+                <a:ea typeface="Meiryo" panose="020B0604030504040204" pitchFamily="34" charset="-128"/>
+              </a:rPr>
+              <a:t>様々な設定をする画面</a:t>
+            </a:r>
+            <a:endParaRPr kumimoji="1" lang="en-US" altLang="ja-JP" sz="800" dirty="0">
+              <a:latin typeface="Meiryo" panose="020B0604030504040204" pitchFamily="34" charset="-128"/>
+              <a:ea typeface="Meiryo" panose="020B0604030504040204" pitchFamily="34" charset="-128"/>
+            </a:endParaRPr>
+          </a:p>
+        </p:txBody>
+      </p:sp>
+      <p:sp>
+        <p:nvSpPr>
+          <p:cNvPr id="57" name="テキスト ボックス 56">
+            <a:extLst>
+              <a:ext uri="{FF2B5EF4-FFF2-40B4-BE49-F238E27FC236}">
+                <a16:creationId xmlns:a16="http://schemas.microsoft.com/office/drawing/2014/main" id="{D6073C42-F145-67A1-CBD2-CEF31BAAA108}"/>
+              </a:ext>
+            </a:extLst>
+          </p:cNvPr>
+          <p:cNvSpPr txBox="1"/>
+          <p:nvPr/>
+        </p:nvSpPr>
+        <p:spPr>
+          <a:xfrm>
+            <a:off x="4064226" y="10255314"/>
+            <a:ext cx="2092240" cy="1446550"/>
+          </a:xfrm>
+          <a:prstGeom prst="rect">
+            <a:avLst/>
+          </a:prstGeom>
+          <a:noFill/>
+        </p:spPr>
+        <p:txBody>
+          <a:bodyPr wrap="none" rtlCol="0">
+            <a:spAutoFit/>
+          </a:bodyPr>
+          <a:lstStyle/>
+          <a:p>
+            <a:pPr algn="ctr"/>
+            <a:r>
+              <a:rPr kumimoji="1" lang="ja-JP" altLang="en-US" sz="800">
+                <a:latin typeface="Meiryo" panose="020B0604030504040204" pitchFamily="34" charset="-128"/>
+                <a:ea typeface="Meiryo" panose="020B0604030504040204" pitchFamily="34" charset="-128"/>
+              </a:rPr>
+              <a:t>選択した年の</a:t>
+            </a:r>
+            <a:endParaRPr kumimoji="1" lang="en-US" altLang="ja-JP" sz="800" dirty="0">
+              <a:latin typeface="Meiryo" panose="020B0604030504040204" pitchFamily="34" charset="-128"/>
+              <a:ea typeface="Meiryo" panose="020B0604030504040204" pitchFamily="34" charset="-128"/>
+            </a:endParaRPr>
+          </a:p>
+          <a:p>
+            <a:pPr algn="ctr"/>
+            <a:r>
+              <a:rPr kumimoji="1" lang="ja-JP" altLang="en-US" sz="800">
+                <a:latin typeface="Meiryo" panose="020B0604030504040204" pitchFamily="34" charset="-128"/>
+                <a:ea typeface="Meiryo" panose="020B0604030504040204" pitchFamily="34" charset="-128"/>
+              </a:rPr>
+              <a:t>各月、各曜日の平均売上額、</a:t>
+            </a:r>
+            <a:endParaRPr kumimoji="1" lang="en-US" altLang="ja-JP" sz="800" dirty="0">
+              <a:latin typeface="Meiryo" panose="020B0604030504040204" pitchFamily="34" charset="-128"/>
+              <a:ea typeface="Meiryo" panose="020B0604030504040204" pitchFamily="34" charset="-128"/>
+            </a:endParaRPr>
+          </a:p>
+          <a:p>
+            <a:pPr algn="ctr"/>
+            <a:r>
+              <a:rPr kumimoji="1" lang="ja-JP" altLang="en-US" sz="800">
+                <a:latin typeface="Meiryo" panose="020B0604030504040204" pitchFamily="34" charset="-128"/>
+                <a:ea typeface="Meiryo" panose="020B0604030504040204" pitchFamily="34" charset="-128"/>
+              </a:rPr>
+              <a:t>平均目標売上額を表示する画面</a:t>
+            </a:r>
+            <a:endParaRPr kumimoji="1" lang="en-US" altLang="ja-JP" sz="800" dirty="0">
+              <a:latin typeface="Meiryo" panose="020B0604030504040204" pitchFamily="34" charset="-128"/>
+              <a:ea typeface="Meiryo" panose="020B0604030504040204" pitchFamily="34" charset="-128"/>
+            </a:endParaRPr>
+          </a:p>
+          <a:p>
+            <a:pPr algn="ctr"/>
+            <a:r>
+              <a:rPr kumimoji="1" lang="ja-JP" altLang="en-US" sz="800">
+                <a:latin typeface="Meiryo" panose="020B0604030504040204" pitchFamily="34" charset="-128"/>
+                <a:ea typeface="Meiryo" panose="020B0604030504040204" pitchFamily="34" charset="-128"/>
+              </a:rPr>
+              <a:t>各曜日の</a:t>
+            </a:r>
+            <a:r>
+              <a:rPr kumimoji="1" lang="en-US" altLang="ja-JP" sz="800" dirty="0">
+                <a:latin typeface="Meiryo" panose="020B0604030504040204" pitchFamily="34" charset="-128"/>
+                <a:ea typeface="Meiryo" panose="020B0604030504040204" pitchFamily="34" charset="-128"/>
+              </a:rPr>
+              <a:t>Bar</a:t>
+            </a:r>
+            <a:r>
+              <a:rPr kumimoji="1" lang="ja-JP" altLang="en-US" sz="800">
+                <a:latin typeface="Meiryo" panose="020B0604030504040204" pitchFamily="34" charset="-128"/>
+                <a:ea typeface="Meiryo" panose="020B0604030504040204" pitchFamily="34" charset="-128"/>
+              </a:rPr>
+              <a:t>に表記する内容</a:t>
+            </a:r>
+            <a:endParaRPr kumimoji="1" lang="en-US" altLang="ja-JP" sz="800" dirty="0">
+              <a:latin typeface="Meiryo" panose="020B0604030504040204" pitchFamily="34" charset="-128"/>
+              <a:ea typeface="Meiryo" panose="020B0604030504040204" pitchFamily="34" charset="-128"/>
+            </a:endParaRPr>
+          </a:p>
+          <a:p>
+            <a:pPr marL="228600" indent="-228600" algn="ctr">
+              <a:buAutoNum type="arabicPeriod"/>
+            </a:pPr>
+            <a:r>
+              <a:rPr kumimoji="1" lang="ja-JP" altLang="en-US" sz="800">
+                <a:latin typeface="Meiryo" panose="020B0604030504040204" pitchFamily="34" charset="-128"/>
+                <a:ea typeface="Meiryo" panose="020B0604030504040204" pitchFamily="34" charset="-128"/>
+              </a:rPr>
+              <a:t>平均売上額</a:t>
+            </a:r>
+            <a:endParaRPr kumimoji="1" lang="en-US" altLang="ja-JP" sz="800" dirty="0">
+              <a:latin typeface="Meiryo" panose="020B0604030504040204" pitchFamily="34" charset="-128"/>
+              <a:ea typeface="Meiryo" panose="020B0604030504040204" pitchFamily="34" charset="-128"/>
+            </a:endParaRPr>
+          </a:p>
+          <a:p>
+            <a:pPr marL="228600" indent="-228600" algn="ctr">
+              <a:buAutoNum type="arabicPeriod"/>
+            </a:pPr>
+            <a:r>
+              <a:rPr kumimoji="1" lang="ja-JP" altLang="en-US" sz="800">
+                <a:latin typeface="Meiryo" panose="020B0604030504040204" pitchFamily="34" charset="-128"/>
+                <a:ea typeface="Meiryo" panose="020B0604030504040204" pitchFamily="34" charset="-128"/>
+              </a:rPr>
+              <a:t>実績売上額</a:t>
+            </a:r>
+            <a:endParaRPr kumimoji="1" lang="en-US" altLang="ja-JP" sz="800" dirty="0">
+              <a:latin typeface="Meiryo" panose="020B0604030504040204" pitchFamily="34" charset="-128"/>
+              <a:ea typeface="Meiryo" panose="020B0604030504040204" pitchFamily="34" charset="-128"/>
+            </a:endParaRPr>
+          </a:p>
+          <a:p>
+            <a:pPr marL="228600" indent="-228600" algn="ctr">
+              <a:buAutoNum type="arabicPeriod"/>
+            </a:pPr>
+            <a:r>
+              <a:rPr kumimoji="1" lang="ja-JP" altLang="en-US" sz="800">
+                <a:latin typeface="Meiryo" panose="020B0604030504040204" pitchFamily="34" charset="-128"/>
+                <a:ea typeface="Meiryo" panose="020B0604030504040204" pitchFamily="34" charset="-128"/>
+              </a:rPr>
+              <a:t>達成率</a:t>
+            </a:r>
+            <a:endParaRPr kumimoji="1" lang="en-US" altLang="ja-JP" sz="800" dirty="0">
+              <a:latin typeface="Meiryo" panose="020B0604030504040204" pitchFamily="34" charset="-128"/>
+              <a:ea typeface="Meiryo" panose="020B0604030504040204" pitchFamily="34" charset="-128"/>
+            </a:endParaRPr>
+          </a:p>
+          <a:p>
+            <a:pPr marL="228600" indent="-228600" algn="ctr">
+              <a:buAutoNum type="arabicPeriod"/>
+            </a:pPr>
+            <a:r>
+              <a:rPr kumimoji="1" lang="ja-JP" altLang="en-US" sz="800">
+                <a:latin typeface="Meiryo" panose="020B0604030504040204" pitchFamily="34" charset="-128"/>
+                <a:ea typeface="Meiryo" panose="020B0604030504040204" pitchFamily="34" charset="-128"/>
+              </a:rPr>
+              <a:t>ランチ・ディナー・全日平均売上額</a:t>
+            </a:r>
+            <a:endParaRPr kumimoji="1" lang="en-US" altLang="ja-JP" sz="800" dirty="0">
+              <a:latin typeface="Meiryo" panose="020B0604030504040204" pitchFamily="34" charset="-128"/>
+              <a:ea typeface="Meiryo" panose="020B0604030504040204" pitchFamily="34" charset="-128"/>
+            </a:endParaRPr>
+          </a:p>
+          <a:p>
+            <a:pPr marL="228600" indent="-228600" algn="ctr">
+              <a:buAutoNum type="arabicPeriod"/>
+            </a:pPr>
+            <a:r>
+              <a:rPr kumimoji="1" lang="ja-JP" altLang="en-US" sz="800">
+                <a:latin typeface="Meiryo" panose="020B0604030504040204" pitchFamily="34" charset="-128"/>
+                <a:ea typeface="Meiryo" panose="020B0604030504040204" pitchFamily="34" charset="-128"/>
+              </a:rPr>
+              <a:t>ランチ・ディナー ・全日平均客単価</a:t>
+            </a:r>
+            <a:endParaRPr kumimoji="1" lang="en-US" altLang="ja-JP" sz="800" dirty="0">
+              <a:latin typeface="Meiryo" panose="020B0604030504040204" pitchFamily="34" charset="-128"/>
+              <a:ea typeface="Meiryo" panose="020B0604030504040204" pitchFamily="34" charset="-128"/>
+            </a:endParaRPr>
+          </a:p>
+          <a:p>
+            <a:pPr marL="228600" indent="-228600" algn="ctr">
+              <a:buAutoNum type="arabicPeriod"/>
+            </a:pPr>
+            <a:r>
+              <a:rPr kumimoji="1" lang="ja-JP" altLang="en-US" sz="800">
+                <a:latin typeface="Meiryo" panose="020B0604030504040204" pitchFamily="34" charset="-128"/>
+                <a:ea typeface="Meiryo" panose="020B0604030504040204" pitchFamily="34" charset="-128"/>
+              </a:rPr>
+              <a:t>ランチ・ディナー ・全日平均組数</a:t>
+            </a:r>
+            <a:endParaRPr kumimoji="1" lang="en-US" altLang="ja-JP" sz="800" dirty="0">
+              <a:latin typeface="Meiryo" panose="020B0604030504040204" pitchFamily="34" charset="-128"/>
+              <a:ea typeface="Meiryo" panose="020B0604030504040204" pitchFamily="34" charset="-128"/>
+            </a:endParaRPr>
+          </a:p>
+          <a:p>
+            <a:pPr marL="228600" indent="-228600" algn="ctr">
+              <a:buAutoNum type="arabicPeriod"/>
+            </a:pPr>
+            <a:r>
+              <a:rPr kumimoji="1" lang="ja-JP" altLang="en-US" sz="800">
+                <a:latin typeface="Meiryo" panose="020B0604030504040204" pitchFamily="34" charset="-128"/>
+                <a:ea typeface="Meiryo" panose="020B0604030504040204" pitchFamily="34" charset="-128"/>
+              </a:rPr>
+              <a:t>ランチ・ディナー ・全日平均客数</a:t>
+            </a:r>
+            <a:endParaRPr kumimoji="1" lang="en-US" altLang="ja-JP" sz="800" dirty="0">
+              <a:latin typeface="Meiryo" panose="020B0604030504040204" pitchFamily="34" charset="-128"/>
+              <a:ea typeface="Meiryo" panose="020B0604030504040204" pitchFamily="34" charset="-128"/>
+            </a:endParaRPr>
+          </a:p>
+        </p:txBody>
+      </p:sp>
+    </p:spTree>
+    <p:extLst>
+      <p:ext uri="{BB962C8B-B14F-4D97-AF65-F5344CB8AC3E}">
+        <p14:creationId xmlns:p14="http://schemas.microsoft.com/office/powerpoint/2010/main" val="1796460720"/>
       </p:ext>
     </p:extLst>
   </p:cSld>

</xml_diff>